<commit_message>
Day 2 morning accessible: convert 12 OLE equations, alt text for OLE chart, fix 49 PUA chars
The S40 OLE object is an embedded chart rather than an equation, so it gets real alt
text instead of a text conversion. Splices the inline sigma-x-bar into its sentence.

Co-Authored-By: Claude Opus 4.8 <noreply@anthropic.com>
</commit_message>
<xml_diff>
--- a/Day2_GLM/FW536_Day2_Morning_ContinuousDistributions_accessible.pptx
+++ b/Day2_GLM/FW536_Day2_Morning_ContinuousDistributions_accessible.pptx
@@ -7572,10 +7572,8 @@
               <a:defRPr/>
             </a:pPr>
             <a:r>
-              <a:rPr lang="en-US" altLang="en-US" sz="1400">
-                <a:sym typeface="Symbol" charset="2"/>
-              </a:rPr>
-              <a:t></a:t>
+              <a:rPr lang="en-US" altLang="en-US" sz="1400"/>
+              <a:t>μ</a:t>
             </a:r>
           </a:p>
         </p:txBody>
@@ -7739,10 +7737,8 @@
               <a:defRPr/>
             </a:pPr>
             <a:r>
-              <a:rPr lang="en-US" altLang="en-US" sz="1400">
-                <a:sym typeface="Symbol" charset="2"/>
-              </a:rPr>
-              <a:t>-</a:t>
+              <a:rPr lang="en-US" altLang="en-US" sz="1400"/>
+              <a:t>μ-σ</a:t>
             </a:r>
           </a:p>
         </p:txBody>
@@ -7906,10 +7902,8 @@
               <a:defRPr/>
             </a:pPr>
             <a:r>
-              <a:rPr lang="en-US" altLang="en-US" sz="1400">
-                <a:sym typeface="Symbol" charset="2"/>
-              </a:rPr>
-              <a:t>-2</a:t>
+              <a:rPr lang="en-US" altLang="en-US" sz="1400"/>
+              <a:t>μ-2σ</a:t>
             </a:r>
           </a:p>
         </p:txBody>
@@ -8073,10 +8067,8 @@
               <a:defRPr/>
             </a:pPr>
             <a:r>
-              <a:rPr lang="en-US" altLang="en-US" sz="1400">
-                <a:sym typeface="Symbol" charset="2"/>
-              </a:rPr>
-              <a:t>-3</a:t>
+              <a:rPr lang="en-US" altLang="en-US" sz="1400"/>
+              <a:t>μ-3σ</a:t>
             </a:r>
           </a:p>
         </p:txBody>
@@ -8240,10 +8232,8 @@
               <a:defRPr/>
             </a:pPr>
             <a:r>
-              <a:rPr lang="en-US" altLang="en-US" sz="1400">
-                <a:sym typeface="Symbol" charset="2"/>
-              </a:rPr>
-              <a:t>+3</a:t>
+              <a:rPr lang="en-US" altLang="en-US" sz="1400"/>
+              <a:t>μ+3σ</a:t>
             </a:r>
           </a:p>
         </p:txBody>
@@ -8407,10 +8397,8 @@
               <a:defRPr/>
             </a:pPr>
             <a:r>
-              <a:rPr lang="en-US" altLang="en-US" sz="1400">
-                <a:sym typeface="Symbol" charset="2"/>
-              </a:rPr>
-              <a:t>+2</a:t>
+              <a:rPr lang="en-US" altLang="en-US" sz="1400"/>
+              <a:t>μ+2σ</a:t>
             </a:r>
           </a:p>
         </p:txBody>
@@ -8574,10 +8562,8 @@
               <a:defRPr/>
             </a:pPr>
             <a:r>
-              <a:rPr lang="en-US" altLang="en-US" sz="1400">
-                <a:sym typeface="Symbol" charset="2"/>
-              </a:rPr>
-              <a:t>+</a:t>
+              <a:rPr lang="en-US" altLang="en-US" sz="1400"/>
+              <a:t>μ+σ</a:t>
             </a:r>
           </a:p>
         </p:txBody>
@@ -9461,10 +9447,8 @@
               <a:t> is normally distributed with mean </a:t>
             </a:r>
             <a:r>
-              <a:rPr lang="en-US" altLang="en-US" dirty="0">
-                <a:sym typeface="Symbol" charset="2"/>
-              </a:rPr>
-              <a:t> and standard deviation </a:t>
+              <a:rPr lang="en-US" altLang="en-US" dirty="0"/>
+              <a:t>μ and standard deviation σ</a:t>
             </a:r>
           </a:p>
           <a:p>
@@ -9580,206 +9564,104 @@
           </a:p>
         </p:txBody>
       </p:sp>
-      <p:graphicFrame>
-        <p:nvGraphicFramePr>
-          <p:cNvPr id="238595" name="Object 4"/>
-          <p:cNvGraphicFramePr>
-            <a:graphicFrameLocks noGrp="1" noChangeAspect="1"/>
-          </p:cNvGraphicFramePr>
-          <p:nvPr>
-            <p:ph sz="quarter" idx="2"/>
-            <p:extLst>
-              <p:ext uri="{D42A27DB-BD31-4B8C-83A1-F6EECF244321}">
-                <p14:modId xmlns:p14="http://schemas.microsoft.com/office/powerpoint/2010/main" val="1270787266"/>
-              </p:ext>
-            </p:extLst>
-          </p:nvPr>
-        </p:nvGraphicFramePr>
-        <p:xfrm>
-          <a:off x="4752976" y="2058757"/>
-          <a:ext cx="1598613" cy="411162"/>
-        </p:xfrm>
-        <a:graphic>
-          <a:graphicData uri="http://schemas.openxmlformats.org/presentationml/2006/ole">
-            <mc:AlternateContent xmlns:mc="http://schemas.openxmlformats.org/markup-compatibility/2006">
-              <mc:Choice xmlns:v="urn:schemas-microsoft-com:vml" Requires="v">
-                <p:oleObj name="Equation" r:id="rId3" imgW="889000" imgH="228600" progId="Equation.DSMT4">
-                  <p:embed/>
-                </p:oleObj>
-              </mc:Choice>
-              <mc:Fallback>
-                <p:oleObj name="Equation" r:id="rId3" imgW="889000" imgH="228600" progId="Equation.DSMT4">
-                  <p:embed/>
-                  <p:pic>
-                    <p:nvPicPr>
-                      <p:cNvPr id="0" name=""/>
-                      <p:cNvPicPr>
-                        <a:picLocks noChangeAspect="1" noChangeArrowheads="1"/>
-                      </p:cNvPicPr>
-                      <p:nvPr/>
-                    </p:nvPicPr>
-                    <p:blipFill>
-                      <a:blip r:embed="rId4">
-                        <a:extLst>
-                          <a:ext uri="{28A0092B-C50C-407E-A947-70E740481C1C}">
-                            <a14:useLocalDpi xmlns:a14="http://schemas.microsoft.com/office/drawing/2010/main" val="0"/>
-                          </a:ext>
-                        </a:extLst>
-                      </a:blip>
-                      <a:srcRect/>
-                      <a:stretch>
-                        <a:fillRect/>
-                      </a:stretch>
-                    </p:blipFill>
-                    <p:spPr bwMode="auto">
-                      <a:xfrm>
-                        <a:off x="4752976" y="2058757"/>
-                        <a:ext cx="1598613" cy="411162"/>
-                      </a:xfrm>
-                      <a:prstGeom prst="rect">
-                        <a:avLst/>
-                      </a:prstGeom>
-                      <a:noFill/>
-                      <a:ln>
-                        <a:noFill/>
-                      </a:ln>
-                      <a:effectLst/>
-                      <a:extLst>
-                        <a:ext uri="{909E8E84-426E-40DD-AFC4-6F175D3DCCD1}">
-                          <a14:hiddenFill xmlns:a14="http://schemas.microsoft.com/office/drawing/2010/main">
-                            <a:solidFill>
-                              <a:srgbClr val="FFFFFF"/>
-                            </a:solidFill>
-                          </a14:hiddenFill>
-                        </a:ext>
-                        <a:ext uri="{91240B29-F687-4F45-9708-019B960494DF}">
-                          <a14:hiddenLine xmlns:a14="http://schemas.microsoft.com/office/drawing/2010/main" w="9525">
-                            <a:solidFill>
-                              <a:srgbClr val="000000"/>
-                            </a:solidFill>
-                            <a:miter lim="800000"/>
-                            <a:headEnd/>
-                            <a:tailEnd/>
-                          </a14:hiddenLine>
-                        </a:ext>
-                        <a:ext uri="{AF507438-7753-43E0-B8FC-AC1667EBCBE1}">
-                          <a14:hiddenEffects xmlns:a14="http://schemas.microsoft.com/office/drawing/2010/main">
-                            <a:effectLst>
-                              <a:outerShdw dist="35921" dir="2700000" algn="ctr" rotWithShape="0">
-                                <a:srgbClr val="808080"/>
-                              </a:outerShdw>
-                            </a:effectLst>
-                          </a14:hiddenEffects>
-                        </a:ext>
-                      </a:extLst>
-                    </p:spPr>
-                  </p:pic>
-                </p:oleObj>
-              </mc:Fallback>
-            </mc:AlternateContent>
-          </a:graphicData>
-        </a:graphic>
-      </p:graphicFrame>
-      <p:graphicFrame>
-        <p:nvGraphicFramePr>
-          <p:cNvPr id="238596" name="Object 6"/>
-          <p:cNvGraphicFramePr>
-            <a:graphicFrameLocks noGrp="1" noChangeAspect="1"/>
-          </p:cNvGraphicFramePr>
-          <p:nvPr>
-            <p:ph sz="quarter" idx="3"/>
-            <p:extLst>
-              <p:ext uri="{D42A27DB-BD31-4B8C-83A1-F6EECF244321}">
-                <p14:modId xmlns:p14="http://schemas.microsoft.com/office/powerpoint/2010/main" val="1586770807"/>
-              </p:ext>
-            </p:extLst>
-          </p:nvPr>
-        </p:nvGraphicFramePr>
-        <p:xfrm>
-          <a:off x="4738766" y="4245847"/>
-          <a:ext cx="2687637" cy="995362"/>
-        </p:xfrm>
-        <a:graphic>
-          <a:graphicData uri="http://schemas.openxmlformats.org/presentationml/2006/ole">
-            <mc:AlternateContent xmlns:mc="http://schemas.openxmlformats.org/markup-compatibility/2006">
-              <mc:Choice xmlns:v="urn:schemas-microsoft-com:vml" Requires="v">
-                <p:oleObj name="Equation" r:id="rId5" imgW="1371600" imgH="508000" progId="Equation.DSMT4">
-                  <p:embed/>
-                </p:oleObj>
-              </mc:Choice>
-              <mc:Fallback>
-                <p:oleObj name="Equation" r:id="rId5" imgW="1371600" imgH="508000" progId="Equation.DSMT4">
-                  <p:embed/>
-                  <p:pic>
-                    <p:nvPicPr>
-                      <p:cNvPr id="0" name=""/>
-                      <p:cNvPicPr>
-                        <a:picLocks noChangeAspect="1" noChangeArrowheads="1"/>
-                      </p:cNvPicPr>
-                      <p:nvPr/>
-                    </p:nvPicPr>
-                    <p:blipFill>
-                      <a:blip r:embed="rId6">
-                        <a:extLst>
-                          <a:ext uri="{28A0092B-C50C-407E-A947-70E740481C1C}">
-                            <a14:useLocalDpi xmlns:a14="http://schemas.microsoft.com/office/drawing/2010/main" val="0"/>
-                          </a:ext>
-                        </a:extLst>
-                      </a:blip>
-                      <a:srcRect/>
-                      <a:stretch>
-                        <a:fillRect/>
-                      </a:stretch>
-                    </p:blipFill>
-                    <p:spPr bwMode="auto">
-                      <a:xfrm>
-                        <a:off x="4738766" y="4245847"/>
-                        <a:ext cx="2687637" cy="995362"/>
-                      </a:xfrm>
-                      <a:prstGeom prst="rect">
-                        <a:avLst/>
-                      </a:prstGeom>
-                      <a:noFill/>
-                      <a:ln>
-                        <a:noFill/>
-                      </a:ln>
-                      <a:effectLst/>
-                      <a:extLst>
-                        <a:ext uri="{909E8E84-426E-40DD-AFC4-6F175D3DCCD1}">
-                          <a14:hiddenFill xmlns:a14="http://schemas.microsoft.com/office/drawing/2010/main">
-                            <a:solidFill>
-                              <a:srgbClr val="FFFFFF"/>
-                            </a:solidFill>
-                          </a14:hiddenFill>
-                        </a:ext>
-                        <a:ext uri="{91240B29-F687-4F45-9708-019B960494DF}">
-                          <a14:hiddenLine xmlns:a14="http://schemas.microsoft.com/office/drawing/2010/main" w="9525">
-                            <a:solidFill>
-                              <a:srgbClr val="000000"/>
-                            </a:solidFill>
-                            <a:miter lim="800000"/>
-                            <a:headEnd/>
-                            <a:tailEnd/>
-                          </a14:hiddenLine>
-                        </a:ext>
-                        <a:ext uri="{AF507438-7753-43E0-B8FC-AC1667EBCBE1}">
-                          <a14:hiddenEffects xmlns:a14="http://schemas.microsoft.com/office/drawing/2010/main">
-                            <a:effectLst>
-                              <a:outerShdw dist="35921" dir="2700000" algn="ctr" rotWithShape="0">
-                                <a:srgbClr val="808080"/>
-                              </a:outerShdw>
-                            </a:effectLst>
-                          </a14:hiddenEffects>
-                        </a:ext>
-                      </a:extLst>
-                    </p:spPr>
-                  </p:pic>
-                </p:oleObj>
-              </mc:Fallback>
-            </mc:AlternateContent>
-          </a:graphicData>
-        </a:graphic>
-      </p:graphicFrame>
+      <p:sp>
+        <p:nvSpPr>
+          <p:cNvPr id="238597" name="TextBox 238596"/>
+          <p:cNvSpPr txBox="1"/>
+          <p:nvPr/>
+        </p:nvSpPr>
+        <p:spPr>
+          <a:xfrm>
+            <a:off x="4752976" y="2058757"/>
+            <a:ext cx="1688123" cy="411162"/>
+          </a:xfrm>
+          <a:prstGeom prst="rect">
+            <a:avLst/>
+          </a:prstGeom>
+          <a:noFill/>
+        </p:spPr>
+        <p:txBody>
+          <a:bodyPr wrap="square" anchor="ctr" lIns="0" rIns="0" tIns="0" bIns="0">
+            <a:spAutoFit/>
+          </a:bodyPr>
+          <a:lstStyle/>
+          <a:p>
+            <a:r>
+              <a:rPr sz="1900">
+                <a:latin typeface="Cambria"/>
+              </a:rPr>
+              <a:t>X ~ N(μ, σ</a:t>
+            </a:r>
+            <a:r>
+              <a:rPr sz="1900" baseline="30000">
+                <a:latin typeface="Cambria"/>
+              </a:rPr>
+              <a:t>2</a:t>
+            </a:r>
+            <a:r>
+              <a:rPr sz="1900">
+                <a:latin typeface="Cambria"/>
+              </a:rPr>
+              <a:t>)</a:t>
+            </a:r>
+          </a:p>
+        </p:txBody>
+      </p:sp>
+      <p:sp>
+        <p:nvSpPr>
+          <p:cNvPr id="238598" name="TextBox 238597"/>
+          <p:cNvSpPr txBox="1"/>
+          <p:nvPr/>
+        </p:nvSpPr>
+        <p:spPr>
+          <a:xfrm>
+            <a:off x="4738766" y="4245847"/>
+            <a:ext cx="6611815" cy="995362"/>
+          </a:xfrm>
+          <a:prstGeom prst="rect">
+            <a:avLst/>
+          </a:prstGeom>
+          <a:noFill/>
+        </p:spPr>
+        <p:txBody>
+          <a:bodyPr wrap="square" anchor="ctr" lIns="0" rIns="0" tIns="0" bIns="0">
+            <a:spAutoFit/>
+          </a:bodyPr>
+          <a:lstStyle/>
+          <a:p>
+            <a:r>
+              <a:rPr sz="1900">
+                <a:latin typeface="Cambria"/>
+              </a:rPr>
+              <a:t>f(x) = 1 / (√(2π) σ) · exp( −(x − μ)</a:t>
+            </a:r>
+            <a:r>
+              <a:rPr sz="1900" baseline="30000">
+                <a:latin typeface="Cambria"/>
+              </a:rPr>
+              <a:t>2</a:t>
+            </a:r>
+            <a:r>
+              <a:rPr sz="1900">
+                <a:latin typeface="Cambria"/>
+              </a:rPr>
+              <a:t> / (2σ</a:t>
+            </a:r>
+            <a:r>
+              <a:rPr sz="1900" baseline="30000">
+                <a:latin typeface="Cambria"/>
+              </a:rPr>
+              <a:t>2</a:t>
+            </a:r>
+            <a:r>
+              <a:rPr sz="1900">
+                <a:latin typeface="Cambria"/>
+              </a:rPr>
+              <a:t>) )</a:t>
+            </a:r>
+          </a:p>
+        </p:txBody>
+      </p:sp>
     </p:spTree>
     <p:extLst>
       <p:ext uri="{BB962C8B-B14F-4D97-AF65-F5344CB8AC3E}">
@@ -9997,10 +9879,8 @@
               <a:t> </a:t>
             </a:r>
             <a:r>
-              <a:rPr lang="en-US" altLang="en-US" dirty="0">
-                <a:sym typeface="Symbol" charset="2"/>
-              </a:rPr>
-              <a:t>X  x]</a:t>
+              <a:rPr lang="en-US" altLang="en-US" dirty="0"/>
+              <a:t>X ≤ x]</a:t>
             </a:r>
           </a:p>
         </p:txBody>
@@ -10158,10 +10038,8 @@
               <a:t> </a:t>
             </a:r>
             <a:r>
-              <a:rPr lang="en-US" altLang="en-US" dirty="0">
-                <a:sym typeface="Symbol" charset="2"/>
-              </a:rPr>
-              <a:t>X  x]</a:t>
+              <a:rPr lang="en-US" altLang="en-US" dirty="0"/>
+              <a:t>X ≤ x]</a:t>
             </a:r>
           </a:p>
           <a:p>
@@ -11904,10 +11782,8 @@
               <a:t> 68% lies between </a:t>
             </a:r>
             <a:r>
-              <a:rPr lang="en-US" altLang="en-US" sz="2000" dirty="0">
-                <a:sym typeface="Symbol" charset="2"/>
-              </a:rPr>
-              <a:t>- and +</a:t>
+              <a:rPr lang="en-US" altLang="en-US" sz="2000" dirty="0"/>
+              <a:t>μ-σ and μ+σ</a:t>
             </a:r>
             <a:r>
               <a:rPr lang="en-US" altLang="en-US" sz="2000" dirty="0"/>
@@ -11923,10 +11799,8 @@
               <a:t> 95% lies between </a:t>
             </a:r>
             <a:r>
-              <a:rPr lang="en-US" altLang="en-US" sz="2000" dirty="0">
-                <a:sym typeface="Symbol" charset="2"/>
-              </a:rPr>
-              <a:t>-2 and +2</a:t>
+              <a:rPr lang="en-US" altLang="en-US" sz="2000" dirty="0"/>
+              <a:t>μ-2σ and μ+2σ</a:t>
             </a:r>
           </a:p>
           <a:p>
@@ -11944,10 +11818,8 @@
               <a:t>lies between </a:t>
             </a:r>
             <a:r>
-              <a:rPr lang="en-US" altLang="en-US" sz="2000" dirty="0">
-                <a:sym typeface="Symbol" charset="2"/>
-              </a:rPr>
-              <a:t>-3 and +3</a:t>
+              <a:rPr lang="en-US" altLang="en-US" sz="2000" dirty="0"/>
+              <a:t>μ-3σ and μ+3σ</a:t>
             </a:r>
             <a:endParaRPr lang="en-US" altLang="en-US" sz="2000" dirty="0"/>
           </a:p>
@@ -13472,101 +13344,6 @@
           </a:p>
         </p:txBody>
       </p:sp>
-      <p:graphicFrame>
-        <p:nvGraphicFramePr>
-          <p:cNvPr id="250884" name="Object 5"/>
-          <p:cNvGraphicFramePr>
-            <a:graphicFrameLocks noGrp="1" noChangeAspect="1"/>
-          </p:cNvGraphicFramePr>
-          <p:nvPr>
-            <p:ph sz="half" idx="2"/>
-          </p:nvPr>
-        </p:nvGraphicFramePr>
-        <p:xfrm>
-          <a:off x="3594100" y="3497263"/>
-          <a:ext cx="4724400" cy="1077912"/>
-        </p:xfrm>
-        <a:graphic>
-          <a:graphicData uri="http://schemas.openxmlformats.org/presentationml/2006/ole">
-            <mc:AlternateContent xmlns:mc="http://schemas.openxmlformats.org/markup-compatibility/2006">
-              <mc:Choice xmlns:v="urn:schemas-microsoft-com:vml" Requires="v">
-                <p:oleObj name="Equation" r:id="rId3" imgW="1892300" imgH="431800" progId="Equation.DSMT4">
-                  <p:embed/>
-                </p:oleObj>
-              </mc:Choice>
-              <mc:Fallback>
-                <p:oleObj name="Equation" r:id="rId3" imgW="1892300" imgH="431800" progId="Equation.DSMT4">
-                  <p:embed/>
-                  <p:pic>
-                    <p:nvPicPr>
-                      <p:cNvPr id="0" name=""/>
-                      <p:cNvPicPr>
-                        <a:picLocks noChangeAspect="1" noChangeArrowheads="1"/>
-                      </p:cNvPicPr>
-                      <p:nvPr/>
-                    </p:nvPicPr>
-                    <p:blipFill>
-                      <a:blip r:embed="rId4">
-                        <a:extLst>
-                          <a:ext uri="{28A0092B-C50C-407E-A947-70E740481C1C}">
-                            <a14:useLocalDpi xmlns:a14="http://schemas.microsoft.com/office/drawing/2010/main" val="0"/>
-                          </a:ext>
-                        </a:extLst>
-                      </a:blip>
-                      <a:srcRect/>
-                      <a:stretch>
-                        <a:fillRect/>
-                      </a:stretch>
-                    </p:blipFill>
-                    <p:spPr bwMode="auto">
-                      <a:xfrm>
-                        <a:off x="3594100" y="3497263"/>
-                        <a:ext cx="4724400" cy="1077912"/>
-                      </a:xfrm>
-                      <a:prstGeom prst="rect">
-                        <a:avLst/>
-                      </a:prstGeom>
-                      <a:noFill/>
-                      <a:ln>
-                        <a:noFill/>
-                      </a:ln>
-                      <a:effectLst/>
-                      <a:extLst>
-                        <a:ext uri="{909E8E84-426E-40DD-AFC4-6F175D3DCCD1}">
-                          <a14:hiddenFill xmlns:a14="http://schemas.microsoft.com/office/drawing/2010/main">
-                            <a:solidFill>
-                              <a:srgbClr val="FFFFFF"/>
-                            </a:solidFill>
-                          </a14:hiddenFill>
-                        </a:ext>
-                        <a:ext uri="{91240B29-F687-4F45-9708-019B960494DF}">
-                          <a14:hiddenLine xmlns:a14="http://schemas.microsoft.com/office/drawing/2010/main" w="9525">
-                            <a:solidFill>
-                              <a:srgbClr val="000000"/>
-                            </a:solidFill>
-                            <a:miter lim="800000"/>
-                            <a:headEnd/>
-                            <a:tailEnd/>
-                          </a14:hiddenLine>
-                        </a:ext>
-                        <a:ext uri="{AF507438-7753-43E0-B8FC-AC1667EBCBE1}">
-                          <a14:hiddenEffects xmlns:a14="http://schemas.microsoft.com/office/drawing/2010/main">
-                            <a:effectLst>
-                              <a:outerShdw dist="35921" dir="2700000" algn="ctr" rotWithShape="0">
-                                <a:srgbClr val="808080"/>
-                              </a:outerShdw>
-                            </a:effectLst>
-                          </a14:hiddenEffects>
-                        </a:ext>
-                      </a:extLst>
-                    </p:spPr>
-                  </p:pic>
-                </p:oleObj>
-              </mc:Fallback>
-            </mc:AlternateContent>
-          </a:graphicData>
-        </a:graphic>
-      </p:graphicFrame>
       <p:sp>
         <p:nvSpPr>
           <p:cNvPr id="250885" name="TextBox 1"/>
@@ -13820,10 +13597,8 @@
               <a:t> = </a:t>
             </a:r>
             <a:r>
-              <a:rPr lang="en-US" altLang="en-US" sz="2400" dirty="0">
-                <a:sym typeface="Symbol" charset="2"/>
-              </a:rPr>
-              <a:t> + </a:t>
+              <a:rPr lang="en-US" altLang="en-US" sz="2400" dirty="0"/>
+              <a:t>μ + σ</a:t>
             </a:r>
             <a:r>
               <a:rPr lang="en-US" altLang="en-US" sz="2400" i="1" dirty="0">
@@ -13832,6 +13607,37 @@
               <a:t>z</a:t>
             </a:r>
             <a:endParaRPr lang="en-US" altLang="en-US" sz="2400" i="1" dirty="0"/>
+          </a:p>
+        </p:txBody>
+      </p:sp>
+      <p:sp>
+        <p:nvSpPr>
+          <p:cNvPr id="250886" name="TextBox 250885"/>
+          <p:cNvSpPr txBox="1"/>
+          <p:nvPr/>
+        </p:nvSpPr>
+        <p:spPr>
+          <a:xfrm>
+            <a:off x="3594100" y="3497263"/>
+            <a:ext cx="7737230" cy="1077912"/>
+          </a:xfrm>
+          <a:prstGeom prst="rect">
+            <a:avLst/>
+          </a:prstGeom>
+          <a:noFill/>
+        </p:spPr>
+        <p:txBody>
+          <a:bodyPr wrap="square" anchor="ctr" lIns="0" rIns="0" tIns="0" bIns="0">
+            <a:spAutoFit/>
+          </a:bodyPr>
+          <a:lstStyle/>
+          <a:p>
+            <a:r>
+              <a:rPr sz="1900">
+                <a:latin typeface="Cambria"/>
+              </a:rPr>
+              <a:t>z = (value − mean) / (standard deviation) = (x − μ) / σ</a:t>
+            </a:r>
           </a:p>
         </p:txBody>
       </p:sp>
@@ -13950,10 +13756,8 @@
               <a:t> </a:t>
             </a:r>
             <a:r>
-              <a:rPr lang="en-US" altLang="en-US" dirty="0">
-                <a:sym typeface="Symbol" charset="2"/>
-              </a:rPr>
-              <a:t> </a:t>
+              <a:rPr lang="en-US" altLang="en-US" dirty="0"/>
+              <a:t>≤ </a:t>
             </a:r>
             <a:r>
               <a:rPr lang="en-US" altLang="en-US" dirty="0"/>
@@ -13973,10 +13777,8 @@
               <a:t>  </a:t>
             </a:r>
             <a:r>
-              <a:rPr lang="en-US" altLang="en-US" dirty="0">
-                <a:sym typeface="Symbol" charset="2"/>
-              </a:rPr>
-              <a:t></a:t>
+              <a:rPr lang="en-US" altLang="en-US" dirty="0"/>
+              <a:t>≥</a:t>
             </a:r>
             <a:r>
               <a:rPr lang="en-US" altLang="en-US" dirty="0"/>
@@ -13992,10 +13794,8 @@
               <a:t>0.1 </a:t>
             </a:r>
             <a:r>
-              <a:rPr lang="en-US" altLang="en-US" dirty="0">
-                <a:sym typeface="Symbol" charset="2"/>
-              </a:rPr>
-              <a:t></a:t>
+              <a:rPr lang="en-US" altLang="en-US" dirty="0"/>
+              <a:t>≤</a:t>
             </a:r>
             <a:r>
               <a:rPr lang="en-US" altLang="en-US" dirty="0"/>
@@ -14010,10 +13810,8 @@
               <a:t> </a:t>
             </a:r>
             <a:r>
-              <a:rPr lang="en-US" altLang="en-US" dirty="0">
-                <a:sym typeface="Symbol" charset="2"/>
-              </a:rPr>
-              <a:t> 0.5 OR 1.5  </a:t>
+              <a:rPr lang="en-US" altLang="en-US" dirty="0"/>
+              <a:t>≤ 0.5 OR 1.5 ≤ </a:t>
             </a:r>
             <a:r>
               <a:rPr lang="en-US" altLang="en-US" i="1" dirty="0">
@@ -14022,10 +13820,8 @@
               <a:t>X </a:t>
             </a:r>
             <a:r>
-              <a:rPr lang="en-US" altLang="en-US" dirty="0">
-                <a:sym typeface="Symbol" charset="2"/>
-              </a:rPr>
-              <a:t> 2</a:t>
+              <a:rPr lang="en-US" altLang="en-US" dirty="0"/>
+              <a:t>≤ 2</a:t>
             </a:r>
           </a:p>
           <a:p>
@@ -16185,7 +15981,23 @@
             </a:pPr>
             <a:r>
               <a:rPr lang="en-US" altLang="en-US" dirty="0"/>
-              <a:t>      is often called the </a:t>
+              <a:t/>
+            </a:r>
+            <a:r>
+              <a:rPr lang="en-US" altLang="en-US" dirty="0">
+                <a:latin typeface="Cambria"/>
+              </a:rPr>
+              <a:t>σ</a:t>
+            </a:r>
+            <a:r>
+              <a:rPr lang="en-US" altLang="en-US" dirty="0" baseline="-25000">
+                <a:latin typeface="Cambria"/>
+              </a:rPr>
+              <a:t>x̄</a:t>
+            </a:r>
+            <a:r>
+              <a:rPr lang="en-US" altLang="en-US" dirty="0"/>
+              <a:t> is often called the </a:t>
             </a:r>
             <a:r>
               <a:rPr lang="en-US" altLang="en-US" b="1" dirty="0">
@@ -16203,307 +16015,92 @@
           </a:p>
         </p:txBody>
       </p:sp>
-      <p:graphicFrame>
-        <p:nvGraphicFramePr>
-          <p:cNvPr id="263171" name="Object 5"/>
-          <p:cNvGraphicFramePr>
-            <a:graphicFrameLocks noGrp="1" noChangeAspect="1"/>
-          </p:cNvGraphicFramePr>
-          <p:nvPr>
-            <p:ph sz="quarter" idx="2"/>
-            <p:extLst>
-              <p:ext uri="{D42A27DB-BD31-4B8C-83A1-F6EECF244321}">
-                <p14:modId xmlns:p14="http://schemas.microsoft.com/office/powerpoint/2010/main" val="245028359"/>
-              </p:ext>
-            </p:extLst>
-          </p:nvPr>
-        </p:nvGraphicFramePr>
-        <p:xfrm>
-          <a:off x="5402264" y="2347338"/>
-          <a:ext cx="941387" cy="457200"/>
-        </p:xfrm>
-        <a:graphic>
-          <a:graphicData uri="http://schemas.openxmlformats.org/presentationml/2006/ole">
-            <mc:AlternateContent xmlns:mc="http://schemas.openxmlformats.org/markup-compatibility/2006">
-              <mc:Choice xmlns:v="urn:schemas-microsoft-com:vml" Requires="v">
-                <p:oleObj name="Equation" r:id="rId3" imgW="469900" imgH="228600" progId="Equation.DSMT4">
-                  <p:embed/>
-                </p:oleObj>
-              </mc:Choice>
-              <mc:Fallback>
-                <p:oleObj name="Equation" r:id="rId3" imgW="469900" imgH="228600" progId="Equation.DSMT4">
-                  <p:embed/>
-                  <p:pic>
-                    <p:nvPicPr>
-                      <p:cNvPr id="0" name=""/>
-                      <p:cNvPicPr>
-                        <a:picLocks noChangeAspect="1" noChangeArrowheads="1"/>
-                      </p:cNvPicPr>
-                      <p:nvPr/>
-                    </p:nvPicPr>
-                    <p:blipFill>
-                      <a:blip r:embed="rId4">
-                        <a:extLst>
-                          <a:ext uri="{28A0092B-C50C-407E-A947-70E740481C1C}">
-                            <a14:useLocalDpi xmlns:a14="http://schemas.microsoft.com/office/drawing/2010/main" val="0"/>
-                          </a:ext>
-                        </a:extLst>
-                      </a:blip>
-                      <a:srcRect/>
-                      <a:stretch>
-                        <a:fillRect/>
-                      </a:stretch>
-                    </p:blipFill>
-                    <p:spPr bwMode="auto">
-                      <a:xfrm>
-                        <a:off x="5402264" y="2347338"/>
-                        <a:ext cx="941387" cy="457200"/>
-                      </a:xfrm>
-                      <a:prstGeom prst="rect">
-                        <a:avLst/>
-                      </a:prstGeom>
-                      <a:noFill/>
-                      <a:ln>
-                        <a:noFill/>
-                      </a:ln>
-                      <a:effectLst/>
-                      <a:extLst>
-                        <a:ext uri="{909E8E84-426E-40DD-AFC4-6F175D3DCCD1}">
-                          <a14:hiddenFill xmlns:a14="http://schemas.microsoft.com/office/drawing/2010/main">
-                            <a:solidFill>
-                              <a:srgbClr val="FFFFFF"/>
-                            </a:solidFill>
-                          </a14:hiddenFill>
-                        </a:ext>
-                        <a:ext uri="{91240B29-F687-4F45-9708-019B960494DF}">
-                          <a14:hiddenLine xmlns:a14="http://schemas.microsoft.com/office/drawing/2010/main" w="9525">
-                            <a:solidFill>
-                              <a:srgbClr val="000000"/>
-                            </a:solidFill>
-                            <a:miter lim="800000"/>
-                            <a:headEnd/>
-                            <a:tailEnd/>
-                          </a14:hiddenLine>
-                        </a:ext>
-                        <a:ext uri="{AF507438-7753-43E0-B8FC-AC1667EBCBE1}">
-                          <a14:hiddenEffects xmlns:a14="http://schemas.microsoft.com/office/drawing/2010/main">
-                            <a:effectLst>
-                              <a:outerShdw dist="35921" dir="2700000" algn="ctr" rotWithShape="0">
-                                <a:srgbClr val="808080"/>
-                              </a:outerShdw>
-                            </a:effectLst>
-                          </a14:hiddenEffects>
-                        </a:ext>
-                      </a:extLst>
-                    </p:spPr>
-                  </p:pic>
-                </p:oleObj>
-              </mc:Fallback>
-            </mc:AlternateContent>
-          </a:graphicData>
-        </a:graphic>
-      </p:graphicFrame>
-      <p:graphicFrame>
-        <p:nvGraphicFramePr>
-          <p:cNvPr id="263172" name="Object 7"/>
-          <p:cNvGraphicFramePr>
-            <a:graphicFrameLocks noGrp="1" noChangeAspect="1"/>
-          </p:cNvGraphicFramePr>
-          <p:nvPr>
-            <p:ph sz="quarter" idx="3"/>
-            <p:extLst>
-              <p:ext uri="{D42A27DB-BD31-4B8C-83A1-F6EECF244321}">
-                <p14:modId xmlns:p14="http://schemas.microsoft.com/office/powerpoint/2010/main" val="1443483951"/>
-              </p:ext>
-            </p:extLst>
-          </p:nvPr>
-        </p:nvGraphicFramePr>
-        <p:xfrm>
-          <a:off x="5029686" y="4162887"/>
-          <a:ext cx="1508125" cy="511175"/>
-        </p:xfrm>
-        <a:graphic>
-          <a:graphicData uri="http://schemas.openxmlformats.org/presentationml/2006/ole">
-            <mc:AlternateContent xmlns:mc="http://schemas.openxmlformats.org/markup-compatibility/2006">
-              <mc:Choice xmlns:v="urn:schemas-microsoft-com:vml" Requires="v">
-                <p:oleObj name="Equation" r:id="rId5" imgW="748975" imgH="253890" progId="Equation.DSMT4">
-                  <p:embed/>
-                </p:oleObj>
-              </mc:Choice>
-              <mc:Fallback>
-                <p:oleObj name="Equation" r:id="rId5" imgW="748975" imgH="253890" progId="Equation.DSMT4">
-                  <p:embed/>
-                  <p:pic>
-                    <p:nvPicPr>
-                      <p:cNvPr id="0" name=""/>
-                      <p:cNvPicPr>
-                        <a:picLocks noChangeAspect="1" noChangeArrowheads="1"/>
-                      </p:cNvPicPr>
-                      <p:nvPr/>
-                    </p:nvPicPr>
-                    <p:blipFill>
-                      <a:blip r:embed="rId6">
-                        <a:extLst>
-                          <a:ext uri="{28A0092B-C50C-407E-A947-70E740481C1C}">
-                            <a14:useLocalDpi xmlns:a14="http://schemas.microsoft.com/office/drawing/2010/main" val="0"/>
-                          </a:ext>
-                        </a:extLst>
-                      </a:blip>
-                      <a:srcRect/>
-                      <a:stretch>
-                        <a:fillRect/>
-                      </a:stretch>
-                    </p:blipFill>
-                    <p:spPr bwMode="auto">
-                      <a:xfrm>
-                        <a:off x="5029686" y="4162887"/>
-                        <a:ext cx="1508125" cy="511175"/>
-                      </a:xfrm>
-                      <a:prstGeom prst="rect">
-                        <a:avLst/>
-                      </a:prstGeom>
-                      <a:noFill/>
-                      <a:ln>
-                        <a:noFill/>
-                      </a:ln>
-                      <a:effectLst/>
-                      <a:extLst>
-                        <a:ext uri="{909E8E84-426E-40DD-AFC4-6F175D3DCCD1}">
-                          <a14:hiddenFill xmlns:a14="http://schemas.microsoft.com/office/drawing/2010/main">
-                            <a:solidFill>
-                              <a:srgbClr val="FFFFFF"/>
-                            </a:solidFill>
-                          </a14:hiddenFill>
-                        </a:ext>
-                        <a:ext uri="{91240B29-F687-4F45-9708-019B960494DF}">
-                          <a14:hiddenLine xmlns:a14="http://schemas.microsoft.com/office/drawing/2010/main" w="9525">
-                            <a:solidFill>
-                              <a:srgbClr val="000000"/>
-                            </a:solidFill>
-                            <a:miter lim="800000"/>
-                            <a:headEnd/>
-                            <a:tailEnd/>
-                          </a14:hiddenLine>
-                        </a:ext>
-                        <a:ext uri="{AF507438-7753-43E0-B8FC-AC1667EBCBE1}">
-                          <a14:hiddenEffects xmlns:a14="http://schemas.microsoft.com/office/drawing/2010/main">
-                            <a:effectLst>
-                              <a:outerShdw dist="35921" dir="2700000" algn="ctr" rotWithShape="0">
-                                <a:srgbClr val="808080"/>
-                              </a:outerShdw>
-                            </a:effectLst>
-                          </a14:hiddenEffects>
-                        </a:ext>
-                      </a:extLst>
-                    </p:spPr>
-                  </p:pic>
-                </p:oleObj>
-              </mc:Fallback>
-            </mc:AlternateContent>
-          </a:graphicData>
-        </a:graphic>
-      </p:graphicFrame>
-      <p:graphicFrame>
-        <p:nvGraphicFramePr>
-          <p:cNvPr id="263173" name="Object 9"/>
-          <p:cNvGraphicFramePr>
-            <a:graphicFrameLocks noChangeAspect="1"/>
-          </p:cNvGraphicFramePr>
-          <p:nvPr>
-            <p:extLst>
-              <p:ext uri="{D42A27DB-BD31-4B8C-83A1-F6EECF244321}">
-                <p14:modId xmlns:p14="http://schemas.microsoft.com/office/powerpoint/2010/main" val="8511365"/>
-              </p:ext>
-            </p:extLst>
-          </p:nvPr>
-        </p:nvGraphicFramePr>
-        <p:xfrm>
-          <a:off x="1425401" y="4988138"/>
-          <a:ext cx="401637" cy="452437"/>
-        </p:xfrm>
-        <a:graphic>
-          <a:graphicData uri="http://schemas.openxmlformats.org/presentationml/2006/ole">
-            <mc:AlternateContent xmlns:mc="http://schemas.openxmlformats.org/markup-compatibility/2006">
-              <mc:Choice xmlns:v="urn:schemas-microsoft-com:vml" Requires="v">
-                <p:oleObj name="Equation" r:id="rId7" imgW="203112" imgH="228501" progId="Equation.DSMT4">
-                  <p:embed/>
-                </p:oleObj>
-              </mc:Choice>
-              <mc:Fallback>
-                <p:oleObj name="Equation" r:id="rId7" imgW="203112" imgH="228501" progId="Equation.DSMT4">
-                  <p:embed/>
-                  <p:pic>
-                    <p:nvPicPr>
-                      <p:cNvPr id="0" name=""/>
-                      <p:cNvPicPr>
-                        <a:picLocks noChangeAspect="1" noChangeArrowheads="1"/>
-                      </p:cNvPicPr>
-                      <p:nvPr/>
-                    </p:nvPicPr>
-                    <p:blipFill>
-                      <a:blip r:embed="rId8">
-                        <a:extLst>
-                          <a:ext uri="{28A0092B-C50C-407E-A947-70E740481C1C}">
-                            <a14:useLocalDpi xmlns:a14="http://schemas.microsoft.com/office/drawing/2010/main" val="0"/>
-                          </a:ext>
-                        </a:extLst>
-                      </a:blip>
-                      <a:srcRect/>
-                      <a:stretch>
-                        <a:fillRect/>
-                      </a:stretch>
-                    </p:blipFill>
-                    <p:spPr bwMode="auto">
-                      <a:xfrm>
-                        <a:off x="1425401" y="4988138"/>
-                        <a:ext cx="401637" cy="452437"/>
-                      </a:xfrm>
-                      <a:prstGeom prst="rect">
-                        <a:avLst/>
-                      </a:prstGeom>
-                      <a:noFill/>
-                      <a:ln>
-                        <a:noFill/>
-                      </a:ln>
-                      <a:effectLst/>
-                      <a:extLst>
-                        <a:ext uri="{909E8E84-426E-40DD-AFC4-6F175D3DCCD1}">
-                          <a14:hiddenFill xmlns:a14="http://schemas.microsoft.com/office/drawing/2010/main">
-                            <a:solidFill>
-                              <a:srgbClr val="FFFFFF"/>
-                            </a:solidFill>
-                          </a14:hiddenFill>
-                        </a:ext>
-                        <a:ext uri="{91240B29-F687-4F45-9708-019B960494DF}">
-                          <a14:hiddenLine xmlns:a14="http://schemas.microsoft.com/office/drawing/2010/main" w="9525">
-                            <a:solidFill>
-                              <a:srgbClr val="000000"/>
-                            </a:solidFill>
-                            <a:miter lim="800000"/>
-                            <a:headEnd/>
-                            <a:tailEnd/>
-                          </a14:hiddenLine>
-                        </a:ext>
-                        <a:ext uri="{AF507438-7753-43E0-B8FC-AC1667EBCBE1}">
-                          <a14:hiddenEffects xmlns:a14="http://schemas.microsoft.com/office/drawing/2010/main">
-                            <a:effectLst>
-                              <a:outerShdw blurRad="63500" dist="38099" dir="2700000" algn="ctr" rotWithShape="0">
-                                <a:srgbClr val="000000">
-                                  <a:alpha val="74997"/>
-                                </a:srgbClr>
-                              </a:outerShdw>
-                            </a:effectLst>
-                          </a14:hiddenEffects>
-                        </a:ext>
-                      </a:extLst>
-                    </p:spPr>
-                  </p:pic>
-                </p:oleObj>
-              </mc:Fallback>
-            </mc:AlternateContent>
-          </a:graphicData>
-        </a:graphic>
-      </p:graphicFrame>
+      <p:sp>
+        <p:nvSpPr>
+          <p:cNvPr id="263174" name="TextBox 263173"/>
+          <p:cNvSpPr txBox="1"/>
+          <p:nvPr/>
+        </p:nvSpPr>
+        <p:spPr>
+          <a:xfrm>
+            <a:off x="5402264" y="2347338"/>
+            <a:ext cx="984738" cy="457200"/>
+          </a:xfrm>
+          <a:prstGeom prst="rect">
+            <a:avLst/>
+          </a:prstGeom>
+          <a:noFill/>
+        </p:spPr>
+        <p:txBody>
+          <a:bodyPr wrap="square" anchor="ctr" lIns="0" rIns="0" tIns="0" bIns="0">
+            <a:spAutoFit/>
+          </a:bodyPr>
+          <a:lstStyle/>
+          <a:p>
+            <a:r>
+              <a:rPr sz="1900">
+                <a:latin typeface="Cambria"/>
+              </a:rPr>
+              <a:t>μ</a:t>
+            </a:r>
+            <a:r>
+              <a:rPr sz="1900" baseline="-25000">
+                <a:latin typeface="Cambria"/>
+              </a:rPr>
+              <a:t>x̄</a:t>
+            </a:r>
+            <a:r>
+              <a:rPr sz="1900">
+                <a:latin typeface="Cambria"/>
+              </a:rPr>
+              <a:t> = μ</a:t>
+            </a:r>
+          </a:p>
+        </p:txBody>
+      </p:sp>
+      <p:sp>
+        <p:nvSpPr>
+          <p:cNvPr id="263175" name="TextBox 263174"/>
+          <p:cNvSpPr txBox="1"/>
+          <p:nvPr/>
+        </p:nvSpPr>
+        <p:spPr>
+          <a:xfrm>
+            <a:off x="5029686" y="4162887"/>
+            <a:ext cx="1688123" cy="511175"/>
+          </a:xfrm>
+          <a:prstGeom prst="rect">
+            <a:avLst/>
+          </a:prstGeom>
+          <a:noFill/>
+        </p:spPr>
+        <p:txBody>
+          <a:bodyPr wrap="square" anchor="ctr" lIns="0" rIns="0" tIns="0" bIns="0">
+            <a:spAutoFit/>
+          </a:bodyPr>
+          <a:lstStyle/>
+          <a:p>
+            <a:r>
+              <a:rPr sz="1900">
+                <a:latin typeface="Cambria"/>
+              </a:rPr>
+              <a:t>σ</a:t>
+            </a:r>
+            <a:r>
+              <a:rPr sz="1900" baseline="-25000">
+                <a:latin typeface="Cambria"/>
+              </a:rPr>
+              <a:t>x̄</a:t>
+            </a:r>
+            <a:r>
+              <a:rPr sz="1900">
+                <a:latin typeface="Cambria"/>
+              </a:rPr>
+              <a:t> = σ / √n</a:t>
+            </a:r>
+          </a:p>
+        </p:txBody>
+      </p:sp>
     </p:spTree>
     <p:extLst>
       <p:ext uri="{BB962C8B-B14F-4D97-AF65-F5344CB8AC3E}">
@@ -16648,10 +16245,8 @@
               <a:t>n </a:t>
             </a:r>
             <a:r>
-              <a:rPr lang="en-US" altLang="en-US" dirty="0">
-                <a:sym typeface="Symbol" charset="2"/>
-              </a:rPr>
-              <a:t>~30) are drawn from </a:t>
+              <a:rPr lang="en-US" altLang="en-US" dirty="0"/>
+              <a:t>≥~30) are drawn from </a:t>
             </a:r>
             <a:r>
               <a:rPr lang="en-US" altLang="en-US" i="1" dirty="0">
@@ -16663,10 +16258,8 @@
               <a:t>any</a:t>
             </a:r>
             <a:r>
-              <a:rPr lang="en-US" altLang="en-US" dirty="0">
-                <a:sym typeface="Symbol" charset="2"/>
-              </a:rPr>
-              <a:t> population with a mean  and a standard deviation , the distribution of the means approximates a normal distribution. The greater the sample size, the better the approximation.</a:t>
+              <a:rPr lang="en-US" altLang="en-US" dirty="0"/>
+              <a:t> population with a mean μ and a standard deviation σ, the distribution of the means approximates a normal distribution. The greater the sample size, the better the approximation.</a:t>
             </a:r>
           </a:p>
           <a:p>
@@ -17587,10 +17180,8 @@
               <a:t> </a:t>
             </a:r>
             <a:r>
-              <a:rPr lang="en-US" altLang="en-US" sz="2000" dirty="0">
-                <a:sym typeface="Symbol" charset="2"/>
-              </a:rPr>
-              <a:t> 5 and </a:t>
+              <a:rPr lang="en-US" altLang="en-US" sz="2000" dirty="0"/>
+              <a:t>≥ 5 and </a:t>
             </a:r>
             <a:r>
               <a:rPr lang="en-US" altLang="en-US" sz="2000" i="1" dirty="0">
@@ -17599,10 +17190,8 @@
               <a:t>nq</a:t>
             </a:r>
             <a:r>
-              <a:rPr lang="en-US" altLang="en-US" sz="2000" dirty="0">
-                <a:sym typeface="Symbol" charset="2"/>
-              </a:rPr>
-              <a:t>  5, the binomial random variable </a:t>
+              <a:rPr lang="en-US" altLang="en-US" sz="2000" dirty="0"/>
+              <a:t> ≥ 5, the binomial random variable </a:t>
             </a:r>
             <a:r>
               <a:rPr lang="en-US" altLang="en-US" sz="2000" i="1" dirty="0">
@@ -17682,106 +17271,6 @@
           </a:p>
         </p:txBody>
       </p:sp>
-      <p:graphicFrame>
-        <p:nvGraphicFramePr>
-          <p:cNvPr id="269315" name="Object 4"/>
-          <p:cNvGraphicFramePr>
-            <a:graphicFrameLocks noGrp="1" noChangeAspect="1"/>
-          </p:cNvGraphicFramePr>
-          <p:nvPr>
-            <p:ph sz="half" idx="2"/>
-            <p:extLst>
-              <p:ext uri="{D42A27DB-BD31-4B8C-83A1-F6EECF244321}">
-                <p14:modId xmlns:p14="http://schemas.microsoft.com/office/powerpoint/2010/main" val="1106756332"/>
-              </p:ext>
-            </p:extLst>
-          </p:nvPr>
-        </p:nvGraphicFramePr>
-        <p:xfrm>
-          <a:off x="4487831" y="3537745"/>
-          <a:ext cx="2286000" cy="512762"/>
-        </p:xfrm>
-        <a:graphic>
-          <a:graphicData uri="http://schemas.openxmlformats.org/presentationml/2006/ole">
-            <mc:AlternateContent xmlns:mc="http://schemas.openxmlformats.org/markup-compatibility/2006">
-              <mc:Choice xmlns:v="urn:schemas-microsoft-com:vml" Requires="v">
-                <p:oleObj name="Equation" r:id="rId3" imgW="1129810" imgH="253890" progId="Equation.DSMT4">
-                  <p:embed/>
-                </p:oleObj>
-              </mc:Choice>
-              <mc:Fallback>
-                <p:oleObj name="Equation" r:id="rId3" imgW="1129810" imgH="253890" progId="Equation.DSMT4">
-                  <p:embed/>
-                  <p:pic>
-                    <p:nvPicPr>
-                      <p:cNvPr id="0" name=""/>
-                      <p:cNvPicPr>
-                        <a:picLocks noChangeAspect="1" noChangeArrowheads="1"/>
-                      </p:cNvPicPr>
-                      <p:nvPr/>
-                    </p:nvPicPr>
-                    <p:blipFill>
-                      <a:blip r:embed="rId4">
-                        <a:extLst>
-                          <a:ext uri="{28A0092B-C50C-407E-A947-70E740481C1C}">
-                            <a14:useLocalDpi xmlns:a14="http://schemas.microsoft.com/office/drawing/2010/main" val="0"/>
-                          </a:ext>
-                        </a:extLst>
-                      </a:blip>
-                      <a:srcRect/>
-                      <a:stretch>
-                        <a:fillRect/>
-                      </a:stretch>
-                    </p:blipFill>
-                    <p:spPr bwMode="auto">
-                      <a:xfrm>
-                        <a:off x="4487831" y="3537745"/>
-                        <a:ext cx="2286000" cy="512762"/>
-                      </a:xfrm>
-                      <a:prstGeom prst="rect">
-                        <a:avLst/>
-                      </a:prstGeom>
-                      <a:noFill/>
-                      <a:ln>
-                        <a:noFill/>
-                      </a:ln>
-                      <a:effectLst/>
-                      <a:extLst>
-                        <a:ext uri="{909E8E84-426E-40DD-AFC4-6F175D3DCCD1}">
-                          <a14:hiddenFill xmlns:a14="http://schemas.microsoft.com/office/drawing/2010/main">
-                            <a:solidFill>
-                              <a:srgbClr val="FFFFFF"/>
-                            </a:solidFill>
-                          </a14:hiddenFill>
-                        </a:ext>
-                        <a:ext uri="{91240B29-F687-4F45-9708-019B960494DF}">
-                          <a14:hiddenLine xmlns:a14="http://schemas.microsoft.com/office/drawing/2010/main" w="9525">
-                            <a:solidFill>
-                              <a:srgbClr val="000000"/>
-                            </a:solidFill>
-                            <a:miter lim="800000"/>
-                            <a:headEnd/>
-                            <a:tailEnd/>
-                          </a14:hiddenLine>
-                        </a:ext>
-                        <a:ext uri="{AF507438-7753-43E0-B8FC-AC1667EBCBE1}">
-                          <a14:hiddenEffects xmlns:a14="http://schemas.microsoft.com/office/drawing/2010/main">
-                            <a:effectLst>
-                              <a:outerShdw dist="35921" dir="2700000" algn="ctr" rotWithShape="0">
-                                <a:srgbClr val="808080"/>
-                              </a:outerShdw>
-                            </a:effectLst>
-                          </a14:hiddenEffects>
-                        </a:ext>
-                      </a:extLst>
-                    </p:spPr>
-                  </p:pic>
-                </p:oleObj>
-              </mc:Fallback>
-            </mc:AlternateContent>
-          </a:graphicData>
-        </a:graphic>
-      </p:graphicFrame>
       <p:sp>
         <p:nvSpPr>
           <p:cNvPr id="2" name="TextBox 1"/>
@@ -17815,6 +17304,37 @@
             <a:r>
               <a:rPr lang="en-US" dirty="0"/>
               <a:t> of a binomial random variable</a:t>
+            </a:r>
+          </a:p>
+        </p:txBody>
+      </p:sp>
+      <p:sp>
+        <p:nvSpPr>
+          <p:cNvPr id="4100" name="TextBox 4099"/>
+          <p:cNvSpPr txBox="1"/>
+          <p:nvPr/>
+        </p:nvSpPr>
+        <p:spPr>
+          <a:xfrm>
+            <a:off x="4487831" y="3537745"/>
+            <a:ext cx="2391507" cy="512762"/>
+          </a:xfrm>
+          <a:prstGeom prst="rect">
+            <a:avLst/>
+          </a:prstGeom>
+          <a:noFill/>
+        </p:spPr>
+        <p:txBody>
+          <a:bodyPr wrap="square" anchor="ctr" lIns="0" rIns="0" tIns="0" bIns="0">
+            <a:spAutoFit/>
+          </a:bodyPr>
+          <a:lstStyle/>
+          <a:p>
+            <a:r>
+              <a:rPr sz="1900">
+                <a:latin typeface="Cambria"/>
+              </a:rPr>
+              <a:t>X ≈ N(np, √(npq))</a:t>
             </a:r>
           </a:p>
         </p:txBody>
@@ -18414,16 +17934,12 @@
               <a:t>If </a:t>
             </a:r>
             <a:r>
-              <a:rPr lang="en-US" altLang="en-US" dirty="0">
-                <a:sym typeface="Symbol" charset="2"/>
-              </a:rPr>
-              <a:t>&gt;10, the Poisson random variable </a:t>
-            </a:r>
-            <a:r>
-              <a:rPr lang="en-US" altLang="en-US" i="1" dirty="0">
-                <a:sym typeface="Symbol" charset="2"/>
-              </a:rPr>
-              <a:t>X ~P()</a:t>
+              <a:rPr lang="en-US" altLang="en-US" dirty="0"/>
+              <a:t>μ&gt;10, the Poisson random variable </a:t>
+            </a:r>
+            <a:r>
+              <a:rPr lang="en-US" altLang="en-US" i="1" dirty="0"/>
+              <a:t>X ~P(μ)</a:t>
             </a:r>
             <a:r>
               <a:rPr lang="en-US" altLang="en-US" dirty="0">
@@ -18450,101 +17966,6 @@
           </a:p>
         </p:txBody>
       </p:sp>
-      <p:graphicFrame>
-        <p:nvGraphicFramePr>
-          <p:cNvPr id="275459" name="Object 4"/>
-          <p:cNvGraphicFramePr>
-            <a:graphicFrameLocks noGrp="1" noChangeAspect="1"/>
-          </p:cNvGraphicFramePr>
-          <p:nvPr>
-            <p:ph sz="half" idx="2"/>
-          </p:nvPr>
-        </p:nvGraphicFramePr>
-        <p:xfrm>
-          <a:off x="4564063" y="4183064"/>
-          <a:ext cx="2590800" cy="700087"/>
-        </p:xfrm>
-        <a:graphic>
-          <a:graphicData uri="http://schemas.openxmlformats.org/presentationml/2006/ole">
-            <mc:AlternateContent xmlns:mc="http://schemas.openxmlformats.org/markup-compatibility/2006">
-              <mc:Choice xmlns:v="urn:schemas-microsoft-com:vml" Requires="v">
-                <p:oleObj name="Equation" r:id="rId3" imgW="939392" imgH="253890" progId="Equation.DSMT4">
-                  <p:embed/>
-                </p:oleObj>
-              </mc:Choice>
-              <mc:Fallback>
-                <p:oleObj name="Equation" r:id="rId3" imgW="939392" imgH="253890" progId="Equation.DSMT4">
-                  <p:embed/>
-                  <p:pic>
-                    <p:nvPicPr>
-                      <p:cNvPr id="0" name=""/>
-                      <p:cNvPicPr>
-                        <a:picLocks noChangeAspect="1" noChangeArrowheads="1"/>
-                      </p:cNvPicPr>
-                      <p:nvPr/>
-                    </p:nvPicPr>
-                    <p:blipFill>
-                      <a:blip r:embed="rId4">
-                        <a:extLst>
-                          <a:ext uri="{28A0092B-C50C-407E-A947-70E740481C1C}">
-                            <a14:useLocalDpi xmlns:a14="http://schemas.microsoft.com/office/drawing/2010/main" val="0"/>
-                          </a:ext>
-                        </a:extLst>
-                      </a:blip>
-                      <a:srcRect/>
-                      <a:stretch>
-                        <a:fillRect/>
-                      </a:stretch>
-                    </p:blipFill>
-                    <p:spPr bwMode="auto">
-                      <a:xfrm>
-                        <a:off x="4564063" y="4183064"/>
-                        <a:ext cx="2590800" cy="700087"/>
-                      </a:xfrm>
-                      <a:prstGeom prst="rect">
-                        <a:avLst/>
-                      </a:prstGeom>
-                      <a:noFill/>
-                      <a:ln>
-                        <a:noFill/>
-                      </a:ln>
-                      <a:effectLst/>
-                      <a:extLst>
-                        <a:ext uri="{909E8E84-426E-40DD-AFC4-6F175D3DCCD1}">
-                          <a14:hiddenFill xmlns:a14="http://schemas.microsoft.com/office/drawing/2010/main">
-                            <a:solidFill>
-                              <a:srgbClr val="FFFFFF"/>
-                            </a:solidFill>
-                          </a14:hiddenFill>
-                        </a:ext>
-                        <a:ext uri="{91240B29-F687-4F45-9708-019B960494DF}">
-                          <a14:hiddenLine xmlns:a14="http://schemas.microsoft.com/office/drawing/2010/main" w="9525">
-                            <a:solidFill>
-                              <a:srgbClr val="000000"/>
-                            </a:solidFill>
-                            <a:miter lim="800000"/>
-                            <a:headEnd/>
-                            <a:tailEnd/>
-                          </a14:hiddenLine>
-                        </a:ext>
-                        <a:ext uri="{AF507438-7753-43E0-B8FC-AC1667EBCBE1}">
-                          <a14:hiddenEffects xmlns:a14="http://schemas.microsoft.com/office/drawing/2010/main">
-                            <a:effectLst>
-                              <a:outerShdw dist="35921" dir="2700000" algn="ctr" rotWithShape="0">
-                                <a:srgbClr val="808080"/>
-                              </a:outerShdw>
-                            </a:effectLst>
-                          </a14:hiddenEffects>
-                        </a:ext>
-                      </a:extLst>
-                    </p:spPr>
-                  </p:pic>
-                </p:oleObj>
-              </mc:Fallback>
-            </mc:AlternateContent>
-          </a:graphicData>
-        </a:graphic>
-      </p:graphicFrame>
       <p:sp>
         <p:nvSpPr>
           <p:cNvPr id="2" name="Rectangle 1"/>
@@ -18864,6 +18285,37 @@
             <a:r>
               <a:rPr lang="en-US" dirty="0"/>
               <a:t> of a Poisson random variable</a:t>
+            </a:r>
+          </a:p>
+        </p:txBody>
+      </p:sp>
+      <p:sp>
+        <p:nvSpPr>
+          <p:cNvPr id="9220" name="TextBox 9219"/>
+          <p:cNvSpPr txBox="1"/>
+          <p:nvPr/>
+        </p:nvSpPr>
+        <p:spPr>
+          <a:xfrm>
+            <a:off x="4564063" y="4183064"/>
+            <a:ext cx="2590800" cy="700087"/>
+          </a:xfrm>
+          <a:prstGeom prst="rect">
+            <a:avLst/>
+          </a:prstGeom>
+          <a:noFill/>
+        </p:spPr>
+        <p:txBody>
+          <a:bodyPr wrap="square" anchor="ctr" lIns="0" rIns="0" tIns="0" bIns="0">
+            <a:spAutoFit/>
+          </a:bodyPr>
+          <a:lstStyle/>
+          <a:p>
+            <a:r>
+              <a:rPr sz="2600">
+                <a:latin typeface="Cambria"/>
+              </a:rPr>
+              <a:t>X ≈ N(μ, √μ)</a:t>
             </a:r>
           </a:p>
         </p:txBody>
@@ -19020,10 +18472,8 @@
               <a:t> </a:t>
             </a:r>
             <a:r>
-              <a:rPr lang="en-US" altLang="en-US" dirty="0">
-                <a:sym typeface="Symbol" charset="2"/>
-              </a:rPr>
-              <a:t>X  x]</a:t>
+              <a:rPr lang="en-US" altLang="en-US" dirty="0"/>
+              <a:t>X ≤ x]</a:t>
             </a:r>
           </a:p>
           <a:p>
@@ -20307,101 +19757,6 @@
           </a:extLst>
         </p:spPr>
       </p:pic>
-      <p:graphicFrame>
-        <p:nvGraphicFramePr>
-          <p:cNvPr id="7172" name="Object 6"/>
-          <p:cNvGraphicFramePr>
-            <a:graphicFrameLocks noGrp="1" noChangeAspect="1"/>
-          </p:cNvGraphicFramePr>
-          <p:nvPr>
-            <p:ph sz="half" idx="2"/>
-          </p:nvPr>
-        </p:nvGraphicFramePr>
-        <p:xfrm>
-          <a:off x="2362200" y="2286001"/>
-          <a:ext cx="2306638" cy="1552575"/>
-        </p:xfrm>
-        <a:graphic>
-          <a:graphicData uri="http://schemas.openxmlformats.org/presentationml/2006/ole">
-            <mc:AlternateContent xmlns:mc="http://schemas.openxmlformats.org/markup-compatibility/2006">
-              <mc:Choice xmlns:v="urn:schemas-microsoft-com:vml" Requires="v">
-                <p:oleObj name="Equation" r:id="rId4" imgW="622030" imgH="418918" progId="Equation.DSMT4">
-                  <p:embed/>
-                </p:oleObj>
-              </mc:Choice>
-              <mc:Fallback>
-                <p:oleObj name="Equation" r:id="rId4" imgW="622030" imgH="418918" progId="Equation.DSMT4">
-                  <p:embed/>
-                  <p:pic>
-                    <p:nvPicPr>
-                      <p:cNvPr id="0" name=""/>
-                      <p:cNvPicPr>
-                        <a:picLocks noChangeAspect="1" noChangeArrowheads="1"/>
-                      </p:cNvPicPr>
-                      <p:nvPr/>
-                    </p:nvPicPr>
-                    <p:blipFill>
-                      <a:blip r:embed="rId5">
-                        <a:extLst>
-                          <a:ext uri="{28A0092B-C50C-407E-A947-70E740481C1C}">
-                            <a14:useLocalDpi xmlns:a14="http://schemas.microsoft.com/office/drawing/2010/main" val="0"/>
-                          </a:ext>
-                        </a:extLst>
-                      </a:blip>
-                      <a:srcRect/>
-                      <a:stretch>
-                        <a:fillRect/>
-                      </a:stretch>
-                    </p:blipFill>
-                    <p:spPr bwMode="auto">
-                      <a:xfrm>
-                        <a:off x="2362200" y="2286001"/>
-                        <a:ext cx="2306638" cy="1552575"/>
-                      </a:xfrm>
-                      <a:prstGeom prst="rect">
-                        <a:avLst/>
-                      </a:prstGeom>
-                      <a:noFill/>
-                      <a:ln>
-                        <a:noFill/>
-                      </a:ln>
-                      <a:effectLst/>
-                      <a:extLst>
-                        <a:ext uri="{909E8E84-426E-40DD-AFC4-6F175D3DCCD1}">
-                          <a14:hiddenFill xmlns:a14="http://schemas.microsoft.com/office/drawing/2010/main">
-                            <a:solidFill>
-                              <a:srgbClr val="FFFFFF"/>
-                            </a:solidFill>
-                          </a14:hiddenFill>
-                        </a:ext>
-                        <a:ext uri="{91240B29-F687-4F45-9708-019B960494DF}">
-                          <a14:hiddenLine xmlns:a14="http://schemas.microsoft.com/office/drawing/2010/main" w="9525">
-                            <a:solidFill>
-                              <a:srgbClr val="000000"/>
-                            </a:solidFill>
-                            <a:miter lim="800000"/>
-                            <a:headEnd/>
-                            <a:tailEnd/>
-                          </a14:hiddenLine>
-                        </a:ext>
-                        <a:ext uri="{AF507438-7753-43E0-B8FC-AC1667EBCBE1}">
-                          <a14:hiddenEffects xmlns:a14="http://schemas.microsoft.com/office/drawing/2010/main">
-                            <a:effectLst>
-                              <a:outerShdw dist="35921" dir="2700000" algn="ctr" rotWithShape="0">
-                                <a:srgbClr val="808080"/>
-                              </a:outerShdw>
-                            </a:effectLst>
-                          </a14:hiddenEffects>
-                        </a:ext>
-                      </a:extLst>
-                    </p:spPr>
-                  </p:pic>
-                </p:oleObj>
-              </mc:Fallback>
-            </mc:AlternateContent>
-          </a:graphicData>
-        </a:graphic>
-      </p:graphicFrame>
       <p:sp>
         <p:nvSpPr>
           <p:cNvPr id="7173" name="Text Box 8"/>
@@ -21099,6 +20454,37 @@
           </a:fontRef>
         </p:style>
       </p:cxnSp>
+      <p:sp>
+        <p:nvSpPr>
+          <p:cNvPr id="7177" name="TextBox 7176"/>
+          <p:cNvSpPr txBox="1"/>
+          <p:nvPr/>
+        </p:nvSpPr>
+        <p:spPr>
+          <a:xfrm>
+            <a:off x="2362200" y="2286001"/>
+            <a:ext cx="2306638" cy="1552575"/>
+          </a:xfrm>
+          <a:prstGeom prst="rect">
+            <a:avLst/>
+          </a:prstGeom>
+          <a:noFill/>
+        </p:spPr>
+        <p:txBody>
+          <a:bodyPr wrap="square" anchor="ctr" lIns="0" rIns="0" tIns="0" bIns="0">
+            <a:spAutoFit/>
+          </a:bodyPr>
+          <a:lstStyle/>
+          <a:p>
+            <a:r>
+              <a:rPr sz="1400">
+                <a:latin typeface="Cambria"/>
+              </a:rPr>
+              <a:t>t = (x̄ − μ) / (s / √n)</a:t>
+            </a:r>
+          </a:p>
+        </p:txBody>
+      </p:sp>
     </p:spTree>
     <p:extLst>
       <p:ext uri="{BB962C8B-B14F-4D97-AF65-F5344CB8AC3E}">
@@ -21226,10 +20612,8 @@
               <a:t>(</a:t>
             </a:r>
             <a:r>
-              <a:rPr lang="en-US" altLang="en-US" sz="2400" i="1" dirty="0">
-                <a:sym typeface="Symbol" charset="2"/>
-              </a:rPr>
-              <a:t>,</a:t>
+              <a:rPr lang="en-US" altLang="en-US" sz="2400" i="1" dirty="0"/>
+              <a:t>μ,</a:t>
             </a:r>
             <a:r>
               <a:rPr lang="el-GR" sz="2400" dirty="0"/>
@@ -21256,10 +20640,8 @@
               <a:t> ~ lognormal(</a:t>
             </a:r>
             <a:r>
-              <a:rPr lang="en-US" altLang="en-US" sz="2400" i="1" dirty="0">
-                <a:sym typeface="Symbol" charset="2"/>
-              </a:rPr>
-              <a:t>,</a:t>
+              <a:rPr lang="en-US" altLang="en-US" sz="2400" i="1" dirty="0"/>
+              <a:t>μ,</a:t>
             </a:r>
             <a:r>
               <a:rPr lang="el-GR" sz="2400" dirty="0"/>
@@ -22970,10 +22352,8 @@
               <a:t>If events are occurring at random with average rate of </a:t>
             </a:r>
             <a:r>
-              <a:rPr lang="en-US" altLang="en-US" sz="2600" dirty="0">
-                <a:sym typeface="Symbol" charset="2"/>
-              </a:rPr>
-              <a:t> per interval, then the </a:t>
+              <a:rPr lang="en-US" altLang="en-US" sz="2600" dirty="0"/>
+              <a:t>λ per interval, then the </a:t>
             </a:r>
             <a:r>
               <a:rPr lang="en-US" altLang="en-US" sz="2600" b="1" dirty="0">
@@ -22990,106 +22370,6 @@
           </a:p>
         </p:txBody>
       </p:sp>
-      <p:graphicFrame>
-        <p:nvGraphicFramePr>
-          <p:cNvPr id="277507" name="Object 4"/>
-          <p:cNvGraphicFramePr>
-            <a:graphicFrameLocks noGrp="1" noChangeAspect="1"/>
-          </p:cNvGraphicFramePr>
-          <p:nvPr>
-            <p:ph sz="half" idx="2"/>
-            <p:extLst>
-              <p:ext uri="{D42A27DB-BD31-4B8C-83A1-F6EECF244321}">
-                <p14:modId xmlns:p14="http://schemas.microsoft.com/office/powerpoint/2010/main" val="1203704957"/>
-              </p:ext>
-            </p:extLst>
-          </p:nvPr>
-        </p:nvGraphicFramePr>
-        <p:xfrm>
-          <a:off x="4904630" y="4794907"/>
-          <a:ext cx="2209800" cy="622300"/>
-        </p:xfrm>
-        <a:graphic>
-          <a:graphicData uri="http://schemas.openxmlformats.org/presentationml/2006/ole">
-            <mc:AlternateContent xmlns:mc="http://schemas.openxmlformats.org/markup-compatibility/2006">
-              <mc:Choice xmlns:v="urn:schemas-microsoft-com:vml" Requires="v">
-                <p:oleObj name="Equation" r:id="rId3" imgW="812447" imgH="228501" progId="Equation.DSMT4">
-                  <p:embed/>
-                </p:oleObj>
-              </mc:Choice>
-              <mc:Fallback>
-                <p:oleObj name="Equation" r:id="rId3" imgW="812447" imgH="228501" progId="Equation.DSMT4">
-                  <p:embed/>
-                  <p:pic>
-                    <p:nvPicPr>
-                      <p:cNvPr id="0" name=""/>
-                      <p:cNvPicPr>
-                        <a:picLocks noChangeAspect="1" noChangeArrowheads="1"/>
-                      </p:cNvPicPr>
-                      <p:nvPr/>
-                    </p:nvPicPr>
-                    <p:blipFill>
-                      <a:blip r:embed="rId4">
-                        <a:extLst>
-                          <a:ext uri="{28A0092B-C50C-407E-A947-70E740481C1C}">
-                            <a14:useLocalDpi xmlns:a14="http://schemas.microsoft.com/office/drawing/2010/main" val="0"/>
-                          </a:ext>
-                        </a:extLst>
-                      </a:blip>
-                      <a:srcRect/>
-                      <a:stretch>
-                        <a:fillRect/>
-                      </a:stretch>
-                    </p:blipFill>
-                    <p:spPr bwMode="auto">
-                      <a:xfrm>
-                        <a:off x="4904630" y="4794907"/>
-                        <a:ext cx="2209800" cy="622300"/>
-                      </a:xfrm>
-                      <a:prstGeom prst="rect">
-                        <a:avLst/>
-                      </a:prstGeom>
-                      <a:noFill/>
-                      <a:ln>
-                        <a:noFill/>
-                      </a:ln>
-                      <a:effectLst/>
-                      <a:extLst>
-                        <a:ext uri="{909E8E84-426E-40DD-AFC4-6F175D3DCCD1}">
-                          <a14:hiddenFill xmlns:a14="http://schemas.microsoft.com/office/drawing/2010/main">
-                            <a:solidFill>
-                              <a:srgbClr val="FFFFFF"/>
-                            </a:solidFill>
-                          </a14:hiddenFill>
-                        </a:ext>
-                        <a:ext uri="{91240B29-F687-4F45-9708-019B960494DF}">
-                          <a14:hiddenLine xmlns:a14="http://schemas.microsoft.com/office/drawing/2010/main" w="9525">
-                            <a:solidFill>
-                              <a:srgbClr val="000000"/>
-                            </a:solidFill>
-                            <a:miter lim="800000"/>
-                            <a:headEnd/>
-                            <a:tailEnd/>
-                          </a14:hiddenLine>
-                        </a:ext>
-                        <a:ext uri="{AF507438-7753-43E0-B8FC-AC1667EBCBE1}">
-                          <a14:hiddenEffects xmlns:a14="http://schemas.microsoft.com/office/drawing/2010/main">
-                            <a:effectLst>
-                              <a:outerShdw dist="35921" dir="2700000" algn="ctr" rotWithShape="0">
-                                <a:srgbClr val="808080"/>
-                              </a:outerShdw>
-                            </a:effectLst>
-                          </a14:hiddenEffects>
-                        </a:ext>
-                      </a:extLst>
-                    </p:spPr>
-                  </p:pic>
-                </p:oleObj>
-              </mc:Fallback>
-            </mc:AlternateContent>
-          </a:graphicData>
-        </a:graphic>
-      </p:graphicFrame>
       <p:sp>
         <p:nvSpPr>
           <p:cNvPr id="2" name="TextBox 1"/>
@@ -23228,6 +22508,43 @@
           </p:sp>
         </mc:Fallback>
       </mc:AlternateContent>
+      <p:sp>
+        <p:nvSpPr>
+          <p:cNvPr id="12292" name="TextBox 12291"/>
+          <p:cNvSpPr txBox="1"/>
+          <p:nvPr/>
+        </p:nvSpPr>
+        <p:spPr>
+          <a:xfrm>
+            <a:off x="4904630" y="4794907"/>
+            <a:ext cx="2209800" cy="622300"/>
+          </a:xfrm>
+          <a:prstGeom prst="rect">
+            <a:avLst/>
+          </a:prstGeom>
+          <a:noFill/>
+        </p:spPr>
+        <p:txBody>
+          <a:bodyPr wrap="square" anchor="ctr" lIns="0" rIns="0" tIns="0" bIns="0">
+            <a:spAutoFit/>
+          </a:bodyPr>
+          <a:lstStyle/>
+          <a:p>
+            <a:r>
+              <a:rPr sz="2400">
+                <a:latin typeface="Cambria"/>
+              </a:rPr>
+              <a:t>f(x) = λ e</a:t>
+            </a:r>
+            <a:r>
+              <a:rPr sz="2400" baseline="30000">
+                <a:latin typeface="Cambria"/>
+              </a:rPr>
+              <a:t>−λx</a:t>
+            </a:r>
+          </a:p>
+        </p:txBody>
+      </p:sp>
     </p:spTree>
     <p:extLst>
       <p:ext uri="{BB962C8B-B14F-4D97-AF65-F5344CB8AC3E}">
@@ -24593,7 +23910,7 @@
       </p:sp>
       <p:graphicFrame>
         <p:nvGraphicFramePr>
-          <p:cNvPr id="279555" name="Object 4"/>
+          <p:cNvPr id="279555" name="Object 4" descr="Line plot of the exponential distribution used for time between spawnings. The x-axis is time between spawnings in weeks, 0 to 5; the y-axis is density, 0 to 0.08. A smooth exponential decay curve starts at about 0.075 at time 0, falls steeply to roughly 0.02 by 2 weeks, and flattens toward 0 beyond about 4 weeks, showing that short intervals between spawnings are most likely and long intervals become increasingly rare."/>
           <p:cNvGraphicFramePr>
             <a:graphicFrameLocks noGrp="1" noChangeAspect="1"/>
           </p:cNvGraphicFramePr>
@@ -24964,10 +24281,8 @@
               <a:t>P[X&gt;2] = 1-P[X</a:t>
             </a:r>
             <a:r>
-              <a:rPr lang="en-US" altLang="en-US" dirty="0">
-                <a:sym typeface="Symbol" charset="2"/>
-              </a:rPr>
-              <a:t>2]=0.0498</a:t>
+              <a:rPr lang="en-US" altLang="en-US" dirty="0"/>
+              <a:t>≤2]=0.0498</a:t>
             </a:r>
           </a:p>
           <a:p>
@@ -25164,206 +24479,6 @@
           </a:p>
         </p:txBody>
       </p:sp>
-      <p:graphicFrame>
-        <p:nvGraphicFramePr>
-          <p:cNvPr id="285699" name="Object 4"/>
-          <p:cNvGraphicFramePr>
-            <a:graphicFrameLocks noGrp="1" noChangeAspect="1"/>
-          </p:cNvGraphicFramePr>
-          <p:nvPr>
-            <p:ph sz="quarter" idx="2"/>
-            <p:extLst>
-              <p:ext uri="{D42A27DB-BD31-4B8C-83A1-F6EECF244321}">
-                <p14:modId xmlns:p14="http://schemas.microsoft.com/office/powerpoint/2010/main" val="1533184933"/>
-              </p:ext>
-            </p:extLst>
-          </p:nvPr>
-        </p:nvGraphicFramePr>
-        <p:xfrm>
-          <a:off x="5181601" y="2761264"/>
-          <a:ext cx="1571625" cy="412750"/>
-        </p:xfrm>
-        <a:graphic>
-          <a:graphicData uri="http://schemas.openxmlformats.org/presentationml/2006/ole">
-            <mc:AlternateContent xmlns:mc="http://schemas.openxmlformats.org/markup-compatibility/2006">
-              <mc:Choice xmlns:v="urn:schemas-microsoft-com:vml" Requires="v">
-                <p:oleObj name="Equation" r:id="rId3" imgW="774364" imgH="203112" progId="Equation.DSMT4">
-                  <p:embed/>
-                </p:oleObj>
-              </mc:Choice>
-              <mc:Fallback>
-                <p:oleObj name="Equation" r:id="rId3" imgW="774364" imgH="203112" progId="Equation.DSMT4">
-                  <p:embed/>
-                  <p:pic>
-                    <p:nvPicPr>
-                      <p:cNvPr id="0" name=""/>
-                      <p:cNvPicPr>
-                        <a:picLocks noChangeAspect="1" noChangeArrowheads="1"/>
-                      </p:cNvPicPr>
-                      <p:nvPr/>
-                    </p:nvPicPr>
-                    <p:blipFill>
-                      <a:blip r:embed="rId4">
-                        <a:extLst>
-                          <a:ext uri="{28A0092B-C50C-407E-A947-70E740481C1C}">
-                            <a14:useLocalDpi xmlns:a14="http://schemas.microsoft.com/office/drawing/2010/main" val="0"/>
-                          </a:ext>
-                        </a:extLst>
-                      </a:blip>
-                      <a:srcRect/>
-                      <a:stretch>
-                        <a:fillRect/>
-                      </a:stretch>
-                    </p:blipFill>
-                    <p:spPr bwMode="auto">
-                      <a:xfrm>
-                        <a:off x="5181601" y="2761264"/>
-                        <a:ext cx="1571625" cy="412750"/>
-                      </a:xfrm>
-                      <a:prstGeom prst="rect">
-                        <a:avLst/>
-                      </a:prstGeom>
-                      <a:noFill/>
-                      <a:ln>
-                        <a:noFill/>
-                      </a:ln>
-                      <a:effectLst/>
-                      <a:extLst>
-                        <a:ext uri="{909E8E84-426E-40DD-AFC4-6F175D3DCCD1}">
-                          <a14:hiddenFill xmlns:a14="http://schemas.microsoft.com/office/drawing/2010/main">
-                            <a:solidFill>
-                              <a:srgbClr val="FFFFFF"/>
-                            </a:solidFill>
-                          </a14:hiddenFill>
-                        </a:ext>
-                        <a:ext uri="{91240B29-F687-4F45-9708-019B960494DF}">
-                          <a14:hiddenLine xmlns:a14="http://schemas.microsoft.com/office/drawing/2010/main" w="9525">
-                            <a:solidFill>
-                              <a:srgbClr val="000000"/>
-                            </a:solidFill>
-                            <a:miter lim="800000"/>
-                            <a:headEnd/>
-                            <a:tailEnd/>
-                          </a14:hiddenLine>
-                        </a:ext>
-                        <a:ext uri="{AF507438-7753-43E0-B8FC-AC1667EBCBE1}">
-                          <a14:hiddenEffects xmlns:a14="http://schemas.microsoft.com/office/drawing/2010/main">
-                            <a:effectLst>
-                              <a:outerShdw dist="35921" dir="2700000" algn="ctr" rotWithShape="0">
-                                <a:srgbClr val="808080"/>
-                              </a:outerShdw>
-                            </a:effectLst>
-                          </a14:hiddenEffects>
-                        </a:ext>
-                      </a:extLst>
-                    </p:spPr>
-                  </p:pic>
-                </p:oleObj>
-              </mc:Fallback>
-            </mc:AlternateContent>
-          </a:graphicData>
-        </a:graphic>
-      </p:graphicFrame>
-      <p:graphicFrame>
-        <p:nvGraphicFramePr>
-          <p:cNvPr id="285700" name="Object 6"/>
-          <p:cNvGraphicFramePr>
-            <a:graphicFrameLocks noGrp="1" noChangeAspect="1"/>
-          </p:cNvGraphicFramePr>
-          <p:nvPr>
-            <p:ph sz="quarter" idx="3"/>
-            <p:extLst>
-              <p:ext uri="{D42A27DB-BD31-4B8C-83A1-F6EECF244321}">
-                <p14:modId xmlns:p14="http://schemas.microsoft.com/office/powerpoint/2010/main" val="841090861"/>
-              </p:ext>
-            </p:extLst>
-          </p:nvPr>
-        </p:nvGraphicFramePr>
-        <p:xfrm>
-          <a:off x="5155069" y="4324092"/>
-          <a:ext cx="1600200" cy="787400"/>
-        </p:xfrm>
-        <a:graphic>
-          <a:graphicData uri="http://schemas.openxmlformats.org/presentationml/2006/ole">
-            <mc:AlternateContent xmlns:mc="http://schemas.openxmlformats.org/markup-compatibility/2006">
-              <mc:Choice xmlns:v="urn:schemas-microsoft-com:vml" Requires="v">
-                <p:oleObj name="Equation" r:id="rId5" imgW="799753" imgH="393529" progId="Equation.DSMT4">
-                  <p:embed/>
-                </p:oleObj>
-              </mc:Choice>
-              <mc:Fallback>
-                <p:oleObj name="Equation" r:id="rId5" imgW="799753" imgH="393529" progId="Equation.DSMT4">
-                  <p:embed/>
-                  <p:pic>
-                    <p:nvPicPr>
-                      <p:cNvPr id="0" name=""/>
-                      <p:cNvPicPr>
-                        <a:picLocks noChangeAspect="1" noChangeArrowheads="1"/>
-                      </p:cNvPicPr>
-                      <p:nvPr/>
-                    </p:nvPicPr>
-                    <p:blipFill>
-                      <a:blip r:embed="rId6">
-                        <a:extLst>
-                          <a:ext uri="{28A0092B-C50C-407E-A947-70E740481C1C}">
-                            <a14:useLocalDpi xmlns:a14="http://schemas.microsoft.com/office/drawing/2010/main" val="0"/>
-                          </a:ext>
-                        </a:extLst>
-                      </a:blip>
-                      <a:srcRect/>
-                      <a:stretch>
-                        <a:fillRect/>
-                      </a:stretch>
-                    </p:blipFill>
-                    <p:spPr bwMode="auto">
-                      <a:xfrm>
-                        <a:off x="5155069" y="4324092"/>
-                        <a:ext cx="1600200" cy="787400"/>
-                      </a:xfrm>
-                      <a:prstGeom prst="rect">
-                        <a:avLst/>
-                      </a:prstGeom>
-                      <a:noFill/>
-                      <a:ln>
-                        <a:noFill/>
-                      </a:ln>
-                      <a:effectLst/>
-                      <a:extLst>
-                        <a:ext uri="{909E8E84-426E-40DD-AFC4-6F175D3DCCD1}">
-                          <a14:hiddenFill xmlns:a14="http://schemas.microsoft.com/office/drawing/2010/main">
-                            <a:solidFill>
-                              <a:srgbClr val="FFFFFF"/>
-                            </a:solidFill>
-                          </a14:hiddenFill>
-                        </a:ext>
-                        <a:ext uri="{91240B29-F687-4F45-9708-019B960494DF}">
-                          <a14:hiddenLine xmlns:a14="http://schemas.microsoft.com/office/drawing/2010/main" w="9525">
-                            <a:solidFill>
-                              <a:srgbClr val="000000"/>
-                            </a:solidFill>
-                            <a:miter lim="800000"/>
-                            <a:headEnd/>
-                            <a:tailEnd/>
-                          </a14:hiddenLine>
-                        </a:ext>
-                        <a:ext uri="{AF507438-7753-43E0-B8FC-AC1667EBCBE1}">
-                          <a14:hiddenEffects xmlns:a14="http://schemas.microsoft.com/office/drawing/2010/main">
-                            <a:effectLst>
-                              <a:outerShdw dist="35921" dir="2700000" algn="ctr" rotWithShape="0">
-                                <a:srgbClr val="808080"/>
-                              </a:outerShdw>
-                            </a:effectLst>
-                          </a14:hiddenEffects>
-                        </a:ext>
-                      </a:extLst>
-                    </p:spPr>
-                  </p:pic>
-                </p:oleObj>
-              </mc:Fallback>
-            </mc:AlternateContent>
-          </a:graphicData>
-        </a:graphic>
-      </p:graphicFrame>
       <p:sp>
         <p:nvSpPr>
           <p:cNvPr id="2" name="TextBox 1"/>
@@ -25428,6 +24543,68 @@
                 </a:solidFill>
               </a:rPr>
               <a:t>Group Work</a:t>
+            </a:r>
+          </a:p>
+        </p:txBody>
+      </p:sp>
+      <p:sp>
+        <p:nvSpPr>
+          <p:cNvPr id="285701" name="TextBox 285700"/>
+          <p:cNvSpPr txBox="1"/>
+          <p:nvPr/>
+        </p:nvSpPr>
+        <p:spPr>
+          <a:xfrm>
+            <a:off x="5181601" y="2761264"/>
+            <a:ext cx="1571625" cy="412750"/>
+          </a:xfrm>
+          <a:prstGeom prst="rect">
+            <a:avLst/>
+          </a:prstGeom>
+          <a:noFill/>
+        </p:spPr>
+        <p:txBody>
+          <a:bodyPr wrap="square" anchor="ctr" lIns="0" rIns="0" tIns="0" bIns="0">
+            <a:spAutoFit/>
+          </a:bodyPr>
+          <a:lstStyle/>
+          <a:p>
+            <a:r>
+              <a:rPr sz="2000">
+                <a:latin typeface="Cambria"/>
+              </a:rPr>
+              <a:t>Z ~ U(a, b)</a:t>
+            </a:r>
+          </a:p>
+        </p:txBody>
+      </p:sp>
+      <p:sp>
+        <p:nvSpPr>
+          <p:cNvPr id="285702" name="TextBox 285701"/>
+          <p:cNvSpPr txBox="1"/>
+          <p:nvPr/>
+        </p:nvSpPr>
+        <p:spPr>
+          <a:xfrm>
+            <a:off x="5155069" y="4324092"/>
+            <a:ext cx="2532184" cy="787400"/>
+          </a:xfrm>
+          <a:prstGeom prst="rect">
+            <a:avLst/>
+          </a:prstGeom>
+          <a:noFill/>
+        </p:spPr>
+        <p:txBody>
+          <a:bodyPr wrap="square" anchor="ctr" lIns="0" rIns="0" tIns="0" bIns="0">
+            <a:spAutoFit/>
+          </a:bodyPr>
+          <a:lstStyle/>
+          <a:p>
+            <a:r>
+              <a:rPr sz="1900">
+                <a:latin typeface="Cambria"/>
+              </a:rPr>
+              <a:t>f(x) = 1 / (b − a)</a:t>
             </a:r>
           </a:p>
         </p:txBody>
@@ -25570,111 +24747,6 @@
           </a:p>
         </p:txBody>
       </p:sp>
-      <p:graphicFrame>
-        <p:nvGraphicFramePr>
-          <p:cNvPr id="5" name="Object 6">
-            <a:extLst>
-              <a:ext uri="{FF2B5EF4-FFF2-40B4-BE49-F238E27FC236}">
-                <a16:creationId xmlns:a16="http://schemas.microsoft.com/office/drawing/2014/main" id="{B06D115A-8E44-E087-E6DD-61D636020508}"/>
-              </a:ext>
-            </a:extLst>
-          </p:cNvPr>
-          <p:cNvGraphicFramePr>
-            <a:graphicFrameLocks noChangeAspect="1"/>
-          </p:cNvGraphicFramePr>
-          <p:nvPr>
-            <p:extLst>
-              <p:ext uri="{D42A27DB-BD31-4B8C-83A1-F6EECF244321}">
-                <p14:modId xmlns:p14="http://schemas.microsoft.com/office/powerpoint/2010/main" val="4063655564"/>
-              </p:ext>
-            </p:extLst>
-          </p:nvPr>
-        </p:nvGraphicFramePr>
-        <p:xfrm>
-          <a:off x="5494401" y="1275443"/>
-          <a:ext cx="1600200" cy="787400"/>
-        </p:xfrm>
-        <a:graphic>
-          <a:graphicData uri="http://schemas.openxmlformats.org/presentationml/2006/ole">
-            <mc:AlternateContent xmlns:mc="http://schemas.openxmlformats.org/markup-compatibility/2006">
-              <mc:Choice xmlns:v="urn:schemas-microsoft-com:vml" Requires="v">
-                <p:oleObj name="Equation" r:id="rId3" imgW="799753" imgH="393529" progId="Equation.DSMT4">
-                  <p:embed/>
-                </p:oleObj>
-              </mc:Choice>
-              <mc:Fallback>
-                <p:oleObj name="Equation" r:id="rId3" imgW="799753" imgH="393529" progId="Equation.DSMT4">
-                  <p:embed/>
-                  <p:pic>
-                    <p:nvPicPr>
-                      <p:cNvPr id="285700" name="Object 6"/>
-                      <p:cNvPicPr>
-                        <a:picLocks noChangeAspect="1" noChangeArrowheads="1"/>
-                      </p:cNvPicPr>
-                      <p:nvPr/>
-                    </p:nvPicPr>
-                    <p:blipFill>
-                      <a:blip r:embed="rId4">
-                        <a:extLst>
-                          <a:ext uri="{28A0092B-C50C-407E-A947-70E740481C1C}">
-                            <a14:useLocalDpi xmlns:a14="http://schemas.microsoft.com/office/drawing/2010/main" val="0"/>
-                          </a:ext>
-                        </a:extLst>
-                      </a:blip>
-                      <a:srcRect/>
-                      <a:stretch>
-                        <a:fillRect/>
-                      </a:stretch>
-                    </p:blipFill>
-                    <p:spPr bwMode="auto">
-                      <a:xfrm>
-                        <a:off x="5494401" y="1275443"/>
-                        <a:ext cx="1600200" cy="787400"/>
-                      </a:xfrm>
-                      <a:prstGeom prst="rect">
-                        <a:avLst/>
-                      </a:prstGeom>
-                      <a:noFill/>
-                      <a:ln>
-                        <a:noFill/>
-                      </a:ln>
-                      <a:effectLst/>
-                      <a:extLst>
-                        <a:ext uri="{909E8E84-426E-40DD-AFC4-6F175D3DCCD1}">
-                          <a14:hiddenFill xmlns:a14="http://schemas.microsoft.com/office/drawing/2010/main">
-                            <a:solidFill>
-                              <a:srgbClr val="FFFFFF"/>
-                            </a:solidFill>
-                          </a14:hiddenFill>
-                        </a:ext>
-                        <a:ext uri="{91240B29-F687-4F45-9708-019B960494DF}">
-                          <a14:hiddenLine xmlns:a14="http://schemas.microsoft.com/office/drawing/2010/main" w="9525">
-                            <a:solidFill>
-                              <a:srgbClr val="000000"/>
-                            </a:solidFill>
-                            <a:miter lim="800000"/>
-                            <a:headEnd/>
-                            <a:tailEnd/>
-                          </a14:hiddenLine>
-                        </a:ext>
-                        <a:ext uri="{AF507438-7753-43E0-B8FC-AC1667EBCBE1}">
-                          <a14:hiddenEffects xmlns:a14="http://schemas.microsoft.com/office/drawing/2010/main">
-                            <a:effectLst>
-                              <a:outerShdw dist="35921" dir="2700000" algn="ctr" rotWithShape="0">
-                                <a:srgbClr val="808080"/>
-                              </a:outerShdw>
-                            </a:effectLst>
-                          </a14:hiddenEffects>
-                        </a:ext>
-                      </a:extLst>
-                    </p:spPr>
-                  </p:pic>
-                </p:oleObj>
-              </mc:Fallback>
-            </mc:AlternateContent>
-          </a:graphicData>
-        </a:graphic>
-      </p:graphicFrame>
       <p:sp>
         <p:nvSpPr>
           <p:cNvPr id="6" name="TextBox 5">
@@ -25776,6 +24848,37 @@
             <a:r>
               <a:rPr lang="en-US" sz="4400" dirty="0"/>
               <a:t>2</a:t>
+            </a:r>
+          </a:p>
+        </p:txBody>
+      </p:sp>
+      <p:sp>
+        <p:nvSpPr>
+          <p:cNvPr id="16388" name="TextBox 16387"/>
+          <p:cNvSpPr txBox="1"/>
+          <p:nvPr/>
+        </p:nvSpPr>
+        <p:spPr>
+          <a:xfrm>
+            <a:off x="5494401" y="1275443"/>
+            <a:ext cx="2532184" cy="787400"/>
+          </a:xfrm>
+          <a:prstGeom prst="rect">
+            <a:avLst/>
+          </a:prstGeom>
+          <a:noFill/>
+        </p:spPr>
+        <p:txBody>
+          <a:bodyPr wrap="square" anchor="ctr" lIns="0" rIns="0" tIns="0" bIns="0">
+            <a:spAutoFit/>
+          </a:bodyPr>
+          <a:lstStyle/>
+          <a:p>
+            <a:r>
+              <a:rPr sz="1900">
+                <a:latin typeface="Cambria"/>
+              </a:rPr>
+              <a:t>f(x) = 1 / (b − a)</a:t>
             </a:r>
           </a:p>
         </p:txBody>

</xml_diff>

<commit_message>
Taal's revisions to the accessible decks
Author's own edits to all nine accessible decks (Day 1-5), committed as received.

Co-Authored-By: Claude Opus 4.8 <noreply@anthropic.com>
</commit_message>
<xml_diff>
--- a/Day2_GLM/FW536_Day2_Morning_ContinuousDistributions_accessible.pptx
+++ b/Day2_GLM/FW536_Day2_Morning_ContinuousDistributions_accessible.pptx
@@ -242,7 +242,7 @@
           <a:p>
             <a:fld id="{C351D292-065C-2343-A862-C3123D0BAE44}" type="datetimeFigureOut">
               <a:rPr lang="en-US" smtClean="0"/>
-              <a:t>9/19/25</a:t>
+              <a:t>7/16/26</a:t>
             </a:fld>
             <a:endParaRPr lang="en-US"/>
           </a:p>
@@ -564,7 +564,7 @@
               </a14:hiddenEffects>
             </a:ext>
             <a:ext uri="{FAA26D3D-D897-4be2-8F04-BA451C77F1D7}">
-              <ma14:placeholderFlag xmlns="" xmlns:ma14="http://schemas.microsoft.com/office/mac/drawingml/2011/main" val="1"/>
+              <ma14:placeholderFlag xmlns:ma14="http://schemas.microsoft.com/office/mac/drawingml/2011/main" xmlns="" val="1"/>
             </a:ext>
           </a:extLst>
         </p:spPr>
@@ -649,7 +649,7 @@
               </a14:hiddenEffects>
             </a:ext>
             <a:ext uri="{FAA26D3D-D897-4be2-8F04-BA451C77F1D7}">
-              <ma14:placeholderFlag xmlns="" xmlns:ma14="http://schemas.microsoft.com/office/mac/drawingml/2011/main" val="1"/>
+              <ma14:placeholderFlag xmlns:ma14="http://schemas.microsoft.com/office/mac/drawingml/2011/main" xmlns="" val="1"/>
             </a:ext>
           </a:extLst>
         </p:spPr>
@@ -734,7 +734,7 @@
               </a14:hiddenEffects>
             </a:ext>
             <a:ext uri="{FAA26D3D-D897-4be2-8F04-BA451C77F1D7}">
-              <ma14:placeholderFlag xmlns="" xmlns:ma14="http://schemas.microsoft.com/office/mac/drawingml/2011/main" val="1"/>
+              <ma14:placeholderFlag xmlns:ma14="http://schemas.microsoft.com/office/mac/drawingml/2011/main" xmlns="" val="1"/>
             </a:ext>
           </a:extLst>
         </p:spPr>
@@ -819,7 +819,7 @@
               </a14:hiddenEffects>
             </a:ext>
             <a:ext uri="{FAA26D3D-D897-4be2-8F04-BA451C77F1D7}">
-              <ma14:placeholderFlag xmlns="" xmlns:ma14="http://schemas.microsoft.com/office/mac/drawingml/2011/main" val="1"/>
+              <ma14:placeholderFlag xmlns:ma14="http://schemas.microsoft.com/office/mac/drawingml/2011/main" xmlns="" val="1"/>
             </a:ext>
           </a:extLst>
         </p:spPr>
@@ -904,7 +904,7 @@
               </a14:hiddenEffects>
             </a:ext>
             <a:ext uri="{FAA26D3D-D897-4be2-8F04-BA451C77F1D7}">
-              <ma14:placeholderFlag xmlns="" xmlns:ma14="http://schemas.microsoft.com/office/mac/drawingml/2011/main" val="1"/>
+              <ma14:placeholderFlag xmlns:ma14="http://schemas.microsoft.com/office/mac/drawingml/2011/main" xmlns="" val="1"/>
             </a:ext>
           </a:extLst>
         </p:spPr>
@@ -989,7 +989,7 @@
               </a14:hiddenEffects>
             </a:ext>
             <a:ext uri="{FAA26D3D-D897-4be2-8F04-BA451C77F1D7}">
-              <ma14:placeholderFlag xmlns="" xmlns:ma14="http://schemas.microsoft.com/office/mac/drawingml/2011/main" val="1"/>
+              <ma14:placeholderFlag xmlns:ma14="http://schemas.microsoft.com/office/mac/drawingml/2011/main" xmlns="" val="1"/>
             </a:ext>
           </a:extLst>
         </p:spPr>
@@ -1074,7 +1074,7 @@
               </a14:hiddenEffects>
             </a:ext>
             <a:ext uri="{FAA26D3D-D897-4be2-8F04-BA451C77F1D7}">
-              <ma14:placeholderFlag xmlns="" xmlns:ma14="http://schemas.microsoft.com/office/mac/drawingml/2011/main" val="1"/>
+              <ma14:placeholderFlag xmlns:ma14="http://schemas.microsoft.com/office/mac/drawingml/2011/main" xmlns="" val="1"/>
             </a:ext>
           </a:extLst>
         </p:spPr>
@@ -1159,7 +1159,7 @@
               </a14:hiddenEffects>
             </a:ext>
             <a:ext uri="{FAA26D3D-D897-4be2-8F04-BA451C77F1D7}">
-              <ma14:placeholderFlag xmlns="" xmlns:ma14="http://schemas.microsoft.com/office/mac/drawingml/2011/main" val="1"/>
+              <ma14:placeholderFlag xmlns:ma14="http://schemas.microsoft.com/office/mac/drawingml/2011/main" xmlns="" val="1"/>
             </a:ext>
           </a:extLst>
         </p:spPr>
@@ -1244,7 +1244,7 @@
               </a14:hiddenEffects>
             </a:ext>
             <a:ext uri="{FAA26D3D-D897-4be2-8F04-BA451C77F1D7}">
-              <ma14:placeholderFlag xmlns="" xmlns:ma14="http://schemas.microsoft.com/office/mac/drawingml/2011/main" val="1"/>
+              <ma14:placeholderFlag xmlns:ma14="http://schemas.microsoft.com/office/mac/drawingml/2011/main" xmlns="" val="1"/>
             </a:ext>
           </a:extLst>
         </p:spPr>
@@ -1329,7 +1329,7 @@
               </a14:hiddenEffects>
             </a:ext>
             <a:ext uri="{FAA26D3D-D897-4be2-8F04-BA451C77F1D7}">
-              <ma14:placeholderFlag xmlns="" xmlns:ma14="http://schemas.microsoft.com/office/mac/drawingml/2011/main" val="1"/>
+              <ma14:placeholderFlag xmlns:ma14="http://schemas.microsoft.com/office/mac/drawingml/2011/main" xmlns="" val="1"/>
             </a:ext>
           </a:extLst>
         </p:spPr>
@@ -1414,7 +1414,7 @@
               </a14:hiddenEffects>
             </a:ext>
             <a:ext uri="{FAA26D3D-D897-4be2-8F04-BA451C77F1D7}">
-              <ma14:placeholderFlag xmlns="" xmlns:ma14="http://schemas.microsoft.com/office/mac/drawingml/2011/main" val="1"/>
+              <ma14:placeholderFlag xmlns:ma14="http://schemas.microsoft.com/office/mac/drawingml/2011/main" xmlns="" val="1"/>
             </a:ext>
           </a:extLst>
         </p:spPr>
@@ -1566,7 +1566,7 @@
               </a14:hiddenEffects>
             </a:ext>
             <a:ext uri="{FAA26D3D-D897-4be2-8F04-BA451C77F1D7}">
-              <ma14:placeholderFlag xmlns="" xmlns:ma14="http://schemas.microsoft.com/office/mac/drawingml/2011/main" val="1"/>
+              <ma14:placeholderFlag xmlns:ma14="http://schemas.microsoft.com/office/mac/drawingml/2011/main" xmlns="" val="1"/>
             </a:ext>
           </a:extLst>
         </p:spPr>
@@ -1651,7 +1651,7 @@
               </a14:hiddenEffects>
             </a:ext>
             <a:ext uri="{FAA26D3D-D897-4be2-8F04-BA451C77F1D7}">
-              <ma14:placeholderFlag xmlns="" xmlns:ma14="http://schemas.microsoft.com/office/mac/drawingml/2011/main" val="1"/>
+              <ma14:placeholderFlag xmlns:ma14="http://schemas.microsoft.com/office/mac/drawingml/2011/main" xmlns="" val="1"/>
             </a:ext>
           </a:extLst>
         </p:spPr>
@@ -1736,7 +1736,7 @@
               </a14:hiddenEffects>
             </a:ext>
             <a:ext uri="{FAA26D3D-D897-4be2-8F04-BA451C77F1D7}">
-              <ma14:placeholderFlag xmlns="" xmlns:ma14="http://schemas.microsoft.com/office/mac/drawingml/2011/main" val="1"/>
+              <ma14:placeholderFlag xmlns:ma14="http://schemas.microsoft.com/office/mac/drawingml/2011/main" xmlns="" val="1"/>
             </a:ext>
           </a:extLst>
         </p:spPr>
@@ -1821,7 +1821,7 @@
               </a14:hiddenEffects>
             </a:ext>
             <a:ext uri="{FAA26D3D-D897-4be2-8F04-BA451C77F1D7}">
-              <ma14:placeholderFlag xmlns="" xmlns:ma14="http://schemas.microsoft.com/office/mac/drawingml/2011/main" val="1"/>
+              <ma14:placeholderFlag xmlns:ma14="http://schemas.microsoft.com/office/mac/drawingml/2011/main" xmlns="" val="1"/>
             </a:ext>
           </a:extLst>
         </p:spPr>
@@ -1906,7 +1906,7 @@
               </a14:hiddenEffects>
             </a:ext>
             <a:ext uri="{FAA26D3D-D897-4be2-8F04-BA451C77F1D7}">
-              <ma14:placeholderFlag xmlns="" xmlns:ma14="http://schemas.microsoft.com/office/mac/drawingml/2011/main" val="1"/>
+              <ma14:placeholderFlag xmlns:ma14="http://schemas.microsoft.com/office/mac/drawingml/2011/main" xmlns="" val="1"/>
             </a:ext>
           </a:extLst>
         </p:spPr>
@@ -1991,7 +1991,7 @@
               </a14:hiddenEffects>
             </a:ext>
             <a:ext uri="{FAA26D3D-D897-4be2-8F04-BA451C77F1D7}">
-              <ma14:placeholderFlag xmlns="" xmlns:ma14="http://schemas.microsoft.com/office/mac/drawingml/2011/main" val="1"/>
+              <ma14:placeholderFlag xmlns:ma14="http://schemas.microsoft.com/office/mac/drawingml/2011/main" xmlns="" val="1"/>
             </a:ext>
           </a:extLst>
         </p:spPr>
@@ -2076,7 +2076,7 @@
               </a14:hiddenEffects>
             </a:ext>
             <a:ext uri="{FAA26D3D-D897-4be2-8F04-BA451C77F1D7}">
-              <ma14:placeholderFlag xmlns="" xmlns:ma14="http://schemas.microsoft.com/office/mac/drawingml/2011/main" val="1"/>
+              <ma14:placeholderFlag xmlns:ma14="http://schemas.microsoft.com/office/mac/drawingml/2011/main" xmlns="" val="1"/>
             </a:ext>
           </a:extLst>
         </p:spPr>
@@ -2161,7 +2161,7 @@
               </a14:hiddenEffects>
             </a:ext>
             <a:ext uri="{FAA26D3D-D897-4be2-8F04-BA451C77F1D7}">
-              <ma14:placeholderFlag xmlns="" xmlns:ma14="http://schemas.microsoft.com/office/mac/drawingml/2011/main" val="1"/>
+              <ma14:placeholderFlag xmlns:ma14="http://schemas.microsoft.com/office/mac/drawingml/2011/main" xmlns="" val="1"/>
             </a:ext>
           </a:extLst>
         </p:spPr>
@@ -2247,7 +2247,7 @@
               </a14:hiddenEffects>
             </a:ext>
             <a:ext uri="{FAA26D3D-D897-4be2-8F04-BA451C77F1D7}">
-              <ma14:placeholderFlag xmlns="" xmlns:ma14="http://schemas.microsoft.com/office/mac/drawingml/2011/main" val="1"/>
+              <ma14:placeholderFlag xmlns:ma14="http://schemas.microsoft.com/office/mac/drawingml/2011/main" xmlns="" val="1"/>
             </a:ext>
           </a:extLst>
         </p:spPr>
@@ -2330,7 +2330,7 @@
               </a14:hiddenEffects>
             </a:ext>
             <a:ext uri="{FAA26D3D-D897-4be2-8F04-BA451C77F1D7}">
-              <ma14:placeholderFlag xmlns="" xmlns:ma14="http://schemas.microsoft.com/office/mac/drawingml/2011/main" val="1"/>
+              <ma14:placeholderFlag xmlns:ma14="http://schemas.microsoft.com/office/mac/drawingml/2011/main" xmlns="" val="1"/>
             </a:ext>
           </a:extLst>
         </p:spPr>
@@ -2430,7 +2430,7 @@
               </a14:hiddenEffects>
             </a:ext>
             <a:ext uri="{FAA26D3D-D897-4be2-8F04-BA451C77F1D7}">
-              <ma14:placeholderFlag xmlns="" xmlns:ma14="http://schemas.microsoft.com/office/mac/drawingml/2011/main" val="1"/>
+              <ma14:placeholderFlag xmlns:ma14="http://schemas.microsoft.com/office/mac/drawingml/2011/main" xmlns="" val="1"/>
             </a:ext>
           </a:extLst>
         </p:spPr>
@@ -2516,7 +2516,7 @@
               </a14:hiddenEffects>
             </a:ext>
             <a:ext uri="{FAA26D3D-D897-4be2-8F04-BA451C77F1D7}">
-              <ma14:placeholderFlag xmlns="" xmlns:ma14="http://schemas.microsoft.com/office/mac/drawingml/2011/main" val="1"/>
+              <ma14:placeholderFlag xmlns:ma14="http://schemas.microsoft.com/office/mac/drawingml/2011/main" xmlns="" val="1"/>
             </a:ext>
           </a:extLst>
         </p:spPr>
@@ -2599,7 +2599,7 @@
               </a14:hiddenEffects>
             </a:ext>
             <a:ext uri="{FAA26D3D-D897-4be2-8F04-BA451C77F1D7}">
-              <ma14:placeholderFlag xmlns="" xmlns:ma14="http://schemas.microsoft.com/office/mac/drawingml/2011/main" val="1"/>
+              <ma14:placeholderFlag xmlns:ma14="http://schemas.microsoft.com/office/mac/drawingml/2011/main" xmlns="" val="1"/>
             </a:ext>
           </a:extLst>
         </p:spPr>
@@ -2681,7 +2681,7 @@
               </a14:hiddenEffects>
             </a:ext>
             <a:ext uri="{FAA26D3D-D897-4be2-8F04-BA451C77F1D7}">
-              <ma14:placeholderFlag xmlns="" xmlns:ma14="http://schemas.microsoft.com/office/mac/drawingml/2011/main" val="1"/>
+              <ma14:placeholderFlag xmlns:ma14="http://schemas.microsoft.com/office/mac/drawingml/2011/main" xmlns="" val="1"/>
             </a:ext>
           </a:extLst>
         </p:spPr>
@@ -2766,7 +2766,7 @@
               </a14:hiddenEffects>
             </a:ext>
             <a:ext uri="{FAA26D3D-D897-4be2-8F04-BA451C77F1D7}">
-              <ma14:placeholderFlag xmlns="" xmlns:ma14="http://schemas.microsoft.com/office/mac/drawingml/2011/main" val="1"/>
+              <ma14:placeholderFlag xmlns:ma14="http://schemas.microsoft.com/office/mac/drawingml/2011/main" xmlns="" val="1"/>
             </a:ext>
           </a:extLst>
         </p:spPr>
@@ -2851,7 +2851,7 @@
               </a14:hiddenEffects>
             </a:ext>
             <a:ext uri="{FAA26D3D-D897-4be2-8F04-BA451C77F1D7}">
-              <ma14:placeholderFlag xmlns="" xmlns:ma14="http://schemas.microsoft.com/office/mac/drawingml/2011/main" val="1"/>
+              <ma14:placeholderFlag xmlns:ma14="http://schemas.microsoft.com/office/mac/drawingml/2011/main" xmlns="" val="1"/>
             </a:ext>
           </a:extLst>
         </p:spPr>
@@ -2936,7 +2936,7 @@
               </a14:hiddenEffects>
             </a:ext>
             <a:ext uri="{FAA26D3D-D897-4be2-8F04-BA451C77F1D7}">
-              <ma14:placeholderFlag xmlns="" xmlns:ma14="http://schemas.microsoft.com/office/mac/drawingml/2011/main" val="1"/>
+              <ma14:placeholderFlag xmlns:ma14="http://schemas.microsoft.com/office/mac/drawingml/2011/main" xmlns="" val="1"/>
             </a:ext>
           </a:extLst>
         </p:spPr>
@@ -3021,7 +3021,7 @@
               </a14:hiddenEffects>
             </a:ext>
             <a:ext uri="{FAA26D3D-D897-4be2-8F04-BA451C77F1D7}">
-              <ma14:placeholderFlag xmlns="" xmlns:ma14="http://schemas.microsoft.com/office/mac/drawingml/2011/main" val="1"/>
+              <ma14:placeholderFlag xmlns:ma14="http://schemas.microsoft.com/office/mac/drawingml/2011/main" xmlns="" val="1"/>
             </a:ext>
           </a:extLst>
         </p:spPr>
@@ -3106,7 +3106,7 @@
               </a14:hiddenEffects>
             </a:ext>
             <a:ext uri="{FAA26D3D-D897-4be2-8F04-BA451C77F1D7}">
-              <ma14:placeholderFlag xmlns="" xmlns:ma14="http://schemas.microsoft.com/office/mac/drawingml/2011/main" val="1"/>
+              <ma14:placeholderFlag xmlns:ma14="http://schemas.microsoft.com/office/mac/drawingml/2011/main" xmlns="" val="1"/>
             </a:ext>
           </a:extLst>
         </p:spPr>
@@ -3191,7 +3191,7 @@
               </a14:hiddenEffects>
             </a:ext>
             <a:ext uri="{FAA26D3D-D897-4be2-8F04-BA451C77F1D7}">
-              <ma14:placeholderFlag xmlns="" xmlns:ma14="http://schemas.microsoft.com/office/mac/drawingml/2011/main" val="1"/>
+              <ma14:placeholderFlag xmlns:ma14="http://schemas.microsoft.com/office/mac/drawingml/2011/main" xmlns="" val="1"/>
             </a:ext>
           </a:extLst>
         </p:spPr>
@@ -3410,7 +3410,7 @@
               </a14:hiddenEffects>
             </a:ext>
             <a:ext uri="{FAA26D3D-D897-4be2-8F04-BA451C77F1D7}">
-              <ma14:placeholderFlag xmlns="" xmlns:ma14="http://schemas.microsoft.com/office/mac/drawingml/2011/main" val="1"/>
+              <ma14:placeholderFlag xmlns:ma14="http://schemas.microsoft.com/office/mac/drawingml/2011/main" xmlns="" val="1"/>
             </a:ext>
           </a:extLst>
         </p:spPr>
@@ -3495,7 +3495,7 @@
               </a14:hiddenEffects>
             </a:ext>
             <a:ext uri="{FAA26D3D-D897-4be2-8F04-BA451C77F1D7}">
-              <ma14:placeholderFlag xmlns="" xmlns:ma14="http://schemas.microsoft.com/office/mac/drawingml/2011/main" val="1"/>
+              <ma14:placeholderFlag xmlns:ma14="http://schemas.microsoft.com/office/mac/drawingml/2011/main" xmlns="" val="1"/>
             </a:ext>
           </a:extLst>
         </p:spPr>
@@ -3580,7 +3580,7 @@
               </a14:hiddenEffects>
             </a:ext>
             <a:ext uri="{FAA26D3D-D897-4be2-8F04-BA451C77F1D7}">
-              <ma14:placeholderFlag xmlns="" xmlns:ma14="http://schemas.microsoft.com/office/mac/drawingml/2011/main" val="1"/>
+              <ma14:placeholderFlag xmlns:ma14="http://schemas.microsoft.com/office/mac/drawingml/2011/main" xmlns="" val="1"/>
             </a:ext>
           </a:extLst>
         </p:spPr>
@@ -3665,7 +3665,7 @@
               </a14:hiddenEffects>
             </a:ext>
             <a:ext uri="{FAA26D3D-D897-4be2-8F04-BA451C77F1D7}">
-              <ma14:placeholderFlag xmlns="" xmlns:ma14="http://schemas.microsoft.com/office/mac/drawingml/2011/main" val="1"/>
+              <ma14:placeholderFlag xmlns:ma14="http://schemas.microsoft.com/office/mac/drawingml/2011/main" xmlns="" val="1"/>
             </a:ext>
           </a:extLst>
         </p:spPr>
@@ -3824,7 +3824,7 @@
           <a:p>
             <a:fld id="{87F5D5F2-6686-074E-AD7B-BFEFAC97C37F}" type="datetimeFigureOut">
               <a:rPr lang="en-US" smtClean="0"/>
-              <a:t>9/19/25</a:t>
+              <a:t>7/16/26</a:t>
             </a:fld>
             <a:endParaRPr lang="en-US"/>
           </a:p>
@@ -3992,7 +3992,7 @@
           <a:p>
             <a:fld id="{87F5D5F2-6686-074E-AD7B-BFEFAC97C37F}" type="datetimeFigureOut">
               <a:rPr lang="en-US" smtClean="0"/>
-              <a:t>9/19/25</a:t>
+              <a:t>7/16/26</a:t>
             </a:fld>
             <a:endParaRPr lang="en-US"/>
           </a:p>
@@ -4170,7 +4170,7 @@
           <a:p>
             <a:fld id="{87F5D5F2-6686-074E-AD7B-BFEFAC97C37F}" type="datetimeFigureOut">
               <a:rPr lang="en-US" smtClean="0"/>
-              <a:t>9/19/25</a:t>
+              <a:t>7/16/26</a:t>
             </a:fld>
             <a:endParaRPr lang="en-US"/>
           </a:p>
@@ -4921,7 +4921,7 @@
           <a:p>
             <a:fld id="{87F5D5F2-6686-074E-AD7B-BFEFAC97C37F}" type="datetimeFigureOut">
               <a:rPr lang="en-US" smtClean="0"/>
-              <a:t>9/19/25</a:t>
+              <a:t>7/16/26</a:t>
             </a:fld>
             <a:endParaRPr lang="en-US"/>
           </a:p>
@@ -5166,7 +5166,7 @@
           <a:p>
             <a:fld id="{87F5D5F2-6686-074E-AD7B-BFEFAC97C37F}" type="datetimeFigureOut">
               <a:rPr lang="en-US" smtClean="0"/>
-              <a:t>9/19/25</a:t>
+              <a:t>7/16/26</a:t>
             </a:fld>
             <a:endParaRPr lang="en-US"/>
           </a:p>
@@ -5395,7 +5395,7 @@
           <a:p>
             <a:fld id="{87F5D5F2-6686-074E-AD7B-BFEFAC97C37F}" type="datetimeFigureOut">
               <a:rPr lang="en-US" smtClean="0"/>
-              <a:t>9/19/25</a:t>
+              <a:t>7/16/26</a:t>
             </a:fld>
             <a:endParaRPr lang="en-US"/>
           </a:p>
@@ -5759,7 +5759,7 @@
           <a:p>
             <a:fld id="{87F5D5F2-6686-074E-AD7B-BFEFAC97C37F}" type="datetimeFigureOut">
               <a:rPr lang="en-US" smtClean="0"/>
-              <a:t>9/19/25</a:t>
+              <a:t>7/16/26</a:t>
             </a:fld>
             <a:endParaRPr lang="en-US"/>
           </a:p>
@@ -5876,7 +5876,7 @@
           <a:p>
             <a:fld id="{87F5D5F2-6686-074E-AD7B-BFEFAC97C37F}" type="datetimeFigureOut">
               <a:rPr lang="en-US" smtClean="0"/>
-              <a:t>9/19/25</a:t>
+              <a:t>7/16/26</a:t>
             </a:fld>
             <a:endParaRPr lang="en-US"/>
           </a:p>
@@ -5971,7 +5971,7 @@
           <a:p>
             <a:fld id="{87F5D5F2-6686-074E-AD7B-BFEFAC97C37F}" type="datetimeFigureOut">
               <a:rPr lang="en-US" smtClean="0"/>
-              <a:t>9/19/25</a:t>
+              <a:t>7/16/26</a:t>
             </a:fld>
             <a:endParaRPr lang="en-US"/>
           </a:p>
@@ -6246,7 +6246,7 @@
           <a:p>
             <a:fld id="{87F5D5F2-6686-074E-AD7B-BFEFAC97C37F}" type="datetimeFigureOut">
               <a:rPr lang="en-US" smtClean="0"/>
-              <a:t>9/19/25</a:t>
+              <a:t>7/16/26</a:t>
             </a:fld>
             <a:endParaRPr lang="en-US"/>
           </a:p>
@@ -6498,7 +6498,7 @@
           <a:p>
             <a:fld id="{87F5D5F2-6686-074E-AD7B-BFEFAC97C37F}" type="datetimeFigureOut">
               <a:rPr lang="en-US" smtClean="0"/>
-              <a:t>9/19/25</a:t>
+              <a:t>7/16/26</a:t>
             </a:fld>
             <a:endParaRPr lang="en-US"/>
           </a:p>
@@ -6709,7 +6709,7 @@
           <a:p>
             <a:fld id="{87F5D5F2-6686-074E-AD7B-BFEFAC97C37F}" type="datetimeFigureOut">
               <a:rPr lang="en-US" smtClean="0"/>
-              <a:t>9/19/25</a:t>
+              <a:t>7/16/26</a:t>
             </a:fld>
             <a:endParaRPr lang="en-US"/>
           </a:p>
@@ -9444,11 +9444,7 @@
             </a:r>
             <a:r>
               <a:rPr lang="en-US" altLang="en-US" dirty="0"/>
-              <a:t> is normally distributed with mean </a:t>
-            </a:r>
-            <a:r>
-              <a:rPr lang="en-US" altLang="en-US" dirty="0"/>
-              <a:t>μ and standard deviation σ</a:t>
+              <a:t> is normally distributed with mean μ and standard deviation σ</a:t>
             </a:r>
           </a:p>
           <a:p>
@@ -9572,8 +9568,8 @@
         </p:nvSpPr>
         <p:spPr>
           <a:xfrm>
-            <a:off x="4752976" y="2058757"/>
-            <a:ext cx="1688123" cy="411162"/>
+            <a:off x="4752976" y="2079672"/>
+            <a:ext cx="1688123" cy="369332"/>
           </a:xfrm>
           <a:prstGeom prst="rect">
             <a:avLst/>
@@ -9581,25 +9577,37 @@
           <a:noFill/>
         </p:spPr>
         <p:txBody>
-          <a:bodyPr wrap="square" anchor="ctr" lIns="0" rIns="0" tIns="0" bIns="0">
+          <a:bodyPr wrap="square" lIns="0" tIns="0" rIns="0" bIns="0" anchor="ctr">
             <a:spAutoFit/>
           </a:bodyPr>
           <a:lstStyle/>
           <a:p>
             <a:r>
-              <a:rPr sz="1900">
+              <a:rPr sz="2400" dirty="0">
                 <a:latin typeface="Cambria"/>
               </a:rPr>
-              <a:t>X ~ N(μ, σ</a:t>
-            </a:r>
-            <a:r>
-              <a:rPr sz="1900" baseline="30000">
+              <a:t>X ~ N(</a:t>
+            </a:r>
+            <a:r>
+              <a:rPr sz="2400" dirty="0" err="1">
+                <a:latin typeface="Cambria"/>
+              </a:rPr>
+              <a:t>μ</a:t>
+            </a:r>
+            <a:r>
+              <a:rPr sz="2400" dirty="0">
+                <a:latin typeface="Cambria"/>
+              </a:rPr>
+              <a:t>, σ</a:t>
+            </a:r>
+            <a:r>
+              <a:rPr sz="2400" baseline="30000" dirty="0">
                 <a:latin typeface="Cambria"/>
               </a:rPr>
               <a:t>2</a:t>
             </a:r>
             <a:r>
-              <a:rPr sz="1900">
+              <a:rPr sz="2400" dirty="0">
                 <a:latin typeface="Cambria"/>
               </a:rPr>
               <a:t>)</a:t>
@@ -9615,8 +9623,8 @@
         </p:nvSpPr>
         <p:spPr>
           <a:xfrm>
-            <a:off x="4738766" y="4245847"/>
-            <a:ext cx="6611815" cy="995362"/>
+            <a:off x="4738766" y="4558862"/>
+            <a:ext cx="6611815" cy="369332"/>
           </a:xfrm>
           <a:prstGeom prst="rect">
             <a:avLst/>
@@ -9624,37 +9632,37 @@
           <a:noFill/>
         </p:spPr>
         <p:txBody>
-          <a:bodyPr wrap="square" anchor="ctr" lIns="0" rIns="0" tIns="0" bIns="0">
+          <a:bodyPr wrap="square" lIns="0" tIns="0" rIns="0" bIns="0" anchor="ctr">
             <a:spAutoFit/>
           </a:bodyPr>
           <a:lstStyle/>
           <a:p>
             <a:r>
-              <a:rPr sz="1900">
+              <a:rPr sz="2400">
                 <a:latin typeface="Cambria"/>
               </a:rPr>
               <a:t>f(x) = 1 / (√(2π) σ) · exp( −(x − μ)</a:t>
             </a:r>
             <a:r>
-              <a:rPr sz="1900" baseline="30000">
+              <a:rPr sz="2400" baseline="30000">
                 <a:latin typeface="Cambria"/>
               </a:rPr>
               <a:t>2</a:t>
             </a:r>
             <a:r>
-              <a:rPr sz="1900">
+              <a:rPr sz="2400">
                 <a:latin typeface="Cambria"/>
               </a:rPr>
               <a:t> / (2σ</a:t>
             </a:r>
             <a:r>
-              <a:rPr sz="1900" baseline="30000">
+              <a:rPr sz="2400" baseline="30000">
                 <a:latin typeface="Cambria"/>
               </a:rPr>
               <a:t>2</a:t>
             </a:r>
             <a:r>
-              <a:rPr sz="1900">
+              <a:rPr sz="2400">
                 <a:latin typeface="Cambria"/>
               </a:rPr>
               <a:t>) )</a:t>
@@ -9672,161 +9680,6 @@
   <p:clrMapOvr>
     <a:masterClrMapping/>
   </p:clrMapOvr>
-  <p:timing>
-    <p:tnLst>
-      <p:par>
-        <p:cTn id="1" dur="indefinite" restart="never" nodeType="tmRoot">
-          <p:childTnLst>
-            <p:seq concurrent="1" nextAc="seek">
-              <p:cTn id="2" dur="indefinite" nodeType="mainSeq">
-                <p:childTnLst>
-                  <p:par>
-                    <p:cTn id="3" fill="hold">
-                      <p:stCondLst>
-                        <p:cond delay="indefinite"/>
-                      </p:stCondLst>
-                      <p:childTnLst>
-                        <p:par>
-                          <p:cTn id="4" fill="hold">
-                            <p:stCondLst>
-                              <p:cond delay="0"/>
-                            </p:stCondLst>
-                            <p:childTnLst>
-                              <p:par>
-                                <p:cTn id="5" presetID="1" presetClass="entr" presetSubtype="0" fill="hold" nodeType="clickEffect">
-                                  <p:stCondLst>
-                                    <p:cond delay="0"/>
-                                  </p:stCondLst>
-                                  <p:childTnLst>
-                                    <p:set>
-                                      <p:cBhvr>
-                                        <p:cTn id="6" dur="1" fill="hold">
-                                          <p:stCondLst>
-                                            <p:cond delay="0"/>
-                                          </p:stCondLst>
-                                        </p:cTn>
-                                        <p:tgtEl>
-                                          <p:spTgt spid="7171">
-                                            <p:txEl>
-                                              <p:pRg st="4" end="4"/>
-                                            </p:txEl>
-                                          </p:spTgt>
-                                        </p:tgtEl>
-                                        <p:attrNameLst>
-                                          <p:attrName>style.visibility</p:attrName>
-                                        </p:attrNameLst>
-                                      </p:cBhvr>
-                                      <p:to>
-                                        <p:strVal val="visible"/>
-                                      </p:to>
-                                    </p:set>
-                                  </p:childTnLst>
-                                </p:cTn>
-                              </p:par>
-                              <p:par>
-                                <p:cTn id="7" presetID="1" presetClass="entr" presetSubtype="0" fill="hold" nodeType="withEffect">
-                                  <p:stCondLst>
-                                    <p:cond delay="0"/>
-                                  </p:stCondLst>
-                                  <p:childTnLst>
-                                    <p:set>
-                                      <p:cBhvr>
-                                        <p:cTn id="8" dur="1" fill="hold">
-                                          <p:stCondLst>
-                                            <p:cond delay="0"/>
-                                          </p:stCondLst>
-                                        </p:cTn>
-                                        <p:tgtEl>
-                                          <p:spTgt spid="238596"/>
-                                        </p:tgtEl>
-                                        <p:attrNameLst>
-                                          <p:attrName>style.visibility</p:attrName>
-                                        </p:attrNameLst>
-                                      </p:cBhvr>
-                                      <p:to>
-                                        <p:strVal val="visible"/>
-                                      </p:to>
-                                    </p:set>
-                                  </p:childTnLst>
-                                </p:cTn>
-                              </p:par>
-                            </p:childTnLst>
-                          </p:cTn>
-                        </p:par>
-                      </p:childTnLst>
-                    </p:cTn>
-                  </p:par>
-                  <p:par>
-                    <p:cTn id="9" fill="hold">
-                      <p:stCondLst>
-                        <p:cond delay="indefinite"/>
-                      </p:stCondLst>
-                      <p:childTnLst>
-                        <p:par>
-                          <p:cTn id="10" fill="hold">
-                            <p:stCondLst>
-                              <p:cond delay="0"/>
-                            </p:stCondLst>
-                            <p:childTnLst>
-                              <p:par>
-                                <p:cTn id="11" presetID="1" presetClass="entr" presetSubtype="0" fill="hold" nodeType="clickEffect">
-                                  <p:stCondLst>
-                                    <p:cond delay="0"/>
-                                  </p:stCondLst>
-                                  <p:childTnLst>
-                                    <p:set>
-                                      <p:cBhvr>
-                                        <p:cTn id="12" dur="1" fill="hold">
-                                          <p:stCondLst>
-                                            <p:cond delay="0"/>
-                                          </p:stCondLst>
-                                        </p:cTn>
-                                        <p:tgtEl>
-                                          <p:spTgt spid="7171">
-                                            <p:txEl>
-                                              <p:pRg st="7" end="7"/>
-                                            </p:txEl>
-                                          </p:spTgt>
-                                        </p:tgtEl>
-                                        <p:attrNameLst>
-                                          <p:attrName>style.visibility</p:attrName>
-                                        </p:attrNameLst>
-                                      </p:cBhvr>
-                                      <p:to>
-                                        <p:strVal val="visible"/>
-                                      </p:to>
-                                    </p:set>
-                                  </p:childTnLst>
-                                </p:cTn>
-                              </p:par>
-                            </p:childTnLst>
-                          </p:cTn>
-                        </p:par>
-                      </p:childTnLst>
-                    </p:cTn>
-                  </p:par>
-                </p:childTnLst>
-              </p:cTn>
-              <p:prevCondLst>
-                <p:cond evt="onPrev" delay="0">
-                  <p:tgtEl>
-                    <p:sldTgt/>
-                  </p:tgtEl>
-                </p:cond>
-              </p:prevCondLst>
-              <p:nextCondLst>
-                <p:cond evt="onNext" delay="0">
-                  <p:tgtEl>
-                    <p:sldTgt/>
-                  </p:tgtEl>
-                </p:cond>
-              </p:nextCondLst>
-            </p:seq>
-          </p:childTnLst>
-        </p:cTn>
-      </p:par>
-    </p:tnLst>
-  </p:timing>
 </p:sld>
 </file>
 
@@ -10218,8 +10071,8 @@
         </p:nvSpPr>
         <p:spPr>
           <a:xfrm>
-            <a:off x="3962400" y="1576388"/>
-            <a:ext cx="2954215" cy="863600"/>
+            <a:off x="3962400" y="1823522"/>
+            <a:ext cx="2954215" cy="369332"/>
           </a:xfrm>
           <a:prstGeom prst="rect">
             <a:avLst/>
@@ -10227,55 +10080,55 @@
           <a:noFill/>
         </p:spPr>
         <p:txBody>
-          <a:bodyPr wrap="square" anchor="ctr" lIns="0" rIns="0" tIns="0" bIns="0">
+          <a:bodyPr wrap="square" lIns="0" tIns="0" rIns="0" bIns="0" anchor="ctr">
             <a:spAutoFit/>
           </a:bodyPr>
           <a:lstStyle/>
           <a:p>
             <a:r>
-              <a:rPr sz="1900" b="0">
+              <a:rPr sz="2400" b="0">
                 <a:latin typeface="Cambria"/>
               </a:rPr>
               <a:t>F</a:t>
             </a:r>
             <a:r>
-              <a:rPr sz="1900" b="0" baseline="-25000">
+              <a:rPr sz="2400" b="0" baseline="-25000">
                 <a:latin typeface="Cambria"/>
               </a:rPr>
               <a:t>X</a:t>
             </a:r>
             <a:r>
-              <a:rPr sz="1900" b="0">
+              <a:rPr sz="2400" b="0">
                 <a:latin typeface="Cambria"/>
               </a:rPr>
               <a:t>(x) = ∫</a:t>
             </a:r>
             <a:r>
-              <a:rPr sz="1900" b="0" baseline="-25000">
+              <a:rPr sz="2400" b="0" baseline="-25000">
                 <a:latin typeface="Cambria"/>
               </a:rPr>
               <a:t>−∞</a:t>
             </a:r>
             <a:r>
-              <a:rPr sz="1900" b="0" baseline="30000">
+              <a:rPr sz="2400" b="0" baseline="30000">
                 <a:latin typeface="Cambria"/>
               </a:rPr>
               <a:t>x</a:t>
             </a:r>
             <a:r>
-              <a:rPr sz="1900" b="0">
+              <a:rPr sz="2400" b="0">
                 <a:latin typeface="Cambria"/>
               </a:rPr>
               <a:t> f</a:t>
             </a:r>
             <a:r>
-              <a:rPr sz="1900" b="0" baseline="-25000">
+              <a:rPr sz="2400" b="0" baseline="-25000">
                 <a:latin typeface="Cambria"/>
               </a:rPr>
               <a:t>X</a:t>
             </a:r>
             <a:r>
-              <a:rPr sz="1900" b="0">
+              <a:rPr sz="2400" b="0">
                 <a:latin typeface="Cambria"/>
               </a:rPr>
               <a:t>(t) dt</a:t>
@@ -10293,130 +10146,6 @@
   <p:clrMapOvr>
     <a:masterClrMapping/>
   </p:clrMapOvr>
-  <p:timing>
-    <p:tnLst>
-      <p:par>
-        <p:cTn id="1" dur="indefinite" restart="never" nodeType="tmRoot">
-          <p:childTnLst>
-            <p:seq concurrent="1" nextAc="seek">
-              <p:cTn id="2" dur="indefinite" nodeType="mainSeq">
-                <p:childTnLst>
-                  <p:par>
-                    <p:cTn id="3" fill="hold" nodeType="clickPar">
-                      <p:stCondLst>
-                        <p:cond delay="indefinite"/>
-                      </p:stCondLst>
-                      <p:childTnLst>
-                        <p:par>
-                          <p:cTn id="4" fill="hold" nodeType="withGroup">
-                            <p:stCondLst>
-                              <p:cond delay="0"/>
-                            </p:stCondLst>
-                            <p:childTnLst>
-                              <p:par>
-                                <p:cTn id="5" presetID="1" presetClass="entr" presetSubtype="0" fill="hold" nodeType="clickEffect">
-                                  <p:stCondLst>
-                                    <p:cond delay="0"/>
-                                  </p:stCondLst>
-                                  <p:childTnLst>
-                                    <p:set>
-                                      <p:cBhvr>
-                                        <p:cTn id="6" dur="1" fill="hold">
-                                          <p:stCondLst>
-                                            <p:cond delay="0"/>
-                                          </p:stCondLst>
-                                        </p:cTn>
-                                        <p:tgtEl>
-                                          <p:spTgt spid="2"/>
-                                        </p:tgtEl>
-                                        <p:attrNameLst>
-                                          <p:attrName>style.visibility</p:attrName>
-                                        </p:attrNameLst>
-                                      </p:cBhvr>
-                                      <p:to>
-                                        <p:strVal val="visible"/>
-                                      </p:to>
-                                    </p:set>
-                                  </p:childTnLst>
-                                </p:cTn>
-                              </p:par>
-                            </p:childTnLst>
-                          </p:cTn>
-                        </p:par>
-                      </p:childTnLst>
-                    </p:cTn>
-                  </p:par>
-                  <p:par>
-                    <p:cTn id="7" fill="hold" nodeType="clickPar">
-                      <p:stCondLst>
-                        <p:cond delay="indefinite"/>
-                      </p:stCondLst>
-                      <p:childTnLst>
-                        <p:par>
-                          <p:cTn id="8" fill="hold" nodeType="withGroup">
-                            <p:stCondLst>
-                              <p:cond delay="0"/>
-                            </p:stCondLst>
-                            <p:childTnLst>
-                              <p:par>
-                                <p:cTn id="9" presetID="1" presetClass="entr" presetSubtype="0" fill="hold" nodeType="clickEffect">
-                                  <p:stCondLst>
-                                    <p:cond delay="0"/>
-                                  </p:stCondLst>
-                                  <p:childTnLst>
-                                    <p:set>
-                                      <p:cBhvr>
-                                        <p:cTn id="10" dur="1" fill="hold">
-                                          <p:stCondLst>
-                                            <p:cond delay="0"/>
-                                          </p:stCondLst>
-                                        </p:cTn>
-                                        <p:tgtEl>
-                                          <p:spTgt spid="8194">
-                                            <p:txEl>
-                                              <p:pRg st="3" end="3"/>
-                                            </p:txEl>
-                                          </p:spTgt>
-                                        </p:tgtEl>
-                                        <p:attrNameLst>
-                                          <p:attrName>style.visibility</p:attrName>
-                                        </p:attrNameLst>
-                                      </p:cBhvr>
-                                      <p:to>
-                                        <p:strVal val="visible"/>
-                                      </p:to>
-                                    </p:set>
-                                  </p:childTnLst>
-                                </p:cTn>
-                              </p:par>
-                            </p:childTnLst>
-                          </p:cTn>
-                        </p:par>
-                      </p:childTnLst>
-                    </p:cTn>
-                  </p:par>
-                </p:childTnLst>
-              </p:cTn>
-              <p:prevCondLst>
-                <p:cond evt="onPrev" delay="0">
-                  <p:tgtEl>
-                    <p:sldTgt/>
-                  </p:tgtEl>
-                </p:cond>
-              </p:prevCondLst>
-              <p:nextCondLst>
-                <p:cond evt="onNext" delay="0">
-                  <p:tgtEl>
-                    <p:sldTgt/>
-                  </p:tgtEl>
-                </p:cond>
-              </p:nextCondLst>
-            </p:seq>
-          </p:childTnLst>
-        </p:cTn>
-      </p:par>
-    </p:tnLst>
-  </p:timing>
 </p:sld>
 </file>
 
@@ -11779,15 +11508,7 @@
             </a:pPr>
             <a:r>
               <a:rPr lang="en-US" altLang="en-US" sz="2000" dirty="0"/>
-              <a:t> 68% lies between </a:t>
-            </a:r>
-            <a:r>
-              <a:rPr lang="en-US" altLang="en-US" sz="2000" dirty="0"/>
-              <a:t>μ-σ and μ+σ</a:t>
-            </a:r>
-            <a:r>
-              <a:rPr lang="en-US" altLang="en-US" sz="2000" dirty="0"/>
-              <a:t> </a:t>
+              <a:t> 68% lies between μ-σ and μ+σ </a:t>
             </a:r>
           </a:p>
           <a:p>
@@ -11796,11 +11517,7 @@
             </a:pPr>
             <a:r>
               <a:rPr lang="en-US" altLang="en-US" sz="2000" dirty="0"/>
-              <a:t> 95% lies between </a:t>
-            </a:r>
-            <a:r>
-              <a:rPr lang="en-US" altLang="en-US" sz="2000" dirty="0"/>
-              <a:t>μ-2σ and μ+2σ</a:t>
+              <a:t> 95% lies between μ-2σ and μ+2σ</a:t>
             </a:r>
           </a:p>
           <a:p>
@@ -11815,13 +11532,8 @@
             </a:r>
             <a:r>
               <a:rPr lang="en-US" altLang="en-US" sz="2000" dirty="0"/>
-              <a:t>lies between </a:t>
-            </a:r>
-            <a:r>
-              <a:rPr lang="en-US" altLang="en-US" sz="2000" dirty="0"/>
-              <a:t>μ-3σ and μ+3σ</a:t>
-            </a:r>
-            <a:endParaRPr lang="en-US" altLang="en-US" sz="2000" dirty="0"/>
+              <a:t>lies between μ-3σ and μ+3σ</a:t>
+            </a:r>
           </a:p>
           <a:p>
             <a:pPr eaLnBrk="1" hangingPunct="1">
@@ -13594,11 +13306,7 @@
             </a:r>
             <a:r>
               <a:rPr lang="en-US" altLang="en-US" sz="2400" dirty="0"/>
-              <a:t> = </a:t>
-            </a:r>
-            <a:r>
-              <a:rPr lang="en-US" altLang="en-US" sz="2400" dirty="0"/>
-              <a:t>μ + σ</a:t>
+              <a:t> = μ + σ</a:t>
             </a:r>
             <a:r>
               <a:rPr lang="en-US" altLang="en-US" sz="2400" i="1" dirty="0">
@@ -13627,7 +13335,7 @@
           <a:noFill/>
         </p:spPr>
         <p:txBody>
-          <a:bodyPr wrap="square" anchor="ctr" lIns="0" rIns="0" tIns="0" bIns="0">
+          <a:bodyPr wrap="square" lIns="0" tIns="0" rIns="0" bIns="0" anchor="ctr">
             <a:spAutoFit/>
           </a:bodyPr>
           <a:lstStyle/>
@@ -13753,15 +13461,7 @@
             </a:r>
             <a:r>
               <a:rPr lang="en-US" altLang="en-US" dirty="0"/>
-              <a:t> </a:t>
-            </a:r>
-            <a:r>
-              <a:rPr lang="en-US" altLang="en-US" dirty="0"/>
-              <a:t>≤ </a:t>
-            </a:r>
-            <a:r>
-              <a:rPr lang="en-US" altLang="en-US" dirty="0"/>
-              <a:t>-0.95</a:t>
+              <a:t> ≤ -0.95</a:t>
             </a:r>
           </a:p>
           <a:p>
@@ -13774,15 +13474,7 @@
             </a:r>
             <a:r>
               <a:rPr lang="en-US" altLang="en-US" dirty="0"/>
-              <a:t>  </a:t>
-            </a:r>
-            <a:r>
-              <a:rPr lang="en-US" altLang="en-US" dirty="0"/>
-              <a:t>≥</a:t>
-            </a:r>
-            <a:r>
-              <a:rPr lang="en-US" altLang="en-US" dirty="0"/>
-              <a:t> 1</a:t>
+              <a:t>  ≥ 1</a:t>
             </a:r>
           </a:p>
           <a:p>
@@ -13791,15 +13483,7 @@
             </a:pPr>
             <a:r>
               <a:rPr lang="en-US" altLang="en-US" dirty="0"/>
-              <a:t>0.1 </a:t>
-            </a:r>
-            <a:r>
-              <a:rPr lang="en-US" altLang="en-US" dirty="0"/>
-              <a:t>≤</a:t>
-            </a:r>
-            <a:r>
-              <a:rPr lang="en-US" altLang="en-US" dirty="0"/>
-              <a:t> </a:t>
+              <a:t>0.1 ≤ </a:t>
             </a:r>
             <a:r>
               <a:rPr lang="en-US" altLang="en-US" i="1" dirty="0"/>
@@ -13807,11 +13491,7 @@
             </a:r>
             <a:r>
               <a:rPr lang="en-US" altLang="en-US" dirty="0"/>
-              <a:t> </a:t>
-            </a:r>
-            <a:r>
-              <a:rPr lang="en-US" altLang="en-US" dirty="0"/>
-              <a:t>≤ 0.5 OR 1.5 ≤ </a:t>
+              <a:t> ≤ 0.5 OR 1.5 ≤ </a:t>
             </a:r>
             <a:r>
               <a:rPr lang="en-US" altLang="en-US" i="1" dirty="0">
@@ -13935,8 +13615,8 @@
           </a:p>
         </p:txBody>
       </p:sp>
-      <mc:AlternateContent xmlns:mc="http://schemas.openxmlformats.org/markup-compatibility/2006" xmlns:a14="http://schemas.microsoft.com/office/drawing/2010/main">
-        <mc:Choice Requires="a14">
+      <mc:AlternateContent xmlns:mc="http://schemas.openxmlformats.org/markup-compatibility/2006">
+        <mc:Choice xmlns:a14="http://schemas.microsoft.com/office/drawing/2010/main" Requires="a14">
           <p:sp>
             <p:nvSpPr>
               <p:cNvPr id="2" name="Text Placeholder 1"/>
@@ -13955,7 +13635,7 @@
             </p:spPr>
             <p:txBody>
               <a:bodyPr>
-                <a:normAutofit fontScale="92500" lnSpcReduction="10000"/>
+                <a:normAutofit fontScale="92500" lnSpcReduction="20000"/>
               </a:bodyPr>
               <a:lstStyle/>
               <a:p>
@@ -14168,12 +13848,19 @@
                 </a:r>
               </a:p>
               <a:p>
+                <a:pPr marL="457200" lvl="1" indent="0">
+                  <a:buNone/>
+                  <a:defRPr/>
+                </a:pPr>
+                <a:endParaRPr lang="en-US" i="1" dirty="0"/>
+              </a:p>
+              <a:p>
                 <a:pPr lvl="1">
                   <a:defRPr/>
                 </a:pPr>
                 <a:r>
                   <a:rPr lang="en-US" i="1" dirty="0"/>
-                  <a:t> The CDF is the </a:t>
+                  <a:t>The CDF is the </a:t>
                 </a:r>
                 <a:r>
                   <a:rPr lang="en-US" b="1" i="1" dirty="0">
@@ -14293,6 +13980,12 @@
                   <a:rPr lang="en-US" i="1" dirty="0"/>
                   <a:t> </a:t>
                 </a:r>
+              </a:p>
+              <a:p>
+                <a:pPr lvl="1">
+                  <a:defRPr/>
+                </a:pPr>
+                <a:endParaRPr lang="en-US" i="1" dirty="0"/>
               </a:p>
               <a:p>
                 <a:pPr lvl="1">
@@ -14466,7 +14159,7 @@
             </p:txBody>
           </p:sp>
         </mc:Choice>
-        <mc:Fallback xmlns="">
+        <mc:Fallback>
           <p:sp>
             <p:nvSpPr>
               <p:cNvPr id="2" name="Text Placeholder 1"/>
@@ -14485,7 +14178,7 @@
               <a:blipFill>
                 <a:blip r:embed="rId3"/>
                 <a:stretch>
-                  <a:fillRect l="-948" t="-2299" b="-17701"/>
+                  <a:fillRect l="-948" t="-2759" b="-18851"/>
                 </a:stretch>
               </a:blipFill>
             </p:spPr>
@@ -14581,7 +14274,7 @@
                                         <p:tgtEl>
                                           <p:spTgt spid="2">
                                             <p:txEl>
-                                              <p:pRg st="3" end="3"/>
+                                              <p:pRg st="4" end="4"/>
                                             </p:txEl>
                                           </p:spTgt>
                                         </p:tgtEl>
@@ -14630,7 +14323,7 @@
                                         <p:tgtEl>
                                           <p:spTgt spid="2">
                                             <p:txEl>
-                                              <p:pRg st="5" end="5"/>
+                                              <p:pRg st="6" end="6"/>
                                             </p:txEl>
                                           </p:spTgt>
                                         </p:tgtEl>
@@ -14661,7 +14354,7 @@
                                         <p:tgtEl>
                                           <p:spTgt spid="2">
                                             <p:txEl>
-                                              <p:pRg st="6" end="6"/>
+                                              <p:pRg st="8" end="8"/>
                                             </p:txEl>
                                           </p:spTgt>
                                         </p:tgtEl>
@@ -14710,7 +14403,7 @@
                                         <p:tgtEl>
                                           <p:spTgt spid="2">
                                             <p:txEl>
-                                              <p:pRg st="8" end="8"/>
+                                              <p:pRg st="10" end="10"/>
                                             </p:txEl>
                                           </p:spTgt>
                                         </p:tgtEl>
@@ -15980,17 +15673,13 @@
               <a:defRPr/>
             </a:pPr>
             <a:r>
-              <a:rPr lang="en-US" altLang="en-US" dirty="0"/>
-              <a:t/>
-            </a:r>
-            <a:r>
               <a:rPr lang="en-US" altLang="en-US" dirty="0">
                 <a:latin typeface="Cambria"/>
               </a:rPr>
               <a:t>σ</a:t>
             </a:r>
             <a:r>
-              <a:rPr lang="en-US" altLang="en-US" dirty="0" baseline="-25000">
+              <a:rPr lang="en-US" altLang="en-US" baseline="-25000" dirty="0">
                 <a:latin typeface="Cambria"/>
               </a:rPr>
               <a:t>x̄</a:t>
@@ -16023,8 +15712,8 @@
         </p:nvSpPr>
         <p:spPr>
           <a:xfrm>
-            <a:off x="5402264" y="2347338"/>
-            <a:ext cx="984738" cy="457200"/>
+            <a:off x="5402264" y="2391272"/>
+            <a:ext cx="984738" cy="369332"/>
           </a:xfrm>
           <a:prstGeom prst="rect">
             <a:avLst/>
@@ -16032,29 +15721,44 @@
           <a:noFill/>
         </p:spPr>
         <p:txBody>
-          <a:bodyPr wrap="square" anchor="ctr" lIns="0" rIns="0" tIns="0" bIns="0">
+          <a:bodyPr wrap="square" lIns="0" tIns="0" rIns="0" bIns="0" anchor="ctr">
             <a:spAutoFit/>
           </a:bodyPr>
           <a:lstStyle/>
           <a:p>
             <a:r>
-              <a:rPr sz="1900">
+              <a:rPr sz="2400" dirty="0" err="1">
                 <a:latin typeface="Cambria"/>
               </a:rPr>
               <a:t>μ</a:t>
             </a:r>
             <a:r>
-              <a:rPr sz="1900" baseline="-25000">
+              <a:rPr sz="2400" baseline="-25000" dirty="0" err="1">
                 <a:latin typeface="Cambria"/>
               </a:rPr>
-              <a:t>x̄</a:t>
-            </a:r>
-            <a:r>
-              <a:rPr sz="1900">
+              <a:t>x</a:t>
+            </a:r>
+            <a:r>
+              <a:rPr sz="2400" baseline="-25000" dirty="0">
                 <a:latin typeface="Cambria"/>
               </a:rPr>
-              <a:t> = μ</a:t>
-            </a:r>
+              <a:t>̄</a:t>
+            </a:r>
+            <a:r>
+              <a:rPr sz="2400" dirty="0">
+                <a:latin typeface="Cambria"/>
+              </a:rPr>
+              <a:t> = </a:t>
+            </a:r>
+            <a:r>
+              <a:rPr sz="2400" dirty="0" err="1">
+                <a:latin typeface="Cambria"/>
+              </a:rPr>
+              <a:t>μ</a:t>
+            </a:r>
+            <a:endParaRPr sz="2400" dirty="0">
+              <a:latin typeface="Cambria"/>
+            </a:endParaRPr>
           </a:p>
         </p:txBody>
       </p:sp>
@@ -16066,8 +15770,8 @@
         </p:nvSpPr>
         <p:spPr>
           <a:xfrm>
-            <a:off x="5029686" y="4162887"/>
-            <a:ext cx="1688123" cy="511175"/>
+            <a:off x="5029686" y="4233808"/>
+            <a:ext cx="1688123" cy="369332"/>
           </a:xfrm>
           <a:prstGeom prst="rect">
             <a:avLst/>
@@ -16075,25 +15779,25 @@
           <a:noFill/>
         </p:spPr>
         <p:txBody>
-          <a:bodyPr wrap="square" anchor="ctr" lIns="0" rIns="0" tIns="0" bIns="0">
+          <a:bodyPr wrap="square" lIns="0" tIns="0" rIns="0" bIns="0" anchor="ctr">
             <a:spAutoFit/>
           </a:bodyPr>
           <a:lstStyle/>
           <a:p>
             <a:r>
-              <a:rPr sz="1900">
+              <a:rPr sz="2400">
                 <a:latin typeface="Cambria"/>
               </a:rPr>
               <a:t>σ</a:t>
             </a:r>
             <a:r>
-              <a:rPr sz="1900" baseline="-25000">
+              <a:rPr sz="2400" baseline="-25000">
                 <a:latin typeface="Cambria"/>
               </a:rPr>
               <a:t>x̄</a:t>
             </a:r>
             <a:r>
-              <a:rPr sz="1900">
+              <a:rPr sz="2400">
                 <a:latin typeface="Cambria"/>
               </a:rPr>
               <a:t> = σ / √n</a:t>
@@ -17177,11 +16881,7 @@
             </a:r>
             <a:r>
               <a:rPr lang="en-US" altLang="en-US" sz="2000" dirty="0"/>
-              <a:t> </a:t>
-            </a:r>
-            <a:r>
-              <a:rPr lang="en-US" altLang="en-US" sz="2000" dirty="0"/>
-              <a:t>≥ 5 and </a:t>
+              <a:t> ≥ 5 and </a:t>
             </a:r>
             <a:r>
               <a:rPr lang="en-US" altLang="en-US" sz="2000" i="1" dirty="0">
@@ -17325,16 +17025,28 @@
           <a:noFill/>
         </p:spPr>
         <p:txBody>
-          <a:bodyPr wrap="square" anchor="ctr" lIns="0" rIns="0" tIns="0" bIns="0">
+          <a:bodyPr wrap="square" lIns="0" tIns="0" rIns="0" bIns="0" anchor="ctr">
             <a:spAutoFit/>
           </a:bodyPr>
           <a:lstStyle/>
           <a:p>
             <a:r>
-              <a:rPr sz="1900">
+              <a:rPr sz="1900" dirty="0">
                 <a:latin typeface="Cambria"/>
               </a:rPr>
-              <a:t>X ≈ N(np, √(npq))</a:t>
+              <a:t>X ≈ N(np, √(</a:t>
+            </a:r>
+            <a:r>
+              <a:rPr sz="1900" dirty="0" err="1">
+                <a:latin typeface="Cambria"/>
+              </a:rPr>
+              <a:t>npq</a:t>
+            </a:r>
+            <a:r>
+              <a:rPr sz="1900" dirty="0">
+                <a:latin typeface="Cambria"/>
+              </a:rPr>
+              <a:t>))</a:t>
             </a:r>
           </a:p>
         </p:txBody>
@@ -17931,11 +17643,7 @@
             </a:pPr>
             <a:r>
               <a:rPr lang="en-US" altLang="en-US" dirty="0"/>
-              <a:t>If </a:t>
-            </a:r>
-            <a:r>
-              <a:rPr lang="en-US" altLang="en-US" dirty="0"/>
-              <a:t>μ&gt;10, the Poisson random variable </a:t>
+              <a:t>If μ&gt;10, the Poisson random variable </a:t>
             </a:r>
             <a:r>
               <a:rPr lang="en-US" altLang="en-US" i="1" dirty="0"/>
@@ -18306,7 +18014,7 @@
           <a:noFill/>
         </p:spPr>
         <p:txBody>
-          <a:bodyPr wrap="square" anchor="ctr" lIns="0" rIns="0" tIns="0" bIns="0">
+          <a:bodyPr wrap="square" lIns="0" tIns="0" rIns="0" bIns="0" anchor="ctr">
             <a:spAutoFit/>
           </a:bodyPr>
           <a:lstStyle/>
@@ -18670,8 +18378,8 @@
         </p:nvSpPr>
         <p:spPr>
           <a:xfrm>
-            <a:off x="3962400" y="1576388"/>
-            <a:ext cx="2954215" cy="863600"/>
+            <a:off x="3962400" y="1823522"/>
+            <a:ext cx="2954215" cy="369332"/>
           </a:xfrm>
           <a:prstGeom prst="rect">
             <a:avLst/>
@@ -18679,55 +18387,55 @@
           <a:noFill/>
         </p:spPr>
         <p:txBody>
-          <a:bodyPr wrap="square" anchor="ctr" lIns="0" rIns="0" tIns="0" bIns="0">
+          <a:bodyPr wrap="square" lIns="0" tIns="0" rIns="0" bIns="0" anchor="ctr">
             <a:spAutoFit/>
           </a:bodyPr>
           <a:lstStyle/>
           <a:p>
             <a:r>
-              <a:rPr sz="1900" b="0">
+              <a:rPr sz="2400" b="0">
                 <a:latin typeface="Cambria"/>
               </a:rPr>
               <a:t>F</a:t>
             </a:r>
             <a:r>
-              <a:rPr sz="1900" b="0" baseline="-25000">
+              <a:rPr sz="2400" b="0" baseline="-25000">
                 <a:latin typeface="Cambria"/>
               </a:rPr>
               <a:t>X</a:t>
             </a:r>
             <a:r>
-              <a:rPr sz="1900" b="0">
+              <a:rPr sz="2400" b="0">
                 <a:latin typeface="Cambria"/>
               </a:rPr>
               <a:t>(x) = ∫</a:t>
             </a:r>
             <a:r>
-              <a:rPr sz="1900" b="0" baseline="-25000">
+              <a:rPr sz="2400" b="0" baseline="-25000">
                 <a:latin typeface="Cambria"/>
               </a:rPr>
               <a:t>−∞</a:t>
             </a:r>
             <a:r>
-              <a:rPr sz="1900" b="0" baseline="30000">
+              <a:rPr sz="2400" b="0" baseline="30000">
                 <a:latin typeface="Cambria"/>
               </a:rPr>
               <a:t>x</a:t>
             </a:r>
             <a:r>
-              <a:rPr sz="1900" b="0">
+              <a:rPr sz="2400" b="0">
                 <a:latin typeface="Cambria"/>
               </a:rPr>
               <a:t> f</a:t>
             </a:r>
             <a:r>
-              <a:rPr sz="1900" b="0" baseline="-25000">
+              <a:rPr sz="2400" b="0" baseline="-25000">
                 <a:latin typeface="Cambria"/>
               </a:rPr>
               <a:t>X</a:t>
             </a:r>
             <a:r>
-              <a:rPr sz="1900" b="0">
+              <a:rPr sz="2400" b="0">
                 <a:latin typeface="Cambria"/>
               </a:rPr>
               <a:t>(t) dt</a:t>
@@ -18745,130 +18453,6 @@
   <p:clrMapOvr>
     <a:masterClrMapping/>
   </p:clrMapOvr>
-  <p:timing>
-    <p:tnLst>
-      <p:par>
-        <p:cTn id="1" dur="indefinite" restart="never" nodeType="tmRoot">
-          <p:childTnLst>
-            <p:seq concurrent="1" nextAc="seek">
-              <p:cTn id="2" dur="indefinite" nodeType="mainSeq">
-                <p:childTnLst>
-                  <p:par>
-                    <p:cTn id="3" fill="hold" nodeType="clickPar">
-                      <p:stCondLst>
-                        <p:cond delay="indefinite"/>
-                      </p:stCondLst>
-                      <p:childTnLst>
-                        <p:par>
-                          <p:cTn id="4" fill="hold" nodeType="withGroup">
-                            <p:stCondLst>
-                              <p:cond delay="0"/>
-                            </p:stCondLst>
-                            <p:childTnLst>
-                              <p:par>
-                                <p:cTn id="5" presetID="1" presetClass="entr" presetSubtype="0" fill="hold" nodeType="clickEffect">
-                                  <p:stCondLst>
-                                    <p:cond delay="0"/>
-                                  </p:stCondLst>
-                                  <p:childTnLst>
-                                    <p:set>
-                                      <p:cBhvr>
-                                        <p:cTn id="6" dur="1" fill="hold">
-                                          <p:stCondLst>
-                                            <p:cond delay="0"/>
-                                          </p:stCondLst>
-                                        </p:cTn>
-                                        <p:tgtEl>
-                                          <p:spTgt spid="2"/>
-                                        </p:tgtEl>
-                                        <p:attrNameLst>
-                                          <p:attrName>style.visibility</p:attrName>
-                                        </p:attrNameLst>
-                                      </p:cBhvr>
-                                      <p:to>
-                                        <p:strVal val="visible"/>
-                                      </p:to>
-                                    </p:set>
-                                  </p:childTnLst>
-                                </p:cTn>
-                              </p:par>
-                            </p:childTnLst>
-                          </p:cTn>
-                        </p:par>
-                      </p:childTnLst>
-                    </p:cTn>
-                  </p:par>
-                  <p:par>
-                    <p:cTn id="7" fill="hold" nodeType="clickPar">
-                      <p:stCondLst>
-                        <p:cond delay="indefinite"/>
-                      </p:stCondLst>
-                      <p:childTnLst>
-                        <p:par>
-                          <p:cTn id="8" fill="hold" nodeType="withGroup">
-                            <p:stCondLst>
-                              <p:cond delay="0"/>
-                            </p:stCondLst>
-                            <p:childTnLst>
-                              <p:par>
-                                <p:cTn id="9" presetID="1" presetClass="entr" presetSubtype="0" fill="hold" nodeType="clickEffect">
-                                  <p:stCondLst>
-                                    <p:cond delay="0"/>
-                                  </p:stCondLst>
-                                  <p:childTnLst>
-                                    <p:set>
-                                      <p:cBhvr>
-                                        <p:cTn id="10" dur="1" fill="hold">
-                                          <p:stCondLst>
-                                            <p:cond delay="0"/>
-                                          </p:stCondLst>
-                                        </p:cTn>
-                                        <p:tgtEl>
-                                          <p:spTgt spid="8194">
-                                            <p:txEl>
-                                              <p:pRg st="3" end="3"/>
-                                            </p:txEl>
-                                          </p:spTgt>
-                                        </p:tgtEl>
-                                        <p:attrNameLst>
-                                          <p:attrName>style.visibility</p:attrName>
-                                        </p:attrNameLst>
-                                      </p:cBhvr>
-                                      <p:to>
-                                        <p:strVal val="visible"/>
-                                      </p:to>
-                                    </p:set>
-                                  </p:childTnLst>
-                                </p:cTn>
-                              </p:par>
-                            </p:childTnLst>
-                          </p:cTn>
-                        </p:par>
-                      </p:childTnLst>
-                    </p:cTn>
-                  </p:par>
-                </p:childTnLst>
-              </p:cTn>
-              <p:prevCondLst>
-                <p:cond evt="onPrev" delay="0">
-                  <p:tgtEl>
-                    <p:sldTgt/>
-                  </p:tgtEl>
-                </p:cond>
-              </p:prevCondLst>
-              <p:nextCondLst>
-                <p:cond evt="onNext" delay="0">
-                  <p:tgtEl>
-                    <p:sldTgt/>
-                  </p:tgtEl>
-                </p:cond>
-              </p:nextCondLst>
-            </p:seq>
-          </p:childTnLst>
-        </p:cTn>
-      </p:par>
-    </p:tnLst>
-  </p:timing>
 </p:sld>
 </file>
 
@@ -19039,7 +18623,7 @@
         </p:nvSpPr>
         <p:spPr>
           <a:xfrm>
-            <a:off x="4688917" y="3770098"/>
+            <a:off x="4873162" y="3887057"/>
             <a:ext cx="1406769" cy="704695"/>
           </a:xfrm>
           <a:prstGeom prst="rect">
@@ -19048,25 +18632,31 @@
           <a:noFill/>
         </p:spPr>
         <p:txBody>
-          <a:bodyPr wrap="square" anchor="ctr" lIns="0" rIns="0" tIns="0" bIns="0">
+          <a:bodyPr wrap="square" lIns="0" tIns="0" rIns="0" bIns="0" anchor="ctr">
             <a:spAutoFit/>
           </a:bodyPr>
           <a:lstStyle/>
           <a:p>
             <a:r>
-              <a:rPr sz="1900" b="0">
+              <a:rPr sz="1900" b="0" dirty="0" err="1">
                 <a:latin typeface="Cambria"/>
               </a:rPr>
               <a:t>σ</a:t>
             </a:r>
             <a:r>
-              <a:rPr sz="1900" b="0" baseline="-25000">
+              <a:rPr sz="1900" b="0" baseline="-25000" dirty="0" err="1">
                 <a:latin typeface="Cambria"/>
               </a:rPr>
-              <a:t>x̄</a:t>
-            </a:r>
-            <a:r>
-              <a:rPr sz="1900" b="0">
+              <a:t>x</a:t>
+            </a:r>
+            <a:r>
+              <a:rPr sz="1900" b="0" baseline="-25000" dirty="0">
+                <a:latin typeface="Cambria"/>
+              </a:rPr>
+              <a:t>̄</a:t>
+            </a:r>
+            <a:r>
+              <a:rPr sz="1900" b="0" dirty="0">
                 <a:latin typeface="Cambria"/>
               </a:rPr>
               <a:t> ≈ s/√n</a:t>
@@ -19084,259 +18674,6 @@
   <p:clrMapOvr>
     <a:masterClrMapping/>
   </p:clrMapOvr>
-  <p:timing>
-    <p:tnLst>
-      <p:par>
-        <p:cTn id="1" dur="indefinite" restart="never" nodeType="tmRoot">
-          <p:childTnLst>
-            <p:seq concurrent="1" nextAc="seek">
-              <p:cTn id="2" dur="indefinite" nodeType="mainSeq">
-                <p:childTnLst>
-                  <p:par>
-                    <p:cTn id="3" fill="hold">
-                      <p:stCondLst>
-                        <p:cond delay="indefinite"/>
-                      </p:stCondLst>
-                      <p:childTnLst>
-                        <p:par>
-                          <p:cTn id="4" fill="hold">
-                            <p:stCondLst>
-                              <p:cond delay="0"/>
-                            </p:stCondLst>
-                            <p:childTnLst>
-                              <p:par>
-                                <p:cTn id="5" presetID="1" presetClass="entr" presetSubtype="0" fill="hold" nodeType="clickEffect">
-                                  <p:stCondLst>
-                                    <p:cond delay="0"/>
-                                  </p:stCondLst>
-                                  <p:childTnLst>
-                                    <p:set>
-                                      <p:cBhvr>
-                                        <p:cTn id="6" dur="1" fill="hold">
-                                          <p:stCondLst>
-                                            <p:cond delay="0"/>
-                                          </p:stCondLst>
-                                        </p:cTn>
-                                        <p:tgtEl>
-                                          <p:spTgt spid="4099">
-                                            <p:txEl>
-                                              <p:pRg st="1" end="1"/>
-                                            </p:txEl>
-                                          </p:spTgt>
-                                        </p:tgtEl>
-                                        <p:attrNameLst>
-                                          <p:attrName>style.visibility</p:attrName>
-                                        </p:attrNameLst>
-                                      </p:cBhvr>
-                                      <p:to>
-                                        <p:strVal val="visible"/>
-                                      </p:to>
-                                    </p:set>
-                                  </p:childTnLst>
-                                </p:cTn>
-                              </p:par>
-                            </p:childTnLst>
-                          </p:cTn>
-                        </p:par>
-                      </p:childTnLst>
-                    </p:cTn>
-                  </p:par>
-                  <p:par>
-                    <p:cTn id="7" fill="hold">
-                      <p:stCondLst>
-                        <p:cond delay="indefinite"/>
-                      </p:stCondLst>
-                      <p:childTnLst>
-                        <p:par>
-                          <p:cTn id="8" fill="hold">
-                            <p:stCondLst>
-                              <p:cond delay="0"/>
-                            </p:stCondLst>
-                            <p:childTnLst>
-                              <p:par>
-                                <p:cTn id="9" presetID="1" presetClass="entr" presetSubtype="0" fill="hold" nodeType="clickEffect">
-                                  <p:stCondLst>
-                                    <p:cond delay="0"/>
-                                  </p:stCondLst>
-                                  <p:childTnLst>
-                                    <p:set>
-                                      <p:cBhvr>
-                                        <p:cTn id="10" dur="1" fill="hold">
-                                          <p:stCondLst>
-                                            <p:cond delay="0"/>
-                                          </p:stCondLst>
-                                        </p:cTn>
-                                        <p:tgtEl>
-                                          <p:spTgt spid="4099">
-                                            <p:txEl>
-                                              <p:pRg st="2" end="2"/>
-                                            </p:txEl>
-                                          </p:spTgt>
-                                        </p:tgtEl>
-                                        <p:attrNameLst>
-                                          <p:attrName>style.visibility</p:attrName>
-                                        </p:attrNameLst>
-                                      </p:cBhvr>
-                                      <p:to>
-                                        <p:strVal val="visible"/>
-                                      </p:to>
-                                    </p:set>
-                                  </p:childTnLst>
-                                </p:cTn>
-                              </p:par>
-                            </p:childTnLst>
-                          </p:cTn>
-                        </p:par>
-                      </p:childTnLst>
-                    </p:cTn>
-                  </p:par>
-                  <p:par>
-                    <p:cTn id="11" fill="hold">
-                      <p:stCondLst>
-                        <p:cond delay="indefinite"/>
-                      </p:stCondLst>
-                      <p:childTnLst>
-                        <p:par>
-                          <p:cTn id="12" fill="hold">
-                            <p:stCondLst>
-                              <p:cond delay="0"/>
-                            </p:stCondLst>
-                            <p:childTnLst>
-                              <p:par>
-                                <p:cTn id="13" presetID="1" presetClass="entr" presetSubtype="0" fill="hold" nodeType="clickEffect">
-                                  <p:stCondLst>
-                                    <p:cond delay="0"/>
-                                  </p:stCondLst>
-                                  <p:childTnLst>
-                                    <p:set>
-                                      <p:cBhvr>
-                                        <p:cTn id="14" dur="1" fill="hold">
-                                          <p:stCondLst>
-                                            <p:cond delay="0"/>
-                                          </p:stCondLst>
-                                        </p:cTn>
-                                        <p:tgtEl>
-                                          <p:spTgt spid="4099">
-                                            <p:txEl>
-                                              <p:pRg st="5" end="5"/>
-                                            </p:txEl>
-                                          </p:spTgt>
-                                        </p:tgtEl>
-                                        <p:attrNameLst>
-                                          <p:attrName>style.visibility</p:attrName>
-                                        </p:attrNameLst>
-                                      </p:cBhvr>
-                                      <p:to>
-                                        <p:strVal val="visible"/>
-                                      </p:to>
-                                    </p:set>
-                                  </p:childTnLst>
-                                </p:cTn>
-                              </p:par>
-                              <p:par>
-                                <p:cTn id="15" presetID="1" presetClass="entr" presetSubtype="0" fill="hold" nodeType="withEffect">
-                                  <p:stCondLst>
-                                    <p:cond delay="0"/>
-                                  </p:stCondLst>
-                                  <p:childTnLst>
-                                    <p:set>
-                                      <p:cBhvr>
-                                        <p:cTn id="16" dur="1" fill="hold">
-                                          <p:stCondLst>
-                                            <p:cond delay="0"/>
-                                          </p:stCondLst>
-                                        </p:cTn>
-                                        <p:tgtEl>
-                                          <p:spTgt spid="2"/>
-                                        </p:tgtEl>
-                                        <p:attrNameLst>
-                                          <p:attrName>style.visibility</p:attrName>
-                                        </p:attrNameLst>
-                                      </p:cBhvr>
-                                      <p:to>
-                                        <p:strVal val="visible"/>
-                                      </p:to>
-                                    </p:set>
-                                  </p:childTnLst>
-                                </p:cTn>
-                              </p:par>
-                            </p:childTnLst>
-                          </p:cTn>
-                        </p:par>
-                      </p:childTnLst>
-                    </p:cTn>
-                  </p:par>
-                  <p:par>
-                    <p:cTn id="17" fill="hold">
-                      <p:stCondLst>
-                        <p:cond delay="indefinite"/>
-                      </p:stCondLst>
-                      <p:childTnLst>
-                        <p:par>
-                          <p:cTn id="18" fill="hold">
-                            <p:stCondLst>
-                              <p:cond delay="0"/>
-                            </p:stCondLst>
-                            <p:childTnLst>
-                              <p:par>
-                                <p:cTn id="19" presetID="1" presetClass="entr" presetSubtype="0" fill="hold" nodeType="clickEffect">
-                                  <p:stCondLst>
-                                    <p:cond delay="0"/>
-                                  </p:stCondLst>
-                                  <p:childTnLst>
-                                    <p:set>
-                                      <p:cBhvr>
-                                        <p:cTn id="20" dur="1" fill="hold">
-                                          <p:stCondLst>
-                                            <p:cond delay="0"/>
-                                          </p:stCondLst>
-                                        </p:cTn>
-                                        <p:tgtEl>
-                                          <p:spTgt spid="4099">
-                                            <p:txEl>
-                                              <p:pRg st="7" end="7"/>
-                                            </p:txEl>
-                                          </p:spTgt>
-                                        </p:tgtEl>
-                                        <p:attrNameLst>
-                                          <p:attrName>style.visibility</p:attrName>
-                                        </p:attrNameLst>
-                                      </p:cBhvr>
-                                      <p:to>
-                                        <p:strVal val="visible"/>
-                                      </p:to>
-                                    </p:set>
-                                  </p:childTnLst>
-                                </p:cTn>
-                              </p:par>
-                            </p:childTnLst>
-                          </p:cTn>
-                        </p:par>
-                      </p:childTnLst>
-                    </p:cTn>
-                  </p:par>
-                </p:childTnLst>
-              </p:cTn>
-              <p:prevCondLst>
-                <p:cond evt="onPrev" delay="0">
-                  <p:tgtEl>
-                    <p:sldTgt/>
-                  </p:tgtEl>
-                </p:cond>
-              </p:prevCondLst>
-              <p:nextCondLst>
-                <p:cond evt="onNext" delay="0">
-                  <p:tgtEl>
-                    <p:sldTgt/>
-                  </p:tgtEl>
-                </p:cond>
-              </p:nextCondLst>
-            </p:seq>
-          </p:childTnLst>
-        </p:cTn>
-      </p:par>
-    </p:tnLst>
-  </p:timing>
 </p:sld>
 </file>
 
@@ -20269,6 +19606,7 @@
             </a:extLst>
           </p:cNvPr>
           <p:cNvCxnSpPr>
+            <a:cxnSpLocks/>
             <a:stCxn id="3" idx="2"/>
           </p:cNvCxnSpPr>
           <p:nvPr/>
@@ -20276,7 +19614,7 @@
         <p:spPr>
           <a:xfrm>
             <a:off x="2146356" y="1988344"/>
-            <a:ext cx="862658" cy="373856"/>
+            <a:ext cx="841393" cy="745946"/>
           </a:xfrm>
           <a:prstGeom prst="straightConnector1">
             <a:avLst/>
@@ -20315,7 +19653,7 @@
         <p:spPr>
           <a:xfrm>
             <a:off x="4386371" y="1577068"/>
-            <a:ext cx="3809999" cy="369332"/>
+            <a:ext cx="4910029" cy="369332"/>
           </a:xfrm>
           <a:prstGeom prst="rect">
             <a:avLst/>
@@ -20330,7 +19668,7 @@
           <a:p>
             <a:r>
               <a:rPr lang="en-US" dirty="0"/>
-              <a:t>True Mean. Zero for hypothesis testing</a:t>
+              <a:t>True Mean. Typically zero for hypothesis testing</a:t>
             </a:r>
           </a:p>
         </p:txBody>
@@ -20346,14 +19684,13 @@
           </p:cNvPr>
           <p:cNvCxnSpPr>
             <a:cxnSpLocks/>
-            <a:stCxn id="6" idx="2"/>
           </p:cNvCxnSpPr>
           <p:nvPr/>
         </p:nvCxnSpPr>
         <p:spPr>
           <a:xfrm flipH="1">
-            <a:off x="4441371" y="1946400"/>
-            <a:ext cx="1850000" cy="511792"/>
+            <a:off x="3648287" y="2012870"/>
+            <a:ext cx="1761913" cy="693046"/>
           </a:xfrm>
           <a:prstGeom prst="straightConnector1">
             <a:avLst/>
@@ -20391,7 +19728,7 @@
         </p:nvSpPr>
         <p:spPr>
           <a:xfrm>
-            <a:off x="1633093" y="4283352"/>
+            <a:off x="2713747" y="3930451"/>
             <a:ext cx="1555169" cy="369332"/>
           </a:xfrm>
           <a:prstGeom prst="rect">
@@ -20429,7 +19766,7 @@
         </p:nvCxnSpPr>
         <p:spPr>
           <a:xfrm flipV="1">
-            <a:off x="2410678" y="3933171"/>
+            <a:off x="3491332" y="3580270"/>
             <a:ext cx="950039" cy="350181"/>
           </a:xfrm>
           <a:prstGeom prst="straightConnector1">
@@ -20462,8 +19799,8 @@
         </p:nvSpPr>
         <p:spPr>
           <a:xfrm>
-            <a:off x="2362200" y="2286001"/>
-            <a:ext cx="2306638" cy="1552575"/>
+            <a:off x="2362200" y="2846844"/>
+            <a:ext cx="3048000" cy="430887"/>
           </a:xfrm>
           <a:prstGeom prst="rect">
             <a:avLst/>
@@ -20471,16 +19808,28 @@
           <a:noFill/>
         </p:spPr>
         <p:txBody>
-          <a:bodyPr wrap="square" anchor="ctr" lIns="0" rIns="0" tIns="0" bIns="0">
+          <a:bodyPr wrap="square" lIns="0" tIns="0" rIns="0" bIns="0" anchor="ctr">
             <a:spAutoFit/>
           </a:bodyPr>
           <a:lstStyle/>
           <a:p>
             <a:r>
-              <a:rPr sz="1400">
+              <a:rPr sz="2800" dirty="0">
                 <a:latin typeface="Cambria"/>
               </a:rPr>
-              <a:t>t = (x̄ − μ) / (s / √n)</a:t>
+              <a:t>t = (x̄ − </a:t>
+            </a:r>
+            <a:r>
+              <a:rPr sz="2800" dirty="0" err="1">
+                <a:latin typeface="Cambria"/>
+              </a:rPr>
+              <a:t>μ</a:t>
+            </a:r>
+            <a:r>
+              <a:rPr sz="2800" dirty="0">
+                <a:latin typeface="Cambria"/>
+              </a:rPr>
+              <a:t>) / (s / √n)</a:t>
             </a:r>
           </a:p>
         </p:txBody>
@@ -20666,8 +20015,8 @@
         </p:nvSpPr>
         <p:spPr>
           <a:xfrm>
-            <a:off x="6083300" y="799322"/>
-            <a:ext cx="4724400" cy="2276690"/>
+            <a:off x="6083299" y="1322113"/>
+            <a:ext cx="5793267" cy="1231106"/>
           </a:xfrm>
           <a:prstGeom prst="rect">
             <a:avLst/>
@@ -20675,25 +20024,37 @@
           <a:noFill/>
         </p:spPr>
         <p:txBody>
-          <a:bodyPr wrap="square" anchor="ctr" lIns="0" rIns="0" tIns="0" bIns="0">
+          <a:bodyPr wrap="square" lIns="0" tIns="0" rIns="0" bIns="0" anchor="ctr">
             <a:spAutoFit/>
           </a:bodyPr>
           <a:lstStyle/>
           <a:p>
             <a:r>
-              <a:rPr sz="1200" b="0">
+              <a:rPr sz="2000" b="0" dirty="0">
                 <a:latin typeface="Cambria"/>
               </a:rPr>
-              <a:t>Lognormal(μ, σ</a:t>
-            </a:r>
-            <a:r>
-              <a:rPr sz="1200" b="0" baseline="30000">
+              <a:t>Lognormal(</a:t>
+            </a:r>
+            <a:r>
+              <a:rPr sz="2000" b="0" dirty="0" err="1">
+                <a:latin typeface="Cambria"/>
+              </a:rPr>
+              <a:t>μ</a:t>
+            </a:r>
+            <a:r>
+              <a:rPr sz="2000" b="0" dirty="0">
+                <a:latin typeface="Cambria"/>
+              </a:rPr>
+              <a:t>, σ</a:t>
+            </a:r>
+            <a:r>
+              <a:rPr sz="2000" b="0" baseline="30000" dirty="0">
                 <a:latin typeface="Cambria"/>
               </a:rPr>
               <a:t>2</a:t>
             </a:r>
             <a:r>
-              <a:rPr sz="1200" b="0">
+              <a:rPr sz="2000" b="0" dirty="0">
                 <a:latin typeface="Cambria"/>
               </a:rPr>
               <a:t>)</a:t>
@@ -20701,15 +20062,39 @@
           </a:p>
           <a:p>
             <a:r>
-              <a:rPr sz="1200" b="0">
+              <a:rPr sz="2000" b="0" dirty="0">
                 <a:latin typeface="Cambria"/>
               </a:rPr>
-              <a:t>Parameters:  μ ∈ (−∞, +∞),  σ &gt; 0</a:t>
-            </a:r>
-          </a:p>
-          <a:p>
-            <a:r>
-              <a:rPr sz="1200" b="0">
+              <a:t>Parameters:  </a:t>
+            </a:r>
+            <a:r>
+              <a:rPr sz="2000" b="0" dirty="0" err="1">
+                <a:latin typeface="Cambria"/>
+              </a:rPr>
+              <a:t>μ</a:t>
+            </a:r>
+            <a:r>
+              <a:rPr sz="2000" b="0" dirty="0">
+                <a:latin typeface="Cambria"/>
+              </a:rPr>
+              <a:t> ∈ (−∞, +∞),  </a:t>
+            </a:r>
+            <a:r>
+              <a:rPr sz="2000" b="0" dirty="0" err="1">
+                <a:latin typeface="Cambria"/>
+              </a:rPr>
+              <a:t>σ</a:t>
+            </a:r>
+            <a:r>
+              <a:rPr sz="2000" b="0" dirty="0">
+                <a:latin typeface="Cambria"/>
+              </a:rPr>
+              <a:t> &gt; 0</a:t>
+            </a:r>
+          </a:p>
+          <a:p>
+            <a:r>
+              <a:rPr sz="2000" b="0" dirty="0">
                 <a:latin typeface="Cambria"/>
               </a:rPr>
               <a:t>Support:  x ∈ (0, +∞)</a:t>
@@ -20717,31 +20102,55 @@
           </a:p>
           <a:p>
             <a:r>
-              <a:rPr sz="1200" b="0">
+              <a:rPr sz="2000" b="0" dirty="0">
                 <a:latin typeface="Cambria"/>
               </a:rPr>
-              <a:t>PDF:  f(x) = 1/(x σ √(2π)) · exp( −(ln x − μ)</a:t>
-            </a:r>
-            <a:r>
-              <a:rPr sz="1200" b="0" baseline="30000">
+              <a:t>PDF:  f(x) = 1/(x </a:t>
+            </a:r>
+            <a:r>
+              <a:rPr sz="2000" b="0" dirty="0" err="1">
+                <a:latin typeface="Cambria"/>
+              </a:rPr>
+              <a:t>σ</a:t>
+            </a:r>
+            <a:r>
+              <a:rPr sz="2000" b="0" dirty="0">
+                <a:latin typeface="Cambria"/>
+              </a:rPr>
+              <a:t> √(2π)) · exp( −(ln x − </a:t>
+            </a:r>
+            <a:r>
+              <a:rPr sz="2000" b="0" dirty="0" err="1">
+                <a:latin typeface="Cambria"/>
+              </a:rPr>
+              <a:t>μ</a:t>
+            </a:r>
+            <a:r>
+              <a:rPr sz="2000" b="0" dirty="0">
+                <a:latin typeface="Cambria"/>
+              </a:rPr>
+              <a:t>)</a:t>
+            </a:r>
+            <a:r>
+              <a:rPr sz="2000" b="0" baseline="30000" dirty="0">
                 <a:latin typeface="Cambria"/>
               </a:rPr>
               <a:t>2</a:t>
             </a:r>
             <a:r>
-              <a:rPr sz="1200" b="0">
+              <a:rPr sz="2000" b="0" dirty="0">
                 <a:latin typeface="Cambria"/>
               </a:rPr>
               <a:t> / (2σ</a:t>
             </a:r>
             <a:r>
-              <a:rPr sz="1200" b="0" baseline="30000">
+              <a:rPr sz="2000" b="0" baseline="30000" dirty="0">
                 <a:latin typeface="Cambria"/>
               </a:rPr>
               <a:t>2</a:t>
             </a:r>
             <a:r>
-              <a:rPr sz="1200" b="0">
+              <a:rPr sz="2000" b="0" dirty="0">
                 <a:latin typeface="Cambria"/>
               </a:rPr>
               <a:t>) )</a:t>
@@ -20757,8 +20166,8 @@
         </p:nvSpPr>
         <p:spPr>
           <a:xfrm>
-            <a:off x="6083300" y="3448050"/>
-            <a:ext cx="4591051" cy="1975751"/>
+            <a:off x="6083300" y="3820372"/>
+            <a:ext cx="4591051" cy="1231106"/>
           </a:xfrm>
           <a:prstGeom prst="rect">
             <a:avLst/>
@@ -20766,25 +20175,25 @@
           <a:noFill/>
         </p:spPr>
         <p:txBody>
-          <a:bodyPr wrap="square" anchor="ctr" lIns="0" rIns="0" tIns="0" bIns="0">
+          <a:bodyPr wrap="square" lIns="0" tIns="0" rIns="0" bIns="0" anchor="ctr">
             <a:spAutoFit/>
           </a:bodyPr>
           <a:lstStyle/>
           <a:p>
             <a:r>
-              <a:rPr sz="1600" b="0">
+              <a:rPr sz="2000" b="0">
                 <a:latin typeface="Cambria"/>
               </a:rPr>
               <a:t>Mean:  exp(μ + σ</a:t>
             </a:r>
             <a:r>
-              <a:rPr sz="1600" b="0" baseline="30000">
+              <a:rPr sz="2000" b="0" baseline="30000">
                 <a:latin typeface="Cambria"/>
               </a:rPr>
               <a:t>2</a:t>
             </a:r>
             <a:r>
-              <a:rPr sz="1600" b="0">
+              <a:rPr sz="2000" b="0">
                 <a:latin typeface="Cambria"/>
               </a:rPr>
               <a:t>/2)</a:t>
@@ -20792,7 +20201,7 @@
           </a:p>
           <a:p>
             <a:r>
-              <a:rPr sz="1600" b="0">
+              <a:rPr sz="2000" b="0">
                 <a:latin typeface="Cambria"/>
               </a:rPr>
               <a:t>Median:  exp(μ)</a:t>
@@ -20800,19 +20209,19 @@
           </a:p>
           <a:p>
             <a:r>
-              <a:rPr sz="1600" b="0">
+              <a:rPr sz="2000" b="0">
                 <a:latin typeface="Cambria"/>
               </a:rPr>
               <a:t>Mode:  exp(μ − σ</a:t>
             </a:r>
             <a:r>
-              <a:rPr sz="1600" b="0" baseline="30000">
+              <a:rPr sz="2000" b="0" baseline="30000">
                 <a:latin typeface="Cambria"/>
               </a:rPr>
               <a:t>2</a:t>
             </a:r>
             <a:r>
-              <a:rPr sz="1600" b="0">
+              <a:rPr sz="2000" b="0">
                 <a:latin typeface="Cambria"/>
               </a:rPr>
               <a:t>)</a:t>
@@ -20820,31 +20229,31 @@
           </a:p>
           <a:p>
             <a:r>
-              <a:rPr sz="1600" b="0">
+              <a:rPr sz="2000" b="0">
                 <a:latin typeface="Cambria"/>
               </a:rPr>
               <a:t>Variance:  [exp(σ</a:t>
             </a:r>
             <a:r>
-              <a:rPr sz="1600" b="0" baseline="30000">
+              <a:rPr sz="2000" b="0" baseline="30000">
                 <a:latin typeface="Cambria"/>
               </a:rPr>
               <a:t>2</a:t>
             </a:r>
             <a:r>
-              <a:rPr sz="1600" b="0">
+              <a:rPr sz="2000" b="0">
                 <a:latin typeface="Cambria"/>
               </a:rPr>
               <a:t>) − 1] · exp(2μ + σ</a:t>
             </a:r>
             <a:r>
-              <a:rPr sz="1600" b="0" baseline="30000">
+              <a:rPr sz="2000" b="0" baseline="30000">
                 <a:latin typeface="Cambria"/>
               </a:rPr>
               <a:t>2</a:t>
             </a:r>
             <a:r>
-              <a:rPr sz="1600" b="0">
+              <a:rPr sz="2000" b="0">
                 <a:latin typeface="Cambria"/>
               </a:rPr>
               <a:t>)</a:t>
@@ -21207,7 +20616,7 @@
           <p:nvPr/>
         </p:nvPicPr>
         <p:blipFill>
-          <a:blip r:embed="rId6">
+          <a:blip r:embed="rId3">
             <a:extLst>
               <a:ext uri="{28A0092B-C50C-407E-A947-70E740481C1C}">
                 <a14:useLocalDpi xmlns:a14="http://schemas.microsoft.com/office/drawing/2010/main" val="0"/>
@@ -21260,7 +20669,7 @@
         </p:nvSpPr>
         <p:spPr>
           <a:xfrm>
-            <a:off x="9777984" y="1374711"/>
+            <a:off x="9788616" y="1129657"/>
             <a:ext cx="1434047" cy="369332"/>
           </a:xfrm>
           <a:prstGeom prst="rect">
@@ -21289,8 +20698,8 @@
         </p:nvSpPr>
         <p:spPr>
           <a:xfrm>
-            <a:off x="6488114" y="3456134"/>
-            <a:ext cx="5475286" cy="544564"/>
+            <a:off x="6488114" y="3537599"/>
+            <a:ext cx="5475286" cy="615553"/>
           </a:xfrm>
           <a:prstGeom prst="rect">
             <a:avLst/>
@@ -21298,16 +20707,39 @@
           <a:noFill/>
         </p:spPr>
         <p:txBody>
-          <a:bodyPr wrap="square" anchor="ctr" lIns="0" rIns="0" tIns="0" bIns="0">
+          <a:bodyPr wrap="square" lIns="0" tIns="0" rIns="0" bIns="0" anchor="ctr">
             <a:spAutoFit/>
           </a:bodyPr>
           <a:lstStyle/>
           <a:p>
             <a:r>
-              <a:rPr sz="1400" b="0">
+              <a:rPr sz="2000" b="0" dirty="0">
                 <a:latin typeface="Cambria"/>
               </a:rPr>
-              <a:t>E[X] = kθ  (shape-scale)  ;  E[X] = α/β  (shape-rate)</a:t>
+              <a:t>E[X] = </a:t>
+            </a:r>
+            <a:r>
+              <a:rPr sz="2000" b="0" dirty="0" err="1">
+                <a:latin typeface="Cambria"/>
+              </a:rPr>
+              <a:t>kθ</a:t>
+            </a:r>
+            <a:r>
+              <a:rPr sz="2000" b="0" dirty="0">
+                <a:latin typeface="Cambria"/>
+              </a:rPr>
+              <a:t>  (shape-scale)</a:t>
+            </a:r>
+            <a:endParaRPr lang="en-US" sz="2000" b="0" dirty="0">
+              <a:latin typeface="Cambria"/>
+            </a:endParaRPr>
+          </a:p>
+          <a:p>
+            <a:r>
+              <a:rPr sz="2000" b="0" dirty="0">
+                <a:latin typeface="Cambria"/>
+              </a:rPr>
+              <a:t>E[X] = α/β  (shape-rate)</a:t>
             </a:r>
           </a:p>
         </p:txBody>
@@ -21320,8 +20752,8 @@
         </p:nvSpPr>
         <p:spPr>
           <a:xfrm>
-            <a:off x="6488114" y="1677607"/>
-            <a:ext cx="4986168" cy="1600195"/>
+            <a:off x="6488114" y="1554375"/>
+            <a:ext cx="5534084" cy="1846659"/>
           </a:xfrm>
           <a:prstGeom prst="rect">
             <a:avLst/>
@@ -21329,97 +20761,156 @@
           <a:noFill/>
         </p:spPr>
         <p:txBody>
-          <a:bodyPr wrap="square" anchor="ctr" lIns="0" rIns="0" tIns="0" bIns="0">
+          <a:bodyPr wrap="square" lIns="0" tIns="0" rIns="0" bIns="0" anchor="ctr">
             <a:spAutoFit/>
           </a:bodyPr>
           <a:lstStyle/>
           <a:p>
             <a:r>
-              <a:rPr sz="1200" b="0">
+              <a:rPr sz="2000" b="0" dirty="0">
                 <a:latin typeface="Cambria"/>
               </a:rPr>
-              <a:t>Params — shape-scale: k&gt;0, θ&gt;0; shape-rate: α&gt;0, β&gt;0 (std in R)</a:t>
-            </a:r>
-          </a:p>
-          <a:p>
-            <a:r>
-              <a:rPr sz="1200" b="0">
+              <a:t>Params — shape-scale: k&gt;0, </a:t>
+            </a:r>
+            <a:r>
+              <a:rPr sz="2000" b="0" dirty="0" err="1">
+                <a:latin typeface="Cambria"/>
+              </a:rPr>
+              <a:t>θ</a:t>
+            </a:r>
+            <a:r>
+              <a:rPr sz="2000" b="0" dirty="0">
+                <a:latin typeface="Cambria"/>
+              </a:rPr>
+              <a:t>&gt;0; shape-rate: α&gt;0, β&gt;0 (std in R)</a:t>
+            </a:r>
+          </a:p>
+          <a:p>
+            <a:r>
+              <a:rPr sz="2000" b="0" dirty="0">
                 <a:latin typeface="Cambria"/>
               </a:rPr>
               <a:t>Support:  x ∈ (0, ∞)</a:t>
             </a:r>
-          </a:p>
-          <a:p>
-            <a:r>
-              <a:rPr sz="1200" b="0">
+            <a:endParaRPr lang="en-US" sz="2000" b="0" dirty="0">
+              <a:latin typeface="Cambria"/>
+            </a:endParaRPr>
+          </a:p>
+          <a:p>
+            <a:endParaRPr sz="2000" b="0" dirty="0">
+              <a:latin typeface="Cambria"/>
+            </a:endParaRPr>
+          </a:p>
+          <a:p>
+            <a:r>
+              <a:rPr sz="2000" b="0" dirty="0">
                 <a:latin typeface="Cambria"/>
               </a:rPr>
-              <a:t>PDF (shape-scale):  f(x) = 1/(Γ(k) θ</a:t>
-            </a:r>
-            <a:r>
-              <a:rPr sz="1200" b="0" baseline="30000">
+              <a:t>PDF (shape-scale):  f(x) = 1/(</a:t>
+            </a:r>
+            <a:r>
+              <a:rPr sz="2000" b="0" dirty="0" err="1">
+                <a:latin typeface="Cambria"/>
+              </a:rPr>
+              <a:t>Γ</a:t>
+            </a:r>
+            <a:r>
+              <a:rPr sz="2000" b="0" dirty="0">
+                <a:latin typeface="Cambria"/>
+              </a:rPr>
+              <a:t>(k) </a:t>
+            </a:r>
+            <a:r>
+              <a:rPr sz="2000" b="0" dirty="0" err="1">
+                <a:latin typeface="Cambria"/>
+              </a:rPr>
+              <a:t>θ</a:t>
+            </a:r>
+            <a:r>
+              <a:rPr sz="2000" b="0" baseline="30000" dirty="0" err="1">
                 <a:latin typeface="Cambria"/>
               </a:rPr>
               <a:t>k</a:t>
             </a:r>
             <a:r>
-              <a:rPr sz="1200" b="0">
+              <a:rPr sz="2000" b="0" dirty="0">
                 <a:latin typeface="Cambria"/>
               </a:rPr>
               <a:t>) · x</a:t>
             </a:r>
             <a:r>
-              <a:rPr sz="1200" b="0" baseline="30000">
+              <a:rPr sz="2000" b="0" baseline="30000" dirty="0">
                 <a:latin typeface="Cambria"/>
               </a:rPr>
               <a:t>k−1</a:t>
             </a:r>
             <a:r>
-              <a:rPr sz="1200" b="0">
+              <a:rPr sz="2000" b="0" dirty="0">
                 <a:latin typeface="Cambria"/>
               </a:rPr>
               <a:t> · e</a:t>
             </a:r>
             <a:r>
-              <a:rPr sz="1200" b="0" baseline="30000">
+              <a:rPr sz="2000" b="0" baseline="30000" dirty="0">
                 <a:latin typeface="Cambria"/>
               </a:rPr>
-              <a:t>−x/θ</a:t>
-            </a:r>
-          </a:p>
-          <a:p>
-            <a:r>
-              <a:rPr sz="1200" b="0">
+              <a:t>−x/</a:t>
+            </a:r>
+            <a:r>
+              <a:rPr sz="2000" b="0" baseline="30000" dirty="0" err="1">
+                <a:latin typeface="Cambria"/>
+              </a:rPr>
+              <a:t>θ</a:t>
+            </a:r>
+            <a:endParaRPr sz="2000" b="0" baseline="30000" dirty="0">
+              <a:latin typeface="Cambria"/>
+            </a:endParaRPr>
+          </a:p>
+          <a:p>
+            <a:r>
+              <a:rPr sz="2000" b="0" dirty="0">
                 <a:latin typeface="Cambria"/>
               </a:rPr>
               <a:t>PDF (shape-rate):  f(x) = β</a:t>
             </a:r>
             <a:r>
-              <a:rPr sz="1200" b="0" baseline="30000">
+              <a:rPr sz="2000" b="0" baseline="30000" dirty="0">
                 <a:latin typeface="Cambria"/>
               </a:rPr>
               <a:t>α</a:t>
             </a:r>
             <a:r>
-              <a:rPr sz="1200" b="0">
+              <a:rPr sz="2000" b="0" dirty="0">
                 <a:latin typeface="Cambria"/>
               </a:rPr>
-              <a:t>/Γ(α) · x</a:t>
-            </a:r>
-            <a:r>
-              <a:rPr sz="1200" b="0" baseline="30000">
+              <a:t>/</a:t>
+            </a:r>
+            <a:r>
+              <a:rPr sz="2000" b="0" dirty="0" err="1">
+                <a:latin typeface="Cambria"/>
+              </a:rPr>
+              <a:t>Γ</a:t>
+            </a:r>
+            <a:r>
+              <a:rPr sz="2000" b="0" dirty="0">
+                <a:latin typeface="Cambria"/>
+              </a:rPr>
+              <a:t>(α) · x</a:t>
+            </a:r>
+            <a:r>
+              <a:rPr sz="2000" b="0" baseline="30000" dirty="0">
                 <a:latin typeface="Cambria"/>
               </a:rPr>
               <a:t>α−1</a:t>
             </a:r>
             <a:r>
-              <a:rPr sz="1200" b="0">
+              <a:rPr sz="2000" b="0" dirty="0">
                 <a:latin typeface="Cambria"/>
               </a:rPr>
               <a:t> · e</a:t>
             </a:r>
             <a:r>
-              <a:rPr sz="1200" b="0" baseline="30000">
+              <a:rPr sz="2000" b="0" baseline="30000" dirty="0">
                 <a:latin typeface="Cambria"/>
               </a:rPr>
               <a:t>−βx</a:t>
@@ -21435,8 +20926,8 @@
         </p:nvSpPr>
         <p:spPr>
           <a:xfrm>
-            <a:off x="6477000" y="4035425"/>
-            <a:ext cx="5486400" cy="559454"/>
+            <a:off x="6488114" y="4397973"/>
+            <a:ext cx="5475286" cy="615553"/>
           </a:xfrm>
           <a:prstGeom prst="rect">
             <a:avLst/>
@@ -21444,37 +20935,48 @@
           <a:noFill/>
         </p:spPr>
         <p:txBody>
-          <a:bodyPr wrap="square" anchor="ctr" lIns="0" rIns="0" tIns="0" bIns="0">
+          <a:bodyPr wrap="square" lIns="0" tIns="0" rIns="0" bIns="0" anchor="ctr">
             <a:spAutoFit/>
           </a:bodyPr>
           <a:lstStyle/>
           <a:p>
             <a:r>
-              <a:rPr sz="1300" b="0">
+              <a:rPr sz="2000" b="0" dirty="0">
                 <a:latin typeface="Cambria"/>
               </a:rPr>
               <a:t>Var(X) = kθ</a:t>
             </a:r>
             <a:r>
-              <a:rPr sz="1300" b="0" baseline="30000">
+              <a:rPr sz="2000" b="0" baseline="30000" dirty="0">
                 <a:latin typeface="Cambria"/>
               </a:rPr>
               <a:t>2</a:t>
             </a:r>
             <a:r>
-              <a:rPr sz="1300" b="0">
+              <a:rPr sz="2000" b="0" dirty="0">
                 <a:latin typeface="Cambria"/>
               </a:rPr>
-              <a:t>  (shape-scale)  ;  Var(X) = α/β</a:t>
-            </a:r>
-            <a:r>
-              <a:rPr sz="1300" b="0" baseline="30000">
+              <a:t>  (shape-scale)</a:t>
+            </a:r>
+            <a:endParaRPr lang="en-US" sz="2000" b="0" dirty="0">
+              <a:latin typeface="Cambria"/>
+            </a:endParaRPr>
+          </a:p>
+          <a:p>
+            <a:r>
+              <a:rPr sz="2000" b="0" dirty="0">
+                <a:latin typeface="Cambria"/>
+              </a:rPr>
+              <a:t>Var(X) = α/β</a:t>
+            </a:r>
+            <a:r>
+              <a:rPr sz="2000" b="0" baseline="30000" dirty="0">
                 <a:latin typeface="Cambria"/>
               </a:rPr>
               <a:t>2</a:t>
             </a:r>
             <a:r>
-              <a:rPr sz="1300" b="0">
+              <a:rPr sz="2000" b="0" dirty="0">
                 <a:latin typeface="Cambria"/>
               </a:rPr>
               <a:t>  (shape-rate)</a:t>
@@ -21813,7 +21315,7 @@
         </p:blipFill>
         <p:spPr bwMode="auto">
           <a:xfrm>
-            <a:off x="1043528" y="1061244"/>
+            <a:off x="873405" y="1061244"/>
             <a:ext cx="5522372" cy="4419359"/>
           </a:xfrm>
           <a:prstGeom prst="rect">
@@ -21915,7 +21417,7 @@
         </p:nvSpPr>
         <p:spPr>
           <a:xfrm>
-            <a:off x="7027864" y="4313517"/>
+            <a:off x="7400004" y="4311674"/>
             <a:ext cx="4280838" cy="876220"/>
           </a:xfrm>
           <a:prstGeom prst="rect">
@@ -21924,13 +21426,13 @@
           <a:noFill/>
         </p:spPr>
         <p:txBody>
-          <a:bodyPr wrap="square" anchor="ctr" lIns="0" rIns="0" tIns="0" bIns="0">
+          <a:bodyPr wrap="square" lIns="0" tIns="0" rIns="0" bIns="0" anchor="ctr">
             <a:spAutoFit/>
           </a:bodyPr>
           <a:lstStyle/>
           <a:p>
             <a:r>
-              <a:rPr sz="2600" b="0">
+              <a:rPr sz="2600" b="0" dirty="0">
                 <a:latin typeface="Cambria"/>
               </a:rPr>
               <a:t>E[X] = α / (α + β)</a:t>
@@ -21946,8 +21448,8 @@
         </p:nvSpPr>
         <p:spPr>
           <a:xfrm>
-            <a:off x="7027864" y="1200945"/>
-            <a:ext cx="4280838" cy="2837519"/>
+            <a:off x="6626973" y="1670106"/>
+            <a:ext cx="5826899" cy="2154436"/>
           </a:xfrm>
           <a:prstGeom prst="rect">
             <a:avLst/>
@@ -21955,13 +21457,13 @@
           <a:noFill/>
         </p:spPr>
         <p:txBody>
-          <a:bodyPr wrap="square" anchor="ctr" lIns="0" rIns="0" tIns="0" bIns="0">
+          <a:bodyPr wrap="square" lIns="0" tIns="0" rIns="0" bIns="0" anchor="ctr">
             <a:spAutoFit/>
           </a:bodyPr>
           <a:lstStyle/>
           <a:p>
             <a:r>
-              <a:rPr sz="1200" b="0">
+              <a:rPr sz="2000" b="0" dirty="0">
                 <a:latin typeface="Cambria"/>
               </a:rPr>
               <a:t>Notation:  Beta(α, β)</a:t>
@@ -21969,7 +21471,7 @@
           </a:p>
           <a:p>
             <a:r>
-              <a:rPr sz="1200" b="0">
+              <a:rPr sz="2000" b="0" dirty="0">
                 <a:latin typeface="Cambria"/>
               </a:rPr>
               <a:t>Parameters:  α &gt; 0 shape (real),  β &gt; 0 shape (real)</a:t>
@@ -21977,50 +21479,96 @@
           </a:p>
           <a:p>
             <a:r>
-              <a:rPr sz="1200" b="0">
+              <a:rPr sz="2000" b="0" dirty="0">
                 <a:latin typeface="Cambria"/>
               </a:rPr>
               <a:t>Support:  x ∈ [0, 1]  or  x ∈ (0, 1)</a:t>
             </a:r>
           </a:p>
           <a:p>
-            <a:r>
-              <a:rPr sz="1200" b="0">
+            <a:endParaRPr lang="en-US" sz="2000" b="0" dirty="0">
+              <a:latin typeface="Cambria"/>
+            </a:endParaRPr>
+          </a:p>
+          <a:p>
+            <a:r>
+              <a:rPr sz="2000" b="0" dirty="0">
                 <a:latin typeface="Cambria"/>
               </a:rPr>
               <a:t>PDF:  f(x) = x</a:t>
             </a:r>
             <a:r>
-              <a:rPr sz="1200" b="0" baseline="30000">
+              <a:rPr sz="2000" b="0" baseline="30000" dirty="0">
                 <a:latin typeface="Cambria"/>
               </a:rPr>
               <a:t>α−1</a:t>
             </a:r>
             <a:r>
-              <a:rPr sz="1200" b="0">
+              <a:rPr sz="2000" b="0" dirty="0">
                 <a:latin typeface="Cambria"/>
               </a:rPr>
               <a:t> (1−x)</a:t>
             </a:r>
             <a:r>
-              <a:rPr sz="1200" b="0" baseline="30000">
+              <a:rPr sz="2000" b="0" baseline="30000" dirty="0">
                 <a:latin typeface="Cambria"/>
               </a:rPr>
               <a:t>β−1</a:t>
             </a:r>
             <a:r>
-              <a:rPr sz="1200" b="0">
+              <a:rPr sz="2000" b="0" dirty="0">
                 <a:latin typeface="Cambria"/>
               </a:rPr>
               <a:t> / B(α, β)</a:t>
             </a:r>
           </a:p>
           <a:p>
-            <a:r>
-              <a:rPr sz="1200" b="0">
+            <a:endParaRPr lang="en-US" sz="2000" b="0" dirty="0">
+              <a:latin typeface="Cambria"/>
+            </a:endParaRPr>
+          </a:p>
+          <a:p>
+            <a:r>
+              <a:rPr sz="2000" b="0" dirty="0">
                 <a:latin typeface="Cambria"/>
               </a:rPr>
-              <a:t>where B(α, β) = Γ(α) Γ(β) / Γ(α + β)</a:t>
+              <a:t>where B(α, β) = </a:t>
+            </a:r>
+            <a:r>
+              <a:rPr sz="2000" b="0" dirty="0" err="1">
+                <a:latin typeface="Cambria"/>
+              </a:rPr>
+              <a:t>Γ</a:t>
+            </a:r>
+            <a:r>
+              <a:rPr sz="2000" b="0" dirty="0">
+                <a:latin typeface="Cambria"/>
+              </a:rPr>
+              <a:t>(α) </a:t>
+            </a:r>
+            <a:r>
+              <a:rPr sz="2000" b="0" dirty="0" err="1">
+                <a:latin typeface="Cambria"/>
+              </a:rPr>
+              <a:t>Γ</a:t>
+            </a:r>
+            <a:r>
+              <a:rPr sz="2000" b="0" dirty="0">
+                <a:latin typeface="Cambria"/>
+              </a:rPr>
+              <a:t>(β) / </a:t>
+            </a:r>
+            <a:r>
+              <a:rPr sz="2000" b="0" dirty="0" err="1">
+                <a:latin typeface="Cambria"/>
+              </a:rPr>
+              <a:t>Γ</a:t>
+            </a:r>
+            <a:r>
+              <a:rPr sz="2000" b="0" dirty="0">
+                <a:latin typeface="Cambria"/>
+              </a:rPr>
+              <a:t>(α + β)</a:t>
             </a:r>
           </a:p>
         </p:txBody>
@@ -22132,8 +21680,8 @@
         </p:nvSpPr>
         <p:spPr>
           <a:xfrm>
-            <a:off x="6972300" y="1570419"/>
-            <a:ext cx="4787900" cy="4102360"/>
+            <a:off x="6972300" y="2236604"/>
+            <a:ext cx="4787900" cy="2769989"/>
           </a:xfrm>
           <a:prstGeom prst="rect">
             <a:avLst/>
@@ -22141,21 +21689,33 @@
           <a:noFill/>
         </p:spPr>
         <p:txBody>
-          <a:bodyPr wrap="square" anchor="ctr" lIns="0" rIns="0" tIns="0" bIns="0">
+          <a:bodyPr wrap="square" lIns="0" tIns="0" rIns="0" bIns="0" anchor="ctr">
             <a:spAutoFit/>
           </a:bodyPr>
           <a:lstStyle/>
           <a:p>
             <a:r>
-              <a:rPr sz="1500" b="0">
+              <a:rPr sz="2000" b="0" dirty="0">
                 <a:latin typeface="Cambria"/>
               </a:rPr>
-              <a:t>Parameters:  λ &gt; 0, rate (or inverse scale)</a:t>
-            </a:r>
-          </a:p>
-          <a:p>
-            <a:r>
-              <a:rPr sz="1500" b="0">
+              <a:t>Parameters:  </a:t>
+            </a:r>
+            <a:r>
+              <a:rPr sz="2000" b="0" dirty="0" err="1">
+                <a:latin typeface="Cambria"/>
+              </a:rPr>
+              <a:t>λ</a:t>
+            </a:r>
+            <a:r>
+              <a:rPr sz="2000" b="0" dirty="0">
+                <a:latin typeface="Cambria"/>
+              </a:rPr>
+              <a:t> &gt; 0, rate (or inverse scale)</a:t>
+            </a:r>
+          </a:p>
+          <a:p>
+            <a:r>
+              <a:rPr sz="2000" b="0" dirty="0">
                 <a:latin typeface="Cambria"/>
               </a:rPr>
               <a:t>Support:  x ∈ [0, ∞)</a:t>
@@ -22163,59 +21723,116 @@
           </a:p>
           <a:p>
             <a:r>
-              <a:rPr sz="1500" b="0">
+              <a:rPr sz="2000" b="0" dirty="0">
                 <a:latin typeface="Cambria"/>
               </a:rPr>
-              <a:t>PDF:  f(x) = λ e</a:t>
-            </a:r>
-            <a:r>
-              <a:rPr sz="1500" b="0" baseline="30000">
+              <a:t>PDF:  f(x) = </a:t>
+            </a:r>
+            <a:r>
+              <a:rPr sz="2000" b="0" dirty="0" err="1">
                 <a:latin typeface="Cambria"/>
               </a:rPr>
-              <a:t>−λx</a:t>
-            </a:r>
-          </a:p>
-          <a:p>
-            <a:r>
-              <a:rPr sz="1500" b="0">
+              <a:t>λ</a:t>
+            </a:r>
+            <a:r>
+              <a:rPr sz="2000" b="0" dirty="0">
+                <a:latin typeface="Cambria"/>
+              </a:rPr>
+              <a:t> e</a:t>
+            </a:r>
+            <a:r>
+              <a:rPr sz="2000" b="0" baseline="30000" dirty="0">
+                <a:latin typeface="Cambria"/>
+              </a:rPr>
+              <a:t>−</a:t>
+            </a:r>
+            <a:r>
+              <a:rPr sz="2000" b="0" baseline="30000" dirty="0" err="1">
+                <a:latin typeface="Cambria"/>
+              </a:rPr>
+              <a:t>λx</a:t>
+            </a:r>
+            <a:endParaRPr sz="2000" b="0" baseline="30000" dirty="0">
+              <a:latin typeface="Cambria"/>
+            </a:endParaRPr>
+          </a:p>
+          <a:p>
+            <a:r>
+              <a:rPr sz="2000" b="0" dirty="0">
                 <a:latin typeface="Cambria"/>
               </a:rPr>
               <a:t>CDF:  F(x) = 1 − e</a:t>
             </a:r>
             <a:r>
-              <a:rPr sz="1500" b="0" baseline="30000">
+              <a:rPr sz="2000" b="0" baseline="30000" dirty="0">
                 <a:latin typeface="Cambria"/>
               </a:rPr>
-              <a:t>−λx</a:t>
-            </a:r>
-          </a:p>
-          <a:p>
-            <a:r>
-              <a:rPr sz="1500" b="0">
+              <a:t>−</a:t>
+            </a:r>
+            <a:r>
+              <a:rPr sz="2000" b="0" baseline="30000" dirty="0" err="1">
                 <a:latin typeface="Cambria"/>
               </a:rPr>
-              <a:t>Quantile:  −ln(1−p) / λ</a:t>
-            </a:r>
-          </a:p>
-          <a:p>
-            <a:r>
-              <a:rPr sz="1500" b="0">
+              <a:t>λx</a:t>
+            </a:r>
+            <a:endParaRPr sz="2000" b="0" baseline="30000" dirty="0">
+              <a:latin typeface="Cambria"/>
+            </a:endParaRPr>
+          </a:p>
+          <a:p>
+            <a:r>
+              <a:rPr sz="2000" b="0" dirty="0">
                 <a:latin typeface="Cambria"/>
               </a:rPr>
-              <a:t>Mean:  1/λ</a:t>
-            </a:r>
-          </a:p>
-          <a:p>
-            <a:r>
-              <a:rPr sz="1500" b="0">
+              <a:t>Quantile:  −ln(1−p) / </a:t>
+            </a:r>
+            <a:r>
+              <a:rPr sz="2000" b="0" dirty="0" err="1">
                 <a:latin typeface="Cambria"/>
               </a:rPr>
-              <a:t>Median:  ln 2 / λ</a:t>
-            </a:r>
-          </a:p>
-          <a:p>
-            <a:r>
-              <a:rPr sz="1500" b="0">
+              <a:t>λ</a:t>
+            </a:r>
+            <a:endParaRPr sz="2000" b="0" dirty="0">
+              <a:latin typeface="Cambria"/>
+            </a:endParaRPr>
+          </a:p>
+          <a:p>
+            <a:r>
+              <a:rPr sz="2000" b="0" dirty="0">
+                <a:latin typeface="Cambria"/>
+              </a:rPr>
+              <a:t>Mean:  1/</a:t>
+            </a:r>
+            <a:r>
+              <a:rPr sz="2000" b="0" dirty="0" err="1">
+                <a:latin typeface="Cambria"/>
+              </a:rPr>
+              <a:t>λ</a:t>
+            </a:r>
+            <a:endParaRPr sz="2000" b="0" dirty="0">
+              <a:latin typeface="Cambria"/>
+            </a:endParaRPr>
+          </a:p>
+          <a:p>
+            <a:r>
+              <a:rPr sz="2000" b="0" dirty="0">
+                <a:latin typeface="Cambria"/>
+              </a:rPr>
+              <a:t>Median:  ln 2 / </a:t>
+            </a:r>
+            <a:r>
+              <a:rPr sz="2000" b="0" dirty="0" err="1">
+                <a:latin typeface="Cambria"/>
+              </a:rPr>
+              <a:t>λ</a:t>
+            </a:r>
+            <a:endParaRPr sz="2000" b="0" dirty="0">
+              <a:latin typeface="Cambria"/>
+            </a:endParaRPr>
+          </a:p>
+          <a:p>
+            <a:r>
+              <a:rPr sz="2000" b="0" dirty="0">
                 <a:latin typeface="Cambria"/>
               </a:rPr>
               <a:t>Mode:  0</a:t>
@@ -22223,13 +21840,13 @@
           </a:p>
           <a:p>
             <a:r>
-              <a:rPr sz="1500" b="0">
+              <a:rPr sz="2000" b="0" dirty="0">
                 <a:latin typeface="Cambria"/>
               </a:rPr>
               <a:t>Variance:  1/λ</a:t>
             </a:r>
             <a:r>
-              <a:rPr sz="1500" b="0" baseline="30000">
+              <a:rPr sz="2000" b="0" baseline="30000" dirty="0">
                 <a:latin typeface="Cambria"/>
               </a:rPr>
               <a:t>2</a:t>
@@ -22349,11 +21966,7 @@
             </a:pPr>
             <a:r>
               <a:rPr lang="en-US" altLang="en-US" sz="2600" dirty="0"/>
-              <a:t>If events are occurring at random with average rate of </a:t>
-            </a:r>
-            <a:r>
-              <a:rPr lang="en-US" altLang="en-US" sz="2600" dirty="0"/>
-              <a:t>λ per interval, then the </a:t>
+              <a:t>If events are occurring at random with average rate of λ per interval, then the </a:t>
             </a:r>
             <a:r>
               <a:rPr lang="en-US" altLang="en-US" sz="2600" b="1" dirty="0">
@@ -22525,23 +22138,44 @@
           <a:noFill/>
         </p:spPr>
         <p:txBody>
-          <a:bodyPr wrap="square" anchor="ctr" lIns="0" rIns="0" tIns="0" bIns="0">
+          <a:bodyPr wrap="square" lIns="0" tIns="0" rIns="0" bIns="0" anchor="ctr">
             <a:spAutoFit/>
           </a:bodyPr>
           <a:lstStyle/>
           <a:p>
             <a:r>
-              <a:rPr sz="2400">
+              <a:rPr sz="2400" dirty="0">
                 <a:latin typeface="Cambria"/>
               </a:rPr>
-              <a:t>f(x) = λ e</a:t>
-            </a:r>
-            <a:r>
-              <a:rPr sz="2400" baseline="30000">
+              <a:t>f(x) = </a:t>
+            </a:r>
+            <a:r>
+              <a:rPr sz="2400" dirty="0" err="1">
                 <a:latin typeface="Cambria"/>
               </a:rPr>
-              <a:t>−λx</a:t>
-            </a:r>
+              <a:t>λ</a:t>
+            </a:r>
+            <a:r>
+              <a:rPr sz="2400" dirty="0">
+                <a:latin typeface="Cambria"/>
+              </a:rPr>
+              <a:t> e</a:t>
+            </a:r>
+            <a:r>
+              <a:rPr sz="2400" baseline="30000" dirty="0">
+                <a:latin typeface="Cambria"/>
+              </a:rPr>
+              <a:t>−</a:t>
+            </a:r>
+            <a:r>
+              <a:rPr sz="2400" baseline="30000" dirty="0" err="1">
+                <a:latin typeface="Cambria"/>
+              </a:rPr>
+              <a:t>λx</a:t>
+            </a:r>
+            <a:endParaRPr sz="2400" baseline="30000" dirty="0">
+              <a:latin typeface="Cambria"/>
+            </a:endParaRPr>
           </a:p>
         </p:txBody>
       </p:sp>
@@ -23366,8 +23000,8 @@
         </p:nvSpPr>
         <p:spPr>
           <a:xfrm>
-            <a:off x="7550150" y="4497388"/>
-            <a:ext cx="1406769" cy="474662"/>
+            <a:off x="7550150" y="4550053"/>
+            <a:ext cx="1406769" cy="369332"/>
           </a:xfrm>
           <a:prstGeom prst="rect">
             <a:avLst/>
@@ -23375,13 +23009,13 @@
           <a:noFill/>
         </p:spPr>
         <p:txBody>
-          <a:bodyPr wrap="square" anchor="ctr" lIns="0" rIns="0" tIns="0" bIns="0">
+          <a:bodyPr wrap="square" lIns="0" tIns="0" rIns="0" bIns="0" anchor="ctr">
             <a:spAutoFit/>
           </a:bodyPr>
           <a:lstStyle/>
           <a:p>
             <a:r>
-              <a:rPr sz="1900" b="0">
+              <a:rPr sz="2400" b="0">
                 <a:latin typeface="Cambria"/>
               </a:rPr>
               <a:t>T ~ Exp(λ)</a:t>
@@ -23397,8 +23031,8 @@
         </p:nvSpPr>
         <p:spPr>
           <a:xfrm>
-            <a:off x="5367339" y="5791200"/>
-            <a:ext cx="1547446" cy="838200"/>
+            <a:off x="5367339" y="6025634"/>
+            <a:ext cx="1547446" cy="369332"/>
           </a:xfrm>
           <a:prstGeom prst="rect">
             <a:avLst/>
@@ -23406,17 +23040,38 @@
           <a:noFill/>
         </p:spPr>
         <p:txBody>
-          <a:bodyPr wrap="square" anchor="ctr" lIns="0" rIns="0" tIns="0" bIns="0">
+          <a:bodyPr wrap="square" lIns="0" tIns="0" rIns="0" bIns="0" anchor="ctr">
             <a:spAutoFit/>
           </a:bodyPr>
           <a:lstStyle/>
           <a:p>
             <a:r>
-              <a:rPr sz="1900" b="0">
+              <a:rPr sz="2400" b="0" dirty="0">
                 <a:latin typeface="Cambria"/>
               </a:rPr>
-              <a:t>Dˆ = λˆ / ā</a:t>
-            </a:r>
+              <a:t>D = </a:t>
+            </a:r>
+            <a:r>
+              <a:rPr sz="2400" b="0" dirty="0" err="1">
+                <a:latin typeface="Cambria"/>
+              </a:rPr>
+              <a:t>λ</a:t>
+            </a:r>
+            <a:r>
+              <a:rPr sz="2400" b="0" dirty="0">
+                <a:latin typeface="Cambria"/>
+              </a:rPr>
+              <a:t> / </a:t>
+            </a:r>
+            <a:r>
+              <a:rPr sz="2400" b="0" dirty="0" err="1">
+                <a:latin typeface="Cambria"/>
+              </a:rPr>
+              <a:t>ā</a:t>
+            </a:r>
+            <a:endParaRPr sz="2400" b="0" dirty="0">
+              <a:latin typeface="Cambria"/>
+            </a:endParaRPr>
           </a:p>
         </p:txBody>
       </p:sp>
@@ -23428,8 +23083,8 @@
         </p:nvSpPr>
         <p:spPr>
           <a:xfrm>
-            <a:off x="2667001" y="4510089"/>
-            <a:ext cx="1969476" cy="460375"/>
+            <a:off x="2667001" y="4555610"/>
+            <a:ext cx="1969476" cy="369332"/>
           </a:xfrm>
           <a:prstGeom prst="rect">
             <a:avLst/>
@@ -23437,28 +23092,40 @@
           <a:noFill/>
         </p:spPr>
         <p:txBody>
-          <a:bodyPr wrap="square" anchor="ctr" lIns="0" rIns="0" tIns="0" bIns="0">
+          <a:bodyPr wrap="square" lIns="0" tIns="0" rIns="0" bIns="0" anchor="ctr">
             <a:spAutoFit/>
           </a:bodyPr>
           <a:lstStyle/>
           <a:p>
             <a:r>
-              <a:rPr sz="1900" b="0">
+              <a:rPr sz="2400" b="0" dirty="0" err="1">
                 <a:latin typeface="Cambria"/>
               </a:rPr>
               <a:t>N</a:t>
             </a:r>
             <a:r>
-              <a:rPr sz="1900" b="0" baseline="-25000">
+              <a:rPr sz="2400" b="0" baseline="-25000" dirty="0" err="1">
                 <a:latin typeface="Cambria"/>
               </a:rPr>
               <a:t>ijk</a:t>
             </a:r>
             <a:r>
-              <a:rPr sz="1900" b="0">
+              <a:rPr sz="2400" b="0" dirty="0">
                 <a:latin typeface="Cambria"/>
               </a:rPr>
-              <a:t> ~ Pois(λ)</a:t>
+              <a:t> ~ Pois(</a:t>
+            </a:r>
+            <a:r>
+              <a:rPr sz="2400" b="0" dirty="0" err="1">
+                <a:latin typeface="Cambria"/>
+              </a:rPr>
+              <a:t>λ</a:t>
+            </a:r>
+            <a:r>
+              <a:rPr sz="2400" b="0" dirty="0">
+                <a:latin typeface="Cambria"/>
+              </a:rPr>
+              <a:t>)</a:t>
             </a:r>
           </a:p>
         </p:txBody>
@@ -23473,257 +23140,6 @@
   <p:clrMapOvr>
     <a:masterClrMapping/>
   </p:clrMapOvr>
-  <p:timing>
-    <p:tnLst>
-      <p:par>
-        <p:cTn id="1" dur="indefinite" restart="never" nodeType="tmRoot">
-          <p:childTnLst>
-            <p:seq concurrent="1" nextAc="seek">
-              <p:cTn id="2" dur="indefinite" nodeType="mainSeq">
-                <p:childTnLst>
-                  <p:par>
-                    <p:cTn id="3" fill="hold" nodeType="clickPar">
-                      <p:stCondLst>
-                        <p:cond delay="indefinite"/>
-                      </p:stCondLst>
-                      <p:childTnLst>
-                        <p:par>
-                          <p:cTn id="4" fill="hold" nodeType="withGroup">
-                            <p:stCondLst>
-                              <p:cond delay="0"/>
-                            </p:stCondLst>
-                            <p:childTnLst>
-                              <p:par>
-                                <p:cTn id="5" presetID="1" presetClass="entr" presetSubtype="0" fill="hold" grpId="0" nodeType="clickEffect">
-                                  <p:stCondLst>
-                                    <p:cond delay="0"/>
-                                  </p:stCondLst>
-                                  <p:childTnLst>
-                                    <p:set>
-                                      <p:cBhvr>
-                                        <p:cTn id="6" dur="1" fill="hold">
-                                          <p:stCondLst>
-                                            <p:cond delay="0"/>
-                                          </p:stCondLst>
-                                        </p:cTn>
-                                        <p:tgtEl>
-                                          <p:spTgt spid="10"/>
-                                        </p:tgtEl>
-                                        <p:attrNameLst>
-                                          <p:attrName>style.visibility</p:attrName>
-                                        </p:attrNameLst>
-                                      </p:cBhvr>
-                                      <p:to>
-                                        <p:strVal val="visible"/>
-                                      </p:to>
-                                    </p:set>
-                                  </p:childTnLst>
-                                </p:cTn>
-                              </p:par>
-                              <p:par>
-                                <p:cTn id="7" presetID="1" presetClass="entr" presetSubtype="0" fill="hold" nodeType="withEffect">
-                                  <p:stCondLst>
-                                    <p:cond delay="0"/>
-                                  </p:stCondLst>
-                                  <p:childTnLst>
-                                    <p:set>
-                                      <p:cBhvr>
-                                        <p:cTn id="8" dur="1" fill="hold">
-                                          <p:stCondLst>
-                                            <p:cond delay="0"/>
-                                          </p:stCondLst>
-                                        </p:cTn>
-                                        <p:tgtEl>
-                                          <p:spTgt spid="9"/>
-                                        </p:tgtEl>
-                                        <p:attrNameLst>
-                                          <p:attrName>style.visibility</p:attrName>
-                                        </p:attrNameLst>
-                                      </p:cBhvr>
-                                      <p:to>
-                                        <p:strVal val="visible"/>
-                                      </p:to>
-                                    </p:set>
-                                  </p:childTnLst>
-                                </p:cTn>
-                              </p:par>
-                            </p:childTnLst>
-                          </p:cTn>
-                        </p:par>
-                      </p:childTnLst>
-                    </p:cTn>
-                  </p:par>
-                  <p:par>
-                    <p:cTn id="9" fill="hold" nodeType="clickPar">
-                      <p:stCondLst>
-                        <p:cond delay="indefinite"/>
-                      </p:stCondLst>
-                      <p:childTnLst>
-                        <p:par>
-                          <p:cTn id="10" fill="hold" nodeType="withGroup">
-                            <p:stCondLst>
-                              <p:cond delay="0"/>
-                            </p:stCondLst>
-                            <p:childTnLst>
-                              <p:par>
-                                <p:cTn id="11" presetID="1" presetClass="entr" presetSubtype="0" fill="hold" grpId="0" nodeType="clickEffect">
-                                  <p:stCondLst>
-                                    <p:cond delay="0"/>
-                                  </p:stCondLst>
-                                  <p:childTnLst>
-                                    <p:set>
-                                      <p:cBhvr>
-                                        <p:cTn id="12" dur="1" fill="hold">
-                                          <p:stCondLst>
-                                            <p:cond delay="0"/>
-                                          </p:stCondLst>
-                                        </p:cTn>
-                                        <p:tgtEl>
-                                          <p:spTgt spid="13"/>
-                                        </p:tgtEl>
-                                        <p:attrNameLst>
-                                          <p:attrName>style.visibility</p:attrName>
-                                        </p:attrNameLst>
-                                      </p:cBhvr>
-                                      <p:to>
-                                        <p:strVal val="visible"/>
-                                      </p:to>
-                                    </p:set>
-                                  </p:childTnLst>
-                                </p:cTn>
-                              </p:par>
-                              <p:par>
-                                <p:cTn id="13" presetID="1" presetClass="entr" presetSubtype="0" fill="hold" nodeType="withEffect">
-                                  <p:stCondLst>
-                                    <p:cond delay="0"/>
-                                  </p:stCondLst>
-                                  <p:childTnLst>
-                                    <p:set>
-                                      <p:cBhvr>
-                                        <p:cTn id="14" dur="1" fill="hold">
-                                          <p:stCondLst>
-                                            <p:cond delay="0"/>
-                                          </p:stCondLst>
-                                        </p:cTn>
-                                        <p:tgtEl>
-                                          <p:spTgt spid="6"/>
-                                        </p:tgtEl>
-                                        <p:attrNameLst>
-                                          <p:attrName>style.visibility</p:attrName>
-                                        </p:attrNameLst>
-                                      </p:cBhvr>
-                                      <p:to>
-                                        <p:strVal val="visible"/>
-                                      </p:to>
-                                    </p:set>
-                                  </p:childTnLst>
-                                </p:cTn>
-                              </p:par>
-                            </p:childTnLst>
-                          </p:cTn>
-                        </p:par>
-                      </p:childTnLst>
-                    </p:cTn>
-                  </p:par>
-                  <p:par>
-                    <p:cTn id="15" fill="hold" nodeType="clickPar">
-                      <p:stCondLst>
-                        <p:cond delay="indefinite"/>
-                      </p:stCondLst>
-                      <p:childTnLst>
-                        <p:par>
-                          <p:cTn id="16" fill="hold" nodeType="withGroup">
-                            <p:stCondLst>
-                              <p:cond delay="0"/>
-                            </p:stCondLst>
-                            <p:childTnLst>
-                              <p:par>
-                                <p:cTn id="17" presetID="1" presetClass="entr" presetSubtype="0" fill="hold" grpId="0" nodeType="clickEffect">
-                                  <p:stCondLst>
-                                    <p:cond delay="0"/>
-                                  </p:stCondLst>
-                                  <p:childTnLst>
-                                    <p:set>
-                                      <p:cBhvr>
-                                        <p:cTn id="18" dur="1" fill="hold">
-                                          <p:stCondLst>
-                                            <p:cond delay="0"/>
-                                          </p:stCondLst>
-                                        </p:cTn>
-                                        <p:tgtEl>
-                                          <p:spTgt spid="14"/>
-                                        </p:tgtEl>
-                                        <p:attrNameLst>
-                                          <p:attrName>style.visibility</p:attrName>
-                                        </p:attrNameLst>
-                                      </p:cBhvr>
-                                      <p:to>
-                                        <p:strVal val="visible"/>
-                                      </p:to>
-                                    </p:set>
-                                  </p:childTnLst>
-                                </p:cTn>
-                              </p:par>
-                              <p:par>
-                                <p:cTn id="19" presetID="1" presetClass="entr" presetSubtype="0" fill="hold" nodeType="withEffect">
-                                  <p:stCondLst>
-                                    <p:cond delay="0"/>
-                                  </p:stCondLst>
-                                  <p:childTnLst>
-                                    <p:set>
-                                      <p:cBhvr>
-                                        <p:cTn id="20" dur="1" fill="hold">
-                                          <p:stCondLst>
-                                            <p:cond delay="0"/>
-                                          </p:stCondLst>
-                                        </p:cTn>
-                                        <p:tgtEl>
-                                          <p:spTgt spid="7"/>
-                                        </p:tgtEl>
-                                        <p:attrNameLst>
-                                          <p:attrName>style.visibility</p:attrName>
-                                        </p:attrNameLst>
-                                      </p:cBhvr>
-                                      <p:to>
-                                        <p:strVal val="visible"/>
-                                      </p:to>
-                                    </p:set>
-                                  </p:childTnLst>
-                                </p:cTn>
-                              </p:par>
-                            </p:childTnLst>
-                          </p:cTn>
-                        </p:par>
-                      </p:childTnLst>
-                    </p:cTn>
-                  </p:par>
-                </p:childTnLst>
-              </p:cTn>
-              <p:prevCondLst>
-                <p:cond evt="onPrev" delay="0">
-                  <p:tgtEl>
-                    <p:sldTgt/>
-                  </p:tgtEl>
-                </p:cond>
-              </p:prevCondLst>
-              <p:nextCondLst>
-                <p:cond evt="onNext" delay="0">
-                  <p:tgtEl>
-                    <p:sldTgt/>
-                  </p:tgtEl>
-                </p:cond>
-              </p:nextCondLst>
-            </p:seq>
-          </p:childTnLst>
-        </p:cTn>
-      </p:par>
-    </p:tnLst>
-    <p:bldLst>
-      <p:bldP spid="10" grpId="0"/>
-      <p:bldP spid="13" grpId="0"/>
-      <p:bldP spid="14" grpId="0"/>
-    </p:bldLst>
-  </p:timing>
 </p:sld>
 </file>
 
@@ -24278,11 +23694,7 @@
             </a:pPr>
             <a:r>
               <a:rPr lang="en-US" altLang="en-US" dirty="0"/>
-              <a:t>P[X&gt;2] = 1-P[X</a:t>
-            </a:r>
-            <a:r>
-              <a:rPr lang="en-US" altLang="en-US" dirty="0"/>
-              <a:t>≤2]=0.0498</a:t>
+              <a:t>P[X&gt;2] = 1-P[X≤2]=0.0498</a:t>
             </a:r>
           </a:p>
           <a:p>
@@ -24555,8 +23967,8 @@
         </p:nvSpPr>
         <p:spPr>
           <a:xfrm>
-            <a:off x="5181601" y="2761264"/>
-            <a:ext cx="1571625" cy="412750"/>
+            <a:off x="5155069" y="2635419"/>
+            <a:ext cx="1571625" cy="369332"/>
           </a:xfrm>
           <a:prstGeom prst="rect">
             <a:avLst/>
@@ -24564,16 +23976,22 @@
           <a:noFill/>
         </p:spPr>
         <p:txBody>
-          <a:bodyPr wrap="square" anchor="ctr" lIns="0" rIns="0" tIns="0" bIns="0">
+          <a:bodyPr wrap="square" lIns="0" tIns="0" rIns="0" bIns="0" anchor="ctr">
             <a:spAutoFit/>
           </a:bodyPr>
           <a:lstStyle/>
           <a:p>
             <a:r>
-              <a:rPr sz="2000">
+              <a:rPr lang="en-US" sz="2400" dirty="0">
                 <a:latin typeface="Cambria"/>
               </a:rPr>
-              <a:t>Z ~ U(a, b)</a:t>
+              <a:t>X</a:t>
+            </a:r>
+            <a:r>
+              <a:rPr sz="2400" dirty="0">
+                <a:latin typeface="Cambria"/>
+              </a:rPr>
+              <a:t> ~ U(a, b)</a:t>
             </a:r>
           </a:p>
         </p:txBody>
@@ -24586,8 +24004,8 @@
         </p:nvSpPr>
         <p:spPr>
           <a:xfrm>
-            <a:off x="5155069" y="4324092"/>
-            <a:ext cx="2532184" cy="787400"/>
+            <a:off x="4764027" y="4354996"/>
+            <a:ext cx="2532184" cy="369332"/>
           </a:xfrm>
           <a:prstGeom prst="rect">
             <a:avLst/>
@@ -24595,13 +24013,13 @@
           <a:noFill/>
         </p:spPr>
         <p:txBody>
-          <a:bodyPr wrap="square" anchor="ctr" lIns="0" rIns="0" tIns="0" bIns="0">
+          <a:bodyPr wrap="square" lIns="0" tIns="0" rIns="0" bIns="0" anchor="ctr">
             <a:spAutoFit/>
           </a:bodyPr>
           <a:lstStyle/>
           <a:p>
             <a:r>
-              <a:rPr sz="1900">
+              <a:rPr sz="2400" dirty="0">
                 <a:latin typeface="Cambria"/>
               </a:rPr>
               <a:t>f(x) = 1 / (b − a)</a:t>
@@ -24860,8 +24278,8 @@
         </p:nvSpPr>
         <p:spPr>
           <a:xfrm>
-            <a:off x="5494401" y="1275443"/>
-            <a:ext cx="2532184" cy="787400"/>
+            <a:off x="5340022" y="1497934"/>
+            <a:ext cx="2532184" cy="369332"/>
           </a:xfrm>
           <a:prstGeom prst="rect">
             <a:avLst/>
@@ -24869,13 +24287,13 @@
           <a:noFill/>
         </p:spPr>
         <p:txBody>
-          <a:bodyPr wrap="square" anchor="ctr" lIns="0" rIns="0" tIns="0" bIns="0">
+          <a:bodyPr wrap="square" lIns="0" tIns="0" rIns="0" bIns="0" anchor="ctr">
             <a:spAutoFit/>
           </a:bodyPr>
           <a:lstStyle/>
           <a:p>
             <a:r>
-              <a:rPr sz="1900">
+              <a:rPr sz="2400">
                 <a:latin typeface="Cambria"/>
               </a:rPr>
               <a:t>f(x) = 1 / (b − a)</a:t>

</xml_diff>